<commit_message>
Rewrite Three Questions Synthesis with ZipperGen as breakthrough — closes MPST gap
</commit_message>
<xml_diff>
--- a/Agent_Governance_Three_Questions_Synthesis.pptx
+++ b/Agent_Governance_Three_Questions_Synthesis.pptx
@@ -24,6 +24,7 @@
     <p:sldId id="272" r:id="rId18"/>
     <p:sldId id="273" r:id="rId19"/>
     <p:sldId id="274" r:id="rId20"/>
+    <p:sldId id="275" r:id="rId21"/>
   </p:sldIdLst>
   <p:sldSz cx="9144000" cy="5143500" type="screen16x9"/>
   <p:notesSz cx="6858000" cy="9144000"/>
@@ -3196,23 +3197,15 @@
           <a:lstStyle/>
           <a:p>
             <a:pPr lvl="0" indent="0" marL="0">
-              <a:spcBef>
-                <a:spcPts val="3000"/>
-              </a:spcBef>
               <a:buNone/>
             </a:pPr>
             <a:r>
               <a:rPr b="1"/>
-              <a:t>Verdict on Question 2</a:t>
-            </a:r>
-          </a:p>
-          <a:p>
-            <a:pPr lvl="0" indent="0" marL="1270000">
-              <a:buNone/>
-            </a:pPr>
-            <a:r>
-              <a:rPr sz="2000" b="1"/>
-              <a:t>Static analysis exists (SkillFortify, SkCC) but is limited to code artifacts or structured representations. There is no formal type system for natural language skill descriptions, and no MPST-style static protocol checking for multi-agent interactions. This is a research gap.</a:t>
+              <a:t>ZipperGen changes the picture:</a:t>
+            </a:r>
+            <a:r>
+              <a:rPr/>
+              <a:t> Before ZipperGen, the answer was “no formal static checking for multi-agent interactions.” Now there is a concrete implementation (ZipperGen) that provides formal global specifications + guaranteed deadlock-free local programs. The gap is no longer “does this exist?” but “how do we extend this to skill content verification and behavioral typing?”</a:t>
             </a:r>
           </a:p>
         </p:txBody>
@@ -3262,19 +3255,16 @@
             </a:pPr>
             <a:r>
               <a:rPr b="1"/>
-              <a:t>Question 3: Runtime Checking in a Deterministic Way (Not LLM-as-Judge)?</a:t>
-            </a:r>
-          </a:p>
-          <a:p>
-            <a:pPr lvl="0" indent="0" marL="0">
-              <a:spcBef>
-                <a:spcPts val="3000"/>
-              </a:spcBef>
+              <a:t>Verdict on Question 2</a:t>
+            </a:r>
+          </a:p>
+          <a:p>
+            <a:pPr lvl="0" indent="0" marL="1270000">
               <a:buNone/>
             </a:pPr>
             <a:r>
-              <a:rPr b="1"/>
-              <a:t>Short Answer: Yes — multiple deterministic runtime enforcement mechanisms exist, some formally verified.</a:t>
+              <a:rPr sz="2000" b="1"/>
+              <a:t>ZipperGen is the breakthrough paper for multi-agent static coordination. It provides formal type checking (well-typedness), deadlock-free-by-construction guarantees, and syntax-directed projection — all before any agent runs. For single-agent skills, SkillFortify and SkCC provide formal static analysis. The remaining gap is behavioral typing of message content and automatic skill composition verification.</a:t>
             </a:r>
           </a:p>
         </p:txBody>
@@ -3324,7 +3314,7 @@
             </a:pPr>
             <a:r>
               <a:rPr b="1"/>
-              <a:t>Papers With Deterministic Runtime Enforcement</a:t>
+              <a:t>Question 3: Runtime Checking in a Deterministic Way (Not LLM-as-Judge)?</a:t>
             </a:r>
           </a:p>
           <a:p>
@@ -3336,554 +3326,7 @@
             </a:pPr>
             <a:r>
               <a:rPr b="1"/>
-              <a:t>1. ACP — Admission Control Protocol (arXiv:2603.18829, Layer 1) — Fastest + Formally Verified</a:t>
-            </a:r>
-          </a:p>
-          <a:p>
-            <a:pPr lvl="0"/>
-            <a:r>
-              <a:rPr b="1"/>
-              <a:t>Deterministic:</a:t>
-            </a:r>
-            <a:r>
-              <a:rPr/>
-              <a:t> Yes — risk scoring is deterministic, not LLM-based</a:t>
-            </a:r>
-          </a:p>
-          <a:p>
-            <a:pPr lvl="0"/>
-            <a:r>
-              <a:rPr b="1"/>
-              <a:t>Mechanism:</a:t>
-            </a:r>
-            <a:r>
-              <a:rPr/>
-              <a:t> Temporal admission control with static risk scoring + stateful signals (anomaly accumulation, cooldown) through LedgerQuerier</a:t>
-            </a:r>
-          </a:p>
-          <a:p>
-            <a:pPr lvl="0"/>
-            <a:r>
-              <a:rPr b="1"/>
-              <a:t>Performance:</a:t>
-            </a:r>
-            <a:r>
-              <a:rPr/>
-              <a:t> 739-832 ns decision latency; 1,720,000 req/s throughput</a:t>
-            </a:r>
-          </a:p>
-          <a:p>
-            <a:pPr lvl="0"/>
-            <a:r>
-              <a:rPr b="1"/>
-              <a:t>Verification:</a:t>
-            </a:r>
-            <a:r>
-              <a:rPr/>
-              <a:t> TLA+ verified across 4,294,930,695 states, 11 invariants + 4 temporal properties, 0 violations</a:t>
-            </a:r>
-          </a:p>
-          <a:p>
-            <a:pPr lvl="0"/>
-            <a:r>
-              <a:rPr b="1"/>
-              <a:t>Key result:</a:t>
-            </a:r>
-            <a:r>
-              <a:rPr/>
-              <a:t> Stateless engines approve 100% of individually-valid requests in a 500-request attack chain; ACP limits autonomous execution to 0.4%</a:t>
-            </a:r>
-          </a:p>
-          <a:p>
-            <a:pPr lvl="0"/>
-            <a:r>
-              <a:rPr b="1"/>
-              <a:t>Open source:</a:t>
-            </a:r>
-            <a:r>
-              <a:rPr/>
-              <a:t> Go reference implementation (23 packages, 138 conformance tests)</a:t>
-            </a:r>
-          </a:p>
-          <a:p>
-            <a:pPr lvl="0"/>
-            <a:r>
-              <a:rPr b="1"/>
-              <a:t>Paper series:</a:t>
-            </a:r>
-            <a:r>
-              <a:rPr/>
-              <a:t> 1 of 6-paper Agent Governance Series (Marcelo Fernandez)</a:t>
-            </a:r>
-          </a:p>
-          <a:p>
-            <a:pPr lvl="0" indent="0" marL="0">
-              <a:spcBef>
-                <a:spcPts val="3000"/>
-              </a:spcBef>
-              <a:buNone/>
-            </a:pPr>
-            <a:r>
-              <a:rPr b="1"/>
-              <a:t>2. Agent Behavioral Contracts (ABC) (arXiv:2602.22302, Layer 1/2) — Most Comprehensive</a:t>
-            </a:r>
-          </a:p>
-          <a:p>
-            <a:pPr lvl="0"/>
-            <a:r>
-              <a:rPr b="1"/>
-              <a:t>Deterministic:</a:t>
-            </a:r>
-            <a:r>
-              <a:rPr/>
-              <a:t> Yes — contracts are formal, not probabilistic</a:t>
-            </a:r>
-          </a:p>
-          <a:p>
-            <a:pPr lvl="0"/>
-            <a:r>
-              <a:rPr b="1"/>
-              <a:t>Mechanism:</a:t>
-            </a:r>
-            <a:r>
-              <a:rPr/>
-              <a:t> Contract C = (P, I, G, R) — Preconditions, Invariants, Governance policies, Recovery</a:t>
-            </a:r>
-          </a:p>
-          <a:p>
-            <a:pPr lvl="0"/>
-            <a:r>
-              <a:rPr b="1"/>
-              <a:t>Runtime:</a:t>
-            </a:r>
-            <a:r>
-              <a:rPr/>
-              <a:t> AgentAssert library enforces contracts with &lt;10 ms overhead per action</a:t>
-            </a:r>
-          </a:p>
-          <a:p>
-            <a:pPr lvl="0"/>
-            <a:r>
-              <a:rPr b="1"/>
-              <a:t>Results:</a:t>
-            </a:r>
-            <a:r>
-              <a:rPr/>
-              <a:t> 88-100% hard constraint compliance; behavioral drift bounded to D* &lt; 0.27</a:t>
-            </a:r>
-          </a:p>
-          <a:p>
-            <a:pPr lvl="0"/>
-            <a:r>
-              <a:rPr b="1"/>
-              <a:t>Verification:</a:t>
-            </a:r>
-            <a:r>
-              <a:rPr/>
-              <a:t> (p, delta, k)-satisfaction for probabilistic compliance; Drift Bounds Theorem</a:t>
-            </a:r>
-          </a:p>
-          <a:p>
-            <a:pPr lvl="0"/>
-            <a:r>
-              <a:rPr b="1"/>
-              <a:t>Open source:</a:t>
-            </a:r>
-            <a:r>
-              <a:rPr/>
-              <a:t> AgentAssert runtime library (Qualixar suite)</a:t>
-            </a:r>
-          </a:p>
-          <a:p>
-            <a:pPr lvl="0"/>
-            <a:r>
-              <a:rPr b="1"/>
-              <a:t>Gap:</a:t>
-            </a:r>
-            <a:r>
-              <a:rPr/>
-              <a:t> Contracts are probabilistically satisfied, not 100% deterministic</a:t>
-            </a:r>
-          </a:p>
-          <a:p>
-            <a:pPr lvl="0" indent="0" marL="0">
-              <a:spcBef>
-                <a:spcPts val="3000"/>
-              </a:spcBef>
-              <a:buNone/>
-            </a:pPr>
-            <a:r>
-              <a:rPr b="1"/>
-              <a:t>3. Runtime Governance / Policies on Paths (arXiv:2603.16586, Layer 1) — Most Expressive</a:t>
-            </a:r>
-          </a:p>
-          <a:p>
-            <a:pPr lvl="0"/>
-            <a:r>
-              <a:rPr b="1"/>
-              <a:t>Deterministic:</a:t>
-            </a:r>
-            <a:r>
-              <a:rPr/>
-              <a:t> Yes — policies are temporal predicates, not LLM-evaluated</a:t>
-            </a:r>
-          </a:p>
-          <a:p>
-            <a:pPr lvl="0"/>
-            <a:r>
-              <a:rPr b="1"/>
-              <a:t>Mechanism:</a:t>
-            </a:r>
-            <a:r>
-              <a:rPr/>
-              <a:t> Path-based policies as functions on execution paths; policy compiler translates requirements to executable path monitors</a:t>
-            </a:r>
-          </a:p>
-          <a:p>
-            <a:pPr lvl="0"/>
-            <a:r>
-              <a:rPr b="1"/>
-              <a:t>Complexity:</a:t>
-            </a:r>
-            <a:r>
-              <a:rPr/>
-              <a:t> Polynomial-time evaluation</a:t>
-            </a:r>
-          </a:p>
-          <a:p>
-            <a:pPr lvl="0"/>
-            <a:r>
-              <a:rPr b="1"/>
-              <a:t>Expressiveness:</a:t>
-            </a:r>
-            <a:r>
-              <a:rPr/>
-              <a:t> Can encode separation of duties, data minimization, audit trails</a:t>
-            </a:r>
-          </a:p>
-          <a:p>
-            <a:pPr lvl="0"/>
-            <a:r>
-              <a:rPr b="1"/>
-              <a:t>Gap:</a:t>
-            </a:r>
-            <a:r>
-              <a:rPr/>
-              <a:t> Proposed framework, not yet evaluated at scale</a:t>
-            </a:r>
-          </a:p>
-          <a:p>
-            <a:pPr lvl="0" indent="0" marL="0">
-              <a:spcBef>
-                <a:spcPts val="3000"/>
-              </a:spcBef>
-              <a:buNone/>
-            </a:pPr>
-            <a:r>
-              <a:rPr b="1"/>
-              <a:t>4. AgentVerify (preprints.org, 2026, Layer 1/2)</a:t>
-            </a:r>
-          </a:p>
-          <a:p>
-            <a:pPr lvl="0"/>
-            <a:r>
-              <a:rPr b="1"/>
-              <a:t>Deterministic:</a:t>
-            </a:r>
-            <a:r>
-              <a:rPr/>
-              <a:t> Hybrid — O(1) runtime monitor + post-hoc Kripke-structure analyser</a:t>
-            </a:r>
-          </a:p>
-          <a:p>
-            <a:pPr lvl="0"/>
-            <a:r>
-              <a:rPr b="1"/>
-              <a:t>Mechanism:</a:t>
-            </a:r>
-            <a:r>
-              <a:rPr/>
-              <a:t> LTL model checking for memory integrity, tool call protocols, MCP/skill invocations, human-in-the-loop boundaries</a:t>
-            </a:r>
-          </a:p>
-          <a:p>
-            <a:pPr lvl="0"/>
-            <a:r>
-              <a:rPr b="1"/>
-              <a:t>Results:</a:t>
-            </a:r>
-            <a:r>
-              <a:rPr/>
-              <a:t> 86.67% verification accuracy vs 46.67% runtime baseline</a:t>
-            </a:r>
-          </a:p>
-          <a:p>
-            <a:pPr lvl="0"/>
-            <a:r>
-              <a:rPr b="1"/>
-              <a:t>Gap:</a:t>
-            </a:r>
-            <a:r>
-              <a:rPr/>
-              <a:t> Hybrid architecture, not purely deterministic runtime</a:t>
-            </a:r>
-          </a:p>
-          <a:p>
-            <a:pPr lvl="0" indent="0" marL="0">
-              <a:spcBef>
-                <a:spcPts val="3000"/>
-              </a:spcBef>
-              <a:buNone/>
-            </a:pPr>
-            <a:r>
-              <a:rPr b="1"/>
-              <a:t>5. SentinelAgent (arXiv:2604.02767, Layer 1)</a:t>
-            </a:r>
-          </a:p>
-          <a:p>
-            <a:pPr lvl="0"/>
-            <a:r>
-              <a:rPr b="1"/>
-              <a:t>Deterministic:</a:t>
-            </a:r>
-            <a:r>
-              <a:rPr/>
-              <a:t> Yes — Delegation Chain Calculus with 7 formal properties</a:t>
-            </a:r>
-          </a:p>
-          <a:p>
-            <a:pPr lvl="0"/>
-            <a:r>
-              <a:rPr b="1"/>
-              <a:t>Mechanism:</a:t>
-            </a:r>
-            <a:r>
-              <a:rPr/>
-              <a:t> DCC (Delegation Chain Calculus) — authority narrowing, policy preservation, forensic reconstructibility, cascade containment, scope-action conformance, output schema conformance, intent preservation</a:t>
-            </a:r>
-          </a:p>
-          <a:p>
-            <a:pPr lvl="0"/>
-            <a:r>
-              <a:rPr b="1"/>
-              <a:t>Verification:</a:t>
-            </a:r>
-            <a:r>
-              <a:rPr/>
-              <a:t> TLA+ verified across 2.7 million states</a:t>
-            </a:r>
-          </a:p>
-          <a:p>
-            <a:pPr lvl="0"/>
-            <a:r>
-              <a:rPr b="1"/>
-              <a:t>Results:</a:t>
-            </a:r>
-            <a:r>
-              <a:rPr/>
-              <a:t> 100% TPR at 0% FPR on DelegationBench v4 (516 scenarios, 10 attack categories)</a:t>
-            </a:r>
-          </a:p>
-          <a:p>
-            <a:pPr lvl="0"/>
-            <a:r>
-              <a:rPr b="1"/>
-              <a:t>Gap:</a:t>
-            </a:r>
-            <a:r>
-              <a:rPr/>
-              <a:t> Focused on delegation chains, not general skill execution</a:t>
-            </a:r>
-          </a:p>
-          <a:p>
-            <a:pPr lvl="0" indent="0" marL="0">
-              <a:spcBef>
-                <a:spcPts val="3000"/>
-              </a:spcBef>
-              <a:buNone/>
-            </a:pPr>
-            <a:r>
-              <a:rPr b="1"/>
-              <a:t>6. Trace-Based Assurance Framework (arXiv:2603.18096, Layer 1/2)</a:t>
-            </a:r>
-          </a:p>
-          <a:p>
-            <a:pPr lvl="0"/>
-            <a:r>
-              <a:rPr b="1"/>
-              <a:t>Deterministic:</a:t>
-            </a:r>
-            <a:r>
-              <a:rPr/>
-              <a:t> Yes — Message-Action Traces (MAT) with explicit contracts</a:t>
-            </a:r>
-          </a:p>
-          <a:p>
-            <a:pPr lvl="0"/>
-            <a:r>
-              <a:rPr b="1"/>
-              <a:t>Mechanism:</a:t>
-            </a:r>
-            <a:r>
-              <a:rPr/>
-              <a:t> Machine-checkable verdicts, deterministic replay, structured fault injection</a:t>
-            </a:r>
-          </a:p>
-          <a:p>
-            <a:pPr lvl="0"/>
-            <a:r>
-              <a:rPr b="1"/>
-              <a:t>Governance:</a:t>
-            </a:r>
-            <a:r>
-              <a:rPr/>
-              <a:t> Runtime component enforcing per-agent capability limits and action mediation (allow/rewrite/block)</a:t>
-            </a:r>
-          </a:p>
-          <a:p>
-            <a:pPr lvl="0"/>
-            <a:r>
-              <a:rPr b="1"/>
-              <a:t>Gap:</a:t>
-            </a:r>
-            <a:r>
-              <a:rPr/>
-              <a:t> Complex to implement; requires trace instrumentation</a:t>
-            </a:r>
-          </a:p>
-          <a:p>
-            <a:pPr lvl="0" indent="0" marL="0">
-              <a:spcBef>
-                <a:spcPts val="3000"/>
-              </a:spcBef>
-              <a:buNone/>
-            </a:pPr>
-            <a:r>
-              <a:rPr b="1"/>
-              <a:t>7. LGA / Layered Governance Architecture (arXiv:2603.07191, Layer 1)</a:t>
-            </a:r>
-          </a:p>
-          <a:p>
-            <a:pPr lvl="0"/>
-            <a:r>
-              <a:rPr b="1"/>
-              <a:t>Deterministic:</a:t>
-            </a:r>
-            <a:r>
-              <a:rPr/>
-              <a:t> Yes — sandboxing, intent verification, zero-trust authorization, audit logging</a:t>
-            </a:r>
-          </a:p>
-          <a:p>
-            <a:pPr lvl="0"/>
-            <a:r>
-              <a:rPr b="1"/>
-              <a:t>Mechanism:</a:t>
-            </a:r>
-            <a:r>
-              <a:rPr/>
-              <a:t> Four layers of runtime governance</a:t>
-            </a:r>
-          </a:p>
-          <a:p>
-            <a:pPr lvl="0"/>
-            <a:r>
-              <a:rPr b="1"/>
-              <a:t>Results:</a:t>
-            </a:r>
-            <a:r>
-              <a:rPr/>
-              <a:t> 89% of attacks succeed against baseline guardrails — showing LGA’s enforcement is needed</a:t>
-            </a:r>
-          </a:p>
-          <a:p>
-            <a:pPr lvl="0"/>
-            <a:r>
-              <a:rPr b="1"/>
-              <a:t>Gap:</a:t>
-            </a:r>
-            <a:r>
-              <a:rPr/>
-              <a:t> Architectural framework, not a specific implementation</a:t>
-            </a:r>
-          </a:p>
-          <a:p>
-            <a:pPr lvl="0" indent="0" marL="0">
-              <a:spcBef>
-                <a:spcPts val="3000"/>
-              </a:spcBef>
-              <a:buNone/>
-            </a:pPr>
-            <a:r>
-              <a:rPr b="1"/>
-              <a:t>8. MCP-38 / Threat Taxonomy (arXiv:2603.18063, Layer 1)</a:t>
-            </a:r>
-          </a:p>
-          <a:p>
-            <a:pPr lvl="0"/>
-            <a:r>
-              <a:rPr b="1"/>
-              <a:t>Deterministic:</a:t>
-            </a:r>
-            <a:r>
-              <a:rPr/>
-              <a:t> N/A — taxonomy paper, not enforcement</a:t>
-            </a:r>
-          </a:p>
-          <a:p>
-            <a:pPr lvl="0"/>
-            <a:r>
-              <a:rPr b="1"/>
-              <a:t>Contribution:</a:t>
-            </a:r>
-            <a:r>
-              <a:rPr/>
-              <a:t> 38 threat categories mapped to STRIDE, OWASP LLM Top 10, OWASP Agentic Top 10</a:t>
-            </a:r>
-          </a:p>
-          <a:p>
-            <a:pPr lvl="0"/>
-            <a:r>
-              <a:rPr b="1"/>
-              <a:t>Gap:</a:t>
-            </a:r>
-            <a:r>
-              <a:rPr/>
-              <a:t> No runtime enforcement mechanism</a:t>
-            </a:r>
-          </a:p>
-          <a:p>
-            <a:pPr lvl="0" indent="0" marL="0">
-              <a:spcBef>
-                <a:spcPts val="3000"/>
-              </a:spcBef>
-              <a:buNone/>
-            </a:pPr>
-            <a:r>
-              <a:rPr b="1"/>
-              <a:t>9. NIST IR 8596 (Dec 2025, Layer 1/2)</a:t>
-            </a:r>
-          </a:p>
-          <a:p>
-            <a:pPr lvl="0"/>
-            <a:r>
-              <a:rPr b="1"/>
-              <a:t>Deterministic:</a:t>
-            </a:r>
-            <a:r>
-              <a:rPr/>
-              <a:t> Standards document, not implementation</a:t>
-            </a:r>
-          </a:p>
-          <a:p>
-            <a:pPr lvl="0"/>
-            <a:r>
-              <a:rPr b="1"/>
-              <a:t>Gap:</a:t>
-            </a:r>
-            <a:r>
-              <a:rPr/>
-              <a:t> Framework only, no runtime enforcement</a:t>
+              <a:t>Short Answer: Yes — and ZipperGen is the only multi-agent approach that deterministically enforces coordination structure.</a:t>
             </a:r>
           </a:p>
         </p:txBody>
@@ -3933,7 +3376,19 @@
             </a:pPr>
             <a:r>
               <a:rPr b="1"/>
-              <a:t>10. ZipperGen / Provable Coordination for LLM Agents via MSCs (arXiv:2604.17612, Cross-layer Layer 0+1)</a:t>
+              <a:t>Papers With Deterministic Runtime Enforcement</a:t>
+            </a:r>
+          </a:p>
+          <a:p>
+            <a:pPr lvl="0" indent="0" marL="0">
+              <a:spcBef>
+                <a:spcPts val="3000"/>
+              </a:spcBef>
+              <a:buNone/>
+            </a:pPr>
+            <a:r>
+              <a:rPr b="1"/>
+              <a:t>1. ZipperGen / Provable Coordination for LLM Agents via MSCs (arXiv:2604.17612, Cross-layer Layer 0+1) — Multi-Agent Coordination — Breakthrough</a:t>
             </a:r>
           </a:p>
           <a:p>
@@ -3944,7 +3399,7 @@
             </a:r>
             <a:r>
               <a:rPr/>
-              <a:t> Yes — message-passing structure is formally specified; LLM actions remain opaque</a:t>
+              <a:t> Yes — message-passing structure is formally specified and deterministically enforced; LLM actions remain opaque</a:t>
             </a:r>
           </a:p>
           <a:p>
@@ -3955,7 +3410,45 @@
             </a:r>
             <a:r>
               <a:rPr/>
-              <a:t> Domain-specific language based on Message Sequence Charts (MSCs). Syntax-directed projection generates deadlock-free local agent programs from global coordination specifications. Owned control flow with explicit deciders. Control broadcasts ensure non-owner lifelines observe branch choices.</a:t>
+              <a:t> Domain-specific language (DSL) based on Message Sequence Charts (MSCs). Syntax-directed projection generates local agent programs from global coordination specifications. Owned control flow with explicit deciders. Control broadcasts ensure non-owner lifelines observe branch choices.</a:t>
+            </a:r>
+          </a:p>
+          <a:p>
+            <a:pPr lvl="0"/>
+            <a:r>
+              <a:rPr b="1"/>
+              <a:t>Key innovation:</a:t>
+            </a:r>
+            <a:r>
+              <a:rPr/>
+              <a:t> The coordination structure (message passing, branch decisions, loops) is </a:t>
+            </a:r>
+            <a:r>
+              <a:rPr b="1"/>
+              <a:t>guaranteed correct by construction</a:t>
+            </a:r>
+            <a:r>
+              <a:rPr/>
+              <a:t> — deadlock-free, no message mismatches, no race conditions. The LLM actions inside the structure are opaque (unpredictable), but the </a:t>
+            </a:r>
+            <a:r>
+              <a:rPr i="1"/>
+              <a:t>structure around them</a:t>
+            </a:r>
+            <a:r>
+              <a:rPr/>
+              <a:t> is deterministic and formally verified.</a:t>
+            </a:r>
+          </a:p>
+          <a:p>
+            <a:pPr lvl="0"/>
+            <a:r>
+              <a:rPr b="1"/>
+              <a:t>Runtime:</a:t>
+            </a:r>
+            <a:r>
+              <a:rPr/>
+              <a:t> The projected local programs are deterministic finite-state programs that agents execute. No LLM-as-judge for coordination decisions.</a:t>
             </a:r>
           </a:p>
           <a:p>
@@ -3966,7 +3459,7 @@
             </a:r>
             <a:r>
               <a:rPr/>
-              <a:t> Deadlock-free by construction. Coordination properties established independently of LLM nondeterminism. Runtime planning extension: LLM generates workflows with same structural guarantees.</a:t>
+              <a:t> Deadlock-free by construction. Coordination properties established independently of LLM nondeterminism. Runtime planning extension: LLM dynamically generates coordination workflows with same structural guarantees.</a:t>
             </a:r>
           </a:p>
           <a:p>
@@ -3988,7 +3481,566 @@
             </a:r>
             <a:r>
               <a:rPr/>
-              <a:t> Does not verify LLM action content (opaque by design). No runtime behavioral enforcement beyond coordination structure.</a:t>
+              <a:t> Does not verify LLM action content (opaque by design). No runtime behavioral enforcement of what agents actually do inside action blocks.</a:t>
+            </a:r>
+          </a:p>
+          <a:p>
+            <a:pPr lvl="0" indent="0" marL="0">
+              <a:spcBef>
+                <a:spcPts val="3000"/>
+              </a:spcBef>
+              <a:buNone/>
+            </a:pPr>
+            <a:r>
+              <a:rPr b="1"/>
+              <a:t>2. ACP — Admission Control Protocol (arXiv:2603.18829, Layer 1) — Fastest Single-Agent + Formally Verified</a:t>
+            </a:r>
+          </a:p>
+          <a:p>
+            <a:pPr lvl="0"/>
+            <a:r>
+              <a:rPr b="1"/>
+              <a:t>Deterministic:</a:t>
+            </a:r>
+            <a:r>
+              <a:rPr/>
+              <a:t> Yes — risk scoring is deterministic, not LLM-based</a:t>
+            </a:r>
+          </a:p>
+          <a:p>
+            <a:pPr lvl="0"/>
+            <a:r>
+              <a:rPr b="1"/>
+              <a:t>Mechanism:</a:t>
+            </a:r>
+            <a:r>
+              <a:rPr/>
+              <a:t> Temporal admission control with static risk scoring + stateful signals (anomaly accumulation, cooldown) through LedgerQuerier</a:t>
+            </a:r>
+          </a:p>
+          <a:p>
+            <a:pPr lvl="0"/>
+            <a:r>
+              <a:rPr b="1"/>
+              <a:t>Performance:</a:t>
+            </a:r>
+            <a:r>
+              <a:rPr/>
+              <a:t> 739-832 ns decision latency; 1,720,000 req/s throughput</a:t>
+            </a:r>
+          </a:p>
+          <a:p>
+            <a:pPr lvl="0"/>
+            <a:r>
+              <a:rPr b="1"/>
+              <a:t>Verification:</a:t>
+            </a:r>
+            <a:r>
+              <a:rPr/>
+              <a:t> TLA+ verified across 4,294,930,695 states, 11 invariants + 4 temporal properties, 0 violations</a:t>
+            </a:r>
+          </a:p>
+          <a:p>
+            <a:pPr lvl="0"/>
+            <a:r>
+              <a:rPr b="1"/>
+              <a:t>Key result:</a:t>
+            </a:r>
+            <a:r>
+              <a:rPr/>
+              <a:t> Stateless engines approve 100% of individually-valid requests in a 500-request attack chain; ACP limits autonomous execution to 0.4%</a:t>
+            </a:r>
+          </a:p>
+          <a:p>
+            <a:pPr lvl="0"/>
+            <a:r>
+              <a:rPr b="1"/>
+              <a:t>Open source:</a:t>
+            </a:r>
+            <a:r>
+              <a:rPr/>
+              <a:t> Go reference implementation (23 packages, 138 conformance tests)</a:t>
+            </a:r>
+          </a:p>
+          <a:p>
+            <a:pPr lvl="0"/>
+            <a:r>
+              <a:rPr b="1"/>
+              <a:t>Paper series:</a:t>
+            </a:r>
+            <a:r>
+              <a:rPr/>
+              <a:t> 1 of 6-paper Agent Governance Series (Marcelo Fernandez)</a:t>
+            </a:r>
+          </a:p>
+          <a:p>
+            <a:pPr lvl="0" indent="0" marL="0">
+              <a:spcBef>
+                <a:spcPts val="3000"/>
+              </a:spcBef>
+              <a:buNone/>
+            </a:pPr>
+            <a:r>
+              <a:rPr b="1"/>
+              <a:t>3. Agent Behavioral Contracts (ABC) (arXiv:2602.22302, Layer 1/2) — Most Comprehensive Single-Agent</a:t>
+            </a:r>
+          </a:p>
+          <a:p>
+            <a:pPr lvl="0"/>
+            <a:r>
+              <a:rPr b="1"/>
+              <a:t>Deterministic:</a:t>
+            </a:r>
+            <a:r>
+              <a:rPr/>
+              <a:t> Yes — contracts are formal, not probabilistic</a:t>
+            </a:r>
+          </a:p>
+          <a:p>
+            <a:pPr lvl="0"/>
+            <a:r>
+              <a:rPr b="1"/>
+              <a:t>Mechanism:</a:t>
+            </a:r>
+            <a:r>
+              <a:rPr/>
+              <a:t> Contract C = (P, I, G, R) — Preconditions, Invariants, Governance policies, Recovery</a:t>
+            </a:r>
+          </a:p>
+          <a:p>
+            <a:pPr lvl="0"/>
+            <a:r>
+              <a:rPr b="1"/>
+              <a:t>Runtime:</a:t>
+            </a:r>
+            <a:r>
+              <a:rPr/>
+              <a:t> AgentAssert library enforces contracts with &lt;10 ms overhead per action</a:t>
+            </a:r>
+          </a:p>
+          <a:p>
+            <a:pPr lvl="0"/>
+            <a:r>
+              <a:rPr b="1"/>
+              <a:t>Results:</a:t>
+            </a:r>
+            <a:r>
+              <a:rPr/>
+              <a:t> 88-100% hard constraint compliance; behavioral drift bounded to D* &lt; 0.27</a:t>
+            </a:r>
+          </a:p>
+          <a:p>
+            <a:pPr lvl="0"/>
+            <a:r>
+              <a:rPr b="1"/>
+              <a:t>Verification:</a:t>
+            </a:r>
+            <a:r>
+              <a:rPr/>
+              <a:t> (p, delta, k)-satisfaction for probabilistic compliance; Drift Bounds Theorem</a:t>
+            </a:r>
+          </a:p>
+          <a:p>
+            <a:pPr lvl="0"/>
+            <a:r>
+              <a:rPr b="1"/>
+              <a:t>Open source:</a:t>
+            </a:r>
+            <a:r>
+              <a:rPr/>
+              <a:t> AgentAssert runtime library (Qualixar suite)</a:t>
+            </a:r>
+          </a:p>
+          <a:p>
+            <a:pPr lvl="0"/>
+            <a:r>
+              <a:rPr b="1"/>
+              <a:t>Gap:</a:t>
+            </a:r>
+            <a:r>
+              <a:rPr/>
+              <a:t> Contracts are probabilistically satisfied, not 100% deterministic; single-agent only</a:t>
+            </a:r>
+          </a:p>
+          <a:p>
+            <a:pPr lvl="0" indent="0" marL="0">
+              <a:spcBef>
+                <a:spcPts val="3000"/>
+              </a:spcBef>
+              <a:buNone/>
+            </a:pPr>
+            <a:r>
+              <a:rPr b="1"/>
+              <a:t>4. Runtime Governance / Policies on Paths (arXiv:2603.16586, Layer 1) — Most Expressive Single-Agent</a:t>
+            </a:r>
+          </a:p>
+          <a:p>
+            <a:pPr lvl="0"/>
+            <a:r>
+              <a:rPr b="1"/>
+              <a:t>Deterministic:</a:t>
+            </a:r>
+            <a:r>
+              <a:rPr/>
+              <a:t> Yes — policies are temporal predicates, not LLM-evaluated</a:t>
+            </a:r>
+          </a:p>
+          <a:p>
+            <a:pPr lvl="0"/>
+            <a:r>
+              <a:rPr b="1"/>
+              <a:t>Mechanism:</a:t>
+            </a:r>
+            <a:r>
+              <a:rPr/>
+              <a:t> Path-based policies as functions on execution paths; policy compiler translates requirements to executable path monitors</a:t>
+            </a:r>
+          </a:p>
+          <a:p>
+            <a:pPr lvl="0"/>
+            <a:r>
+              <a:rPr b="1"/>
+              <a:t>Complexity:</a:t>
+            </a:r>
+            <a:r>
+              <a:rPr/>
+              <a:t> Polynomial-time evaluation</a:t>
+            </a:r>
+          </a:p>
+          <a:p>
+            <a:pPr lvl="0"/>
+            <a:r>
+              <a:rPr b="1"/>
+              <a:t>Expressiveness:</a:t>
+            </a:r>
+            <a:r>
+              <a:rPr/>
+              <a:t> Can encode separation of duties, data minimization, audit trails</a:t>
+            </a:r>
+          </a:p>
+          <a:p>
+            <a:pPr lvl="0"/>
+            <a:r>
+              <a:rPr b="1"/>
+              <a:t>Gap:</a:t>
+            </a:r>
+            <a:r>
+              <a:rPr/>
+              <a:t> Proposed framework, not yet evaluated at scale; single-agent only</a:t>
+            </a:r>
+          </a:p>
+          <a:p>
+            <a:pPr lvl="0" indent="0" marL="0">
+              <a:spcBef>
+                <a:spcPts val="3000"/>
+              </a:spcBef>
+              <a:buNone/>
+            </a:pPr>
+            <a:r>
+              <a:rPr b="1"/>
+              <a:t>5. AgentVerify (preprints.org, 2026, Layer 1/2)</a:t>
+            </a:r>
+          </a:p>
+          <a:p>
+            <a:pPr lvl="0"/>
+            <a:r>
+              <a:rPr b="1"/>
+              <a:t>Deterministic:</a:t>
+            </a:r>
+            <a:r>
+              <a:rPr/>
+              <a:t> Hybrid — O(1) runtime monitor + post-hoc Kripke-structure analyser</a:t>
+            </a:r>
+          </a:p>
+          <a:p>
+            <a:pPr lvl="0"/>
+            <a:r>
+              <a:rPr b="1"/>
+              <a:t>Mechanism:</a:t>
+            </a:r>
+            <a:r>
+              <a:rPr/>
+              <a:t> LTL model checking for memory integrity, tool call protocols, MCP/skill invocations, human-in-the-loop boundaries</a:t>
+            </a:r>
+          </a:p>
+          <a:p>
+            <a:pPr lvl="0"/>
+            <a:r>
+              <a:rPr b="1"/>
+              <a:t>Results:</a:t>
+            </a:r>
+            <a:r>
+              <a:rPr/>
+              <a:t> 86.67% verification accuracy vs 46.67% runtime baseline</a:t>
+            </a:r>
+          </a:p>
+          <a:p>
+            <a:pPr lvl="0"/>
+            <a:r>
+              <a:rPr b="1"/>
+              <a:t>Gap:</a:t>
+            </a:r>
+            <a:r>
+              <a:rPr/>
+              <a:t> Hybrid architecture, not purely deterministic runtime; single-agent only</a:t>
+            </a:r>
+          </a:p>
+          <a:p>
+            <a:pPr lvl="0" indent="0" marL="0">
+              <a:spcBef>
+                <a:spcPts val="3000"/>
+              </a:spcBef>
+              <a:buNone/>
+            </a:pPr>
+            <a:r>
+              <a:rPr b="1"/>
+              <a:t>6. SentinelAgent (arXiv:2604.02767, Layer 1)</a:t>
+            </a:r>
+          </a:p>
+          <a:p>
+            <a:pPr lvl="0"/>
+            <a:r>
+              <a:rPr b="1"/>
+              <a:t>Deterministic:</a:t>
+            </a:r>
+            <a:r>
+              <a:rPr/>
+              <a:t> Yes — Delegation Chain Calculus with 7 formal properties</a:t>
+            </a:r>
+          </a:p>
+          <a:p>
+            <a:pPr lvl="0"/>
+            <a:r>
+              <a:rPr b="1"/>
+              <a:t>Mechanism:</a:t>
+            </a:r>
+            <a:r>
+              <a:rPr/>
+              <a:t> DCC (Delegation Chain Calculus) — authority narrowing, policy preservation, forensic reconstructibility, cascade containment, scope-action conformance, output schema conformance, intent preservation</a:t>
+            </a:r>
+          </a:p>
+          <a:p>
+            <a:pPr lvl="0"/>
+            <a:r>
+              <a:rPr b="1"/>
+              <a:t>Verification:</a:t>
+            </a:r>
+            <a:r>
+              <a:rPr/>
+              <a:t> TLA+ verified across 2.7 million states</a:t>
+            </a:r>
+          </a:p>
+          <a:p>
+            <a:pPr lvl="0"/>
+            <a:r>
+              <a:rPr b="1"/>
+              <a:t>Results:</a:t>
+            </a:r>
+            <a:r>
+              <a:rPr/>
+              <a:t> 100% TPR at 0% FPR on DelegationBench v4 (516 scenarios, 10 attack categories)</a:t>
+            </a:r>
+          </a:p>
+          <a:p>
+            <a:pPr lvl="0"/>
+            <a:r>
+              <a:rPr b="1"/>
+              <a:t>Gap:</a:t>
+            </a:r>
+            <a:r>
+              <a:rPr/>
+              <a:t> Focused on delegation chains, not general skill execution; single-agent only</a:t>
+            </a:r>
+          </a:p>
+          <a:p>
+            <a:pPr lvl="0" indent="0" marL="0">
+              <a:spcBef>
+                <a:spcPts val="3000"/>
+              </a:spcBef>
+              <a:buNone/>
+            </a:pPr>
+            <a:r>
+              <a:rPr b="1"/>
+              <a:t>7. Trace-Based Assurance Framework (arXiv:2603.18096, Layer 1/2)</a:t>
+            </a:r>
+          </a:p>
+          <a:p>
+            <a:pPr lvl="0"/>
+            <a:r>
+              <a:rPr b="1"/>
+              <a:t>Deterministic:</a:t>
+            </a:r>
+            <a:r>
+              <a:rPr/>
+              <a:t> Yes — Message-Action Traces (MAT) with explicit contracts</a:t>
+            </a:r>
+          </a:p>
+          <a:p>
+            <a:pPr lvl="0"/>
+            <a:r>
+              <a:rPr b="1"/>
+              <a:t>Mechanism:</a:t>
+            </a:r>
+            <a:r>
+              <a:rPr/>
+              <a:t> Machine-checkable verdicts, deterministic replay, structured fault injection</a:t>
+            </a:r>
+          </a:p>
+          <a:p>
+            <a:pPr lvl="0"/>
+            <a:r>
+              <a:rPr b="1"/>
+              <a:t>Governance:</a:t>
+            </a:r>
+            <a:r>
+              <a:rPr/>
+              <a:t> Runtime component enforcing per-agent capability limits and action mediation (allow/rewrite/block)</a:t>
+            </a:r>
+          </a:p>
+          <a:p>
+            <a:pPr lvl="0"/>
+            <a:r>
+              <a:rPr b="1"/>
+              <a:t>Gap:</a:t>
+            </a:r>
+            <a:r>
+              <a:rPr/>
+              <a:t> Complex to implement; requires trace instrumentation; single-agent only</a:t>
+            </a:r>
+          </a:p>
+          <a:p>
+            <a:pPr lvl="0" indent="0" marL="0">
+              <a:spcBef>
+                <a:spcPts val="3000"/>
+              </a:spcBef>
+              <a:buNone/>
+            </a:pPr>
+            <a:r>
+              <a:rPr b="1"/>
+              <a:t>8. LGA / Layered Governance Architecture (arXiv:2603.07191, Layer 1)</a:t>
+            </a:r>
+          </a:p>
+          <a:p>
+            <a:pPr lvl="0"/>
+            <a:r>
+              <a:rPr b="1"/>
+              <a:t>Deterministic:</a:t>
+            </a:r>
+            <a:r>
+              <a:rPr/>
+              <a:t> Yes — sandboxing, intent verification, zero-trust authorization, audit logging</a:t>
+            </a:r>
+          </a:p>
+          <a:p>
+            <a:pPr lvl="0"/>
+            <a:r>
+              <a:rPr b="1"/>
+              <a:t>Mechanism:</a:t>
+            </a:r>
+            <a:r>
+              <a:rPr/>
+              <a:t> Four layers of runtime governance</a:t>
+            </a:r>
+          </a:p>
+          <a:p>
+            <a:pPr lvl="0"/>
+            <a:r>
+              <a:rPr b="1"/>
+              <a:t>Results:</a:t>
+            </a:r>
+            <a:r>
+              <a:rPr/>
+              <a:t> 89% of attacks succeed against baseline guardrails — showing LGA’s enforcement is needed</a:t>
+            </a:r>
+          </a:p>
+          <a:p>
+            <a:pPr lvl="0"/>
+            <a:r>
+              <a:rPr b="1"/>
+              <a:t>Gap:</a:t>
+            </a:r>
+            <a:r>
+              <a:rPr/>
+              <a:t> Architectural framework, not a specific implementation; single-agent only</a:t>
+            </a:r>
+          </a:p>
+          <a:p>
+            <a:pPr lvl="0" indent="0" marL="0">
+              <a:spcBef>
+                <a:spcPts val="3000"/>
+              </a:spcBef>
+              <a:buNone/>
+            </a:pPr>
+            <a:r>
+              <a:rPr b="1"/>
+              <a:t>9. MCP-38 / Threat Taxonomy (arXiv:2603.18063, Layer 1)</a:t>
+            </a:r>
+          </a:p>
+          <a:p>
+            <a:pPr lvl="0"/>
+            <a:r>
+              <a:rPr b="1"/>
+              <a:t>Deterministic:</a:t>
+            </a:r>
+            <a:r>
+              <a:rPr/>
+              <a:t> N/A — taxonomy paper, not enforcement</a:t>
+            </a:r>
+          </a:p>
+          <a:p>
+            <a:pPr lvl="0"/>
+            <a:r>
+              <a:rPr b="1"/>
+              <a:t>Contribution:</a:t>
+            </a:r>
+            <a:r>
+              <a:rPr/>
+              <a:t> 38 threat categories mapped to STRIDE, OWASP LLM Top 10, OWASP Agentic Top 10</a:t>
+            </a:r>
+          </a:p>
+          <a:p>
+            <a:pPr lvl="0"/>
+            <a:r>
+              <a:rPr b="1"/>
+              <a:t>Gap:</a:t>
+            </a:r>
+            <a:r>
+              <a:rPr/>
+              <a:t> No runtime enforcement mechanism</a:t>
+            </a:r>
+          </a:p>
+          <a:p>
+            <a:pPr lvl="0" indent="0" marL="0">
+              <a:spcBef>
+                <a:spcPts val="3000"/>
+              </a:spcBef>
+              <a:buNone/>
+            </a:pPr>
+            <a:r>
+              <a:rPr b="1"/>
+              <a:t>10. NIST IR 8596 (Dec 2025, Layer 1/2)</a:t>
+            </a:r>
+          </a:p>
+          <a:p>
+            <a:pPr lvl="0"/>
+            <a:r>
+              <a:rPr b="1"/>
+              <a:t>Deterministic:</a:t>
+            </a:r>
+            <a:r>
+              <a:rPr/>
+              <a:t> Standards document, not implementation</a:t>
+            </a:r>
+          </a:p>
+          <a:p>
+            <a:pPr lvl="0"/>
+            <a:r>
+              <a:rPr b="1"/>
+              <a:t>Gap:</a:t>
+            </a:r>
+            <a:r>
+              <a:rPr/>
+              <a:t> Framework only, no runtime enforcement</a:t>
             </a:r>
           </a:p>
         </p:txBody>
@@ -4017,12 +4069,12 @@
       </p:grpSpPr>
       <p:sp>
         <p:nvSpPr>
-          <p:cNvPr id="4" name="Text Placeholder 3"/>
+          <p:cNvPr id="3" name="Content Placeholder 2"/>
           <p:cNvSpPr>
             <a:spLocks noGrp="1"/>
           </p:cNvSpPr>
           <p:nvPr>
-            <p:ph idx="2" sz="half" type="body"/>
+            <p:ph idx="1"/>
           </p:nvPr>
         </p:nvSpPr>
         <p:spPr/>
@@ -4038,740 +4090,66 @@
             </a:pPr>
             <a:r>
               <a:rPr b="1"/>
-              <a:t>Comparison: Deterministic vs LLM-as-Judge Runtime Checking</a:t>
+              <a:t>10. ZipperGen / Provable Coordination for LLM Agents via MSCs (arXiv:2604.17612, Cross-layer Layer 0+1)</a:t>
+            </a:r>
+          </a:p>
+          <a:p>
+            <a:pPr lvl="0"/>
+            <a:r>
+              <a:rPr b="1"/>
+              <a:t>Deterministic:</a:t>
+            </a:r>
+            <a:r>
+              <a:rPr/>
+              <a:t> Yes — message-passing structure is formally specified; LLM actions remain opaque</a:t>
+            </a:r>
+          </a:p>
+          <a:p>
+            <a:pPr lvl="0"/>
+            <a:r>
+              <a:rPr b="1"/>
+              <a:t>Mechanism:</a:t>
+            </a:r>
+            <a:r>
+              <a:rPr/>
+              <a:t> Domain-specific language based on Message Sequence Charts (MSCs). Syntax-directed projection generates deadlock-free local agent programs from global coordination specifications. Owned control flow with explicit deciders. Control broadcasts ensure non-owner lifelines observe branch choices.</a:t>
+            </a:r>
+          </a:p>
+          <a:p>
+            <a:pPr lvl="0"/>
+            <a:r>
+              <a:rPr b="1"/>
+              <a:t>Results:</a:t>
+            </a:r>
+            <a:r>
+              <a:rPr/>
+              <a:t> Deadlock-free by construction. Coordination properties established independently of LLM nondeterminism. Runtime planning extension: LLM generates workflows with same structural guarantees.</a:t>
+            </a:r>
+          </a:p>
+          <a:p>
+            <a:pPr lvl="0"/>
+            <a:r>
+              <a:rPr b="1"/>
+              <a:t>Open source:</a:t>
+            </a:r>
+            <a:r>
+              <a:rPr/>
+              <a:t> ZipperGen — https://zippergen.io</a:t>
+            </a:r>
+          </a:p>
+          <a:p>
+            <a:pPr lvl="0"/>
+            <a:r>
+              <a:rPr b="1"/>
+              <a:t>Gap:</a:t>
+            </a:r>
+            <a:r>
+              <a:rPr/>
+              <a:t> Does not verify LLM action content (opaque by design). No runtime behavioral enforcement beyond coordination structure.</a:t>
             </a:r>
           </a:p>
         </p:txBody>
       </p:sp>
-      <p:graphicFrame>
-        <p:nvGraphicFramePr>
-          <p:cNvPr id="6" name="Content Placeholder 5"/>
-          <p:cNvGraphicFramePr>
-            <a:graphicFrameLocks noGrp="1"/>
-          </p:cNvGraphicFramePr>
-          <p:nvPr>
-            <p:ph idx="1"/>
-          </p:nvPr>
-        </p:nvGraphicFramePr>
-        <p:xfrm>
-          <a:off x="3568700" y="203200"/>
-          <a:ext cx="5105400" cy="4381500"/>
-        </p:xfrm>
-        <a:graphic>
-          <a:graphicData uri="http://schemas.openxmlformats.org/drawingml/2006/table">
-            <a:tbl>
-              <a:tblPr firstRow="1" bandRow="1">
-                <a:tableStyleId>{5C22544A-7EE6-4342-B048-85BDC9FD1C3A}</a:tableStyleId>
-              </a:tblPr>
-              <a:tblGrid>
-                <a:gridCol w="1016000"/>
-                <a:gridCol w="1016000"/>
-                <a:gridCol w="1016000"/>
-                <a:gridCol w="1016000"/>
-                <a:gridCol w="1016000"/>
-              </a:tblGrid>
-              <a:tr h="0">
-                <a:tc>
-                  <a:txBody>
-                    <a:bodyPr/>
-                    <a:lstStyle/>
-                    <a:p>
-                      <a:pPr lvl="0" indent="0" marL="0">
-                        <a:buNone/>
-                      </a:pPr>
-                      <a:r>
-                        <a:rPr/>
-                        <a:t>Mechanism</a:t>
-                      </a:r>
-                    </a:p>
-                  </a:txBody>
-                  <a:tcPr/>
-                </a:tc>
-                <a:tc>
-                  <a:txBody>
-                    <a:bodyPr/>
-                    <a:lstStyle/>
-                    <a:p>
-                      <a:pPr lvl="0" indent="0" marL="0">
-                        <a:buNone/>
-                      </a:pPr>
-                      <a:r>
-                        <a:rPr/>
-                        <a:t>Deterministic?</a:t>
-                      </a:r>
-                    </a:p>
-                  </a:txBody>
-                  <a:tcPr/>
-                </a:tc>
-                <a:tc>
-                  <a:txBody>
-                    <a:bodyPr/>
-                    <a:lstStyle/>
-                    <a:p>
-                      <a:pPr lvl="0" indent="0" marL="0">
-                        <a:buNone/>
-                      </a:pPr>
-                      <a:r>
-                        <a:rPr/>
-                        <a:t>Speed</a:t>
-                      </a:r>
-                    </a:p>
-                  </a:txBody>
-                  <a:tcPr/>
-                </a:tc>
-                <a:tc>
-                  <a:txBody>
-                    <a:bodyPr/>
-                    <a:lstStyle/>
-                    <a:p>
-                      <a:pPr lvl="0" indent="0" marL="0">
-                        <a:buNone/>
-                      </a:pPr>
-                      <a:r>
-                        <a:rPr/>
-                        <a:t>Formal Verification</a:t>
-                      </a:r>
-                    </a:p>
-                  </a:txBody>
-                  <a:tcPr/>
-                </a:tc>
-                <a:tc>
-                  <a:txBody>
-                    <a:bodyPr/>
-                    <a:lstStyle/>
-                    <a:p>
-                      <a:pPr lvl="0" indent="0" marL="0">
-                        <a:buNone/>
-                      </a:pPr>
-                      <a:r>
-                        <a:rPr/>
-                        <a:t>Production Ready</a:t>
-                      </a:r>
-                    </a:p>
-                  </a:txBody>
-                  <a:tcPr/>
-                </a:tc>
-              </a:tr>
-              <a:tr h="0">
-                <a:tc>
-                  <a:txBody>
-                    <a:bodyPr/>
-                    <a:lstStyle/>
-                    <a:p>
-                      <a:pPr lvl="0" indent="0" marL="0">
-                        <a:buNone/>
-                      </a:pPr>
-                      <a:r>
-                        <a:rPr b="1"/>
-                        <a:t>ACP</a:t>
-                      </a:r>
-                    </a:p>
-                  </a:txBody>
-                </a:tc>
-                <a:tc>
-                  <a:txBody>
-                    <a:bodyPr/>
-                    <a:lstStyle/>
-                    <a:p>
-                      <a:pPr lvl="0" indent="0" marL="0">
-                        <a:buNone/>
-                      </a:pPr>
-                      <a:r>
-                        <a:rPr/>
-                        <a:t>✅ Yes</a:t>
-                      </a:r>
-                    </a:p>
-                  </a:txBody>
-                </a:tc>
-                <a:tc>
-                  <a:txBody>
-                    <a:bodyPr/>
-                    <a:lstStyle/>
-                    <a:p>
-                      <a:pPr lvl="0" indent="0" marL="0">
-                        <a:buNone/>
-                      </a:pPr>
-                      <a:r>
-                        <a:rPr/>
-                        <a:t>739-832 ns</a:t>
-                      </a:r>
-                    </a:p>
-                  </a:txBody>
-                </a:tc>
-                <a:tc>
-                  <a:txBody>
-                    <a:bodyPr/>
-                    <a:lstStyle/>
-                    <a:p>
-                      <a:pPr lvl="0" indent="0" marL="0">
-                        <a:buNone/>
-                      </a:pPr>
-                      <a:r>
-                        <a:rPr/>
-                        <a:t>TLA+ (4.2B states)</a:t>
-                      </a:r>
-                    </a:p>
-                  </a:txBody>
-                </a:tc>
-                <a:tc>
-                  <a:txBody>
-                    <a:bodyPr/>
-                    <a:lstStyle/>
-                    <a:p>
-                      <a:pPr lvl="0" indent="0" marL="0">
-                        <a:buNone/>
-                      </a:pPr>
-                      <a:r>
-                        <a:rPr/>
-                        <a:t>✅ Go impl</a:t>
-                      </a:r>
-                    </a:p>
-                  </a:txBody>
-                </a:tc>
-              </a:tr>
-              <a:tr h="0">
-                <a:tc>
-                  <a:txBody>
-                    <a:bodyPr/>
-                    <a:lstStyle/>
-                    <a:p>
-                      <a:pPr lvl="0" indent="0" marL="0">
-                        <a:buNone/>
-                      </a:pPr>
-                      <a:r>
-                        <a:rPr b="1"/>
-                        <a:t>ABC / AgentAssert</a:t>
-                      </a:r>
-                    </a:p>
-                  </a:txBody>
-                </a:tc>
-                <a:tc>
-                  <a:txBody>
-                    <a:bodyPr/>
-                    <a:lstStyle/>
-                    <a:p>
-                      <a:pPr lvl="0" indent="0" marL="0">
-                        <a:buNone/>
-                      </a:pPr>
-                      <a:r>
-                        <a:rPr/>
-                        <a:t>✅ Mostly</a:t>
-                      </a:r>
-                    </a:p>
-                  </a:txBody>
-                </a:tc>
-                <a:tc>
-                  <a:txBody>
-                    <a:bodyPr/>
-                    <a:lstStyle/>
-                    <a:p>
-                      <a:pPr lvl="0" indent="0" marL="0">
-                        <a:buNone/>
-                      </a:pPr>
-                      <a:r>
-                        <a:rPr/>
-                        <a:t>&lt;10 ms</a:t>
-                      </a:r>
-                    </a:p>
-                  </a:txBody>
-                </a:tc>
-                <a:tc>
-                  <a:txBody>
-                    <a:bodyPr/>
-                    <a:lstStyle/>
-                    <a:p>
-                      <a:pPr lvl="0" indent="0" marL="0">
-                        <a:buNone/>
-                      </a:pPr>
-                      <a:r>
-                        <a:rPr/>
-                        <a:t>Drift Bounds Theorem</a:t>
-                      </a:r>
-                    </a:p>
-                  </a:txBody>
-                </a:tc>
-                <a:tc>
-                  <a:txBody>
-                    <a:bodyPr/>
-                    <a:lstStyle/>
-                    <a:p>
-                      <a:pPr lvl="0" indent="0" marL="0">
-                        <a:buNone/>
-                      </a:pPr>
-                      <a:r>
-                        <a:rPr/>
-                        <a:t>✅ Library</a:t>
-                      </a:r>
-                    </a:p>
-                  </a:txBody>
-                </a:tc>
-              </a:tr>
-              <a:tr h="0">
-                <a:tc>
-                  <a:txBody>
-                    <a:bodyPr/>
-                    <a:lstStyle/>
-                    <a:p>
-                      <a:pPr lvl="0" indent="0" marL="0">
-                        <a:buNone/>
-                      </a:pPr>
-                      <a:r>
-                        <a:rPr b="1"/>
-                        <a:t>Runtime Governance</a:t>
-                      </a:r>
-                    </a:p>
-                  </a:txBody>
-                </a:tc>
-                <a:tc>
-                  <a:txBody>
-                    <a:bodyPr/>
-                    <a:lstStyle/>
-                    <a:p>
-                      <a:pPr lvl="0" indent="0" marL="0">
-                        <a:buNone/>
-                      </a:pPr>
-                      <a:r>
-                        <a:rPr/>
-                        <a:t>✅ Yes</a:t>
-                      </a:r>
-                    </a:p>
-                  </a:txBody>
-                </a:tc>
-                <a:tc>
-                  <a:txBody>
-                    <a:bodyPr/>
-                    <a:lstStyle/>
-                    <a:p>
-                      <a:pPr lvl="0" indent="0" marL="0">
-                        <a:buNone/>
-                      </a:pPr>
-                      <a:r>
-                        <a:rPr/>
-                        <a:t>Polynomial</a:t>
-                      </a:r>
-                    </a:p>
-                  </a:txBody>
-                </a:tc>
-                <a:tc>
-                  <a:txBody>
-                    <a:bodyPr/>
-                    <a:lstStyle/>
-                    <a:p>
-                      <a:pPr lvl="0" indent="0" marL="0">
-                        <a:buNone/>
-                      </a:pPr>
-                      <a:r>
-                        <a:rPr/>
-                        <a:t>Framework</a:t>
-                      </a:r>
-                    </a:p>
-                  </a:txBody>
-                </a:tc>
-                <a:tc>
-                  <a:txBody>
-                    <a:bodyPr/>
-                    <a:lstStyle/>
-                    <a:p>
-                      <a:pPr lvl="0" indent="0" marL="0">
-                        <a:buNone/>
-                      </a:pPr>
-                      <a:r>
-                        <a:rPr/>
-                        <a:t>⚠️ Proposed</a:t>
-                      </a:r>
-                    </a:p>
-                  </a:txBody>
-                </a:tc>
-              </a:tr>
-              <a:tr h="0">
-                <a:tc>
-                  <a:txBody>
-                    <a:bodyPr/>
-                    <a:lstStyle/>
-                    <a:p>
-                      <a:pPr lvl="0" indent="0" marL="0">
-                        <a:buNone/>
-                      </a:pPr>
-                      <a:r>
-                        <a:rPr b="1"/>
-                        <a:t>AgentVerify</a:t>
-                      </a:r>
-                    </a:p>
-                  </a:txBody>
-                </a:tc>
-                <a:tc>
-                  <a:txBody>
-                    <a:bodyPr/>
-                    <a:lstStyle/>
-                    <a:p>
-                      <a:pPr lvl="0" indent="0" marL="0">
-                        <a:buNone/>
-                      </a:pPr>
-                      <a:r>
-                        <a:rPr/>
-                        <a:t>⚠️ Hybrid</a:t>
-                      </a:r>
-                    </a:p>
-                  </a:txBody>
-                </a:tc>
-                <a:tc>
-                  <a:txBody>
-                    <a:bodyPr/>
-                    <a:lstStyle/>
-                    <a:p>
-                      <a:pPr lvl="0" indent="0" marL="0">
-                        <a:buNone/>
-                      </a:pPr>
-                      <a:r>
-                        <a:rPr/>
-                        <a:t>O(1) monitor</a:t>
-                      </a:r>
-                    </a:p>
-                  </a:txBody>
-                </a:tc>
-                <a:tc>
-                  <a:txBody>
-                    <a:bodyPr/>
-                    <a:lstStyle/>
-                    <a:p>
-                      <a:pPr lvl="0" indent="0" marL="0">
-                        <a:buNone/>
-                      </a:pPr>
-                      <a:r>
-                        <a:rPr/>
-                        <a:t>LTL model checking</a:t>
-                      </a:r>
-                    </a:p>
-                  </a:txBody>
-                </a:tc>
-                <a:tc>
-                  <a:txBody>
-                    <a:bodyPr/>
-                    <a:lstStyle/>
-                    <a:p>
-                      <a:pPr lvl="0" indent="0" marL="0">
-                        <a:buNone/>
-                      </a:pPr>
-                      <a:r>
-                        <a:rPr/>
-                        <a:t>⚠️ Research</a:t>
-                      </a:r>
-                    </a:p>
-                  </a:txBody>
-                </a:tc>
-              </a:tr>
-              <a:tr h="0">
-                <a:tc>
-                  <a:txBody>
-                    <a:bodyPr/>
-                    <a:lstStyle/>
-                    <a:p>
-                      <a:pPr lvl="0" indent="0" marL="0">
-                        <a:buNone/>
-                      </a:pPr>
-                      <a:r>
-                        <a:rPr b="1"/>
-                        <a:t>SentinelAgent</a:t>
-                      </a:r>
-                    </a:p>
-                  </a:txBody>
-                </a:tc>
-                <a:tc>
-                  <a:txBody>
-                    <a:bodyPr/>
-                    <a:lstStyle/>
-                    <a:p>
-                      <a:pPr lvl="0" indent="0" marL="0">
-                        <a:buNone/>
-                      </a:pPr>
-                      <a:r>
-                        <a:rPr/>
-                        <a:t>✅ Yes</a:t>
-                      </a:r>
-                    </a:p>
-                  </a:txBody>
-                </a:tc>
-                <a:tc>
-                  <a:txBody>
-                    <a:bodyPr/>
-                    <a:lstStyle/>
-                    <a:p>
-                      <a:pPr lvl="0" indent="0" marL="0">
-                        <a:buNone/>
-                      </a:pPr>
-                      <a:r>
-                        <a:rPr/>
-                        <a:t>—</a:t>
-                      </a:r>
-                    </a:p>
-                  </a:txBody>
-                </a:tc>
-                <a:tc>
-                  <a:txBody>
-                    <a:bodyPr/>
-                    <a:lstStyle/>
-                    <a:p>
-                      <a:pPr lvl="0" indent="0" marL="0">
-                        <a:buNone/>
-                      </a:pPr>
-                      <a:r>
-                        <a:rPr/>
-                        <a:t>TLA+ (2.7M states)</a:t>
-                      </a:r>
-                    </a:p>
-                  </a:txBody>
-                </a:tc>
-                <a:tc>
-                  <a:txBody>
-                    <a:bodyPr/>
-                    <a:lstStyle/>
-                    <a:p>
-                      <a:pPr lvl="0" indent="0" marL="0">
-                        <a:buNone/>
-                      </a:pPr>
-                      <a:r>
-                        <a:rPr/>
-                        <a:t>⚠️ Research</a:t>
-                      </a:r>
-                    </a:p>
-                  </a:txBody>
-                </a:tc>
-              </a:tr>
-              <a:tr h="0">
-                <a:tc>
-                  <a:txBody>
-                    <a:bodyPr/>
-                    <a:lstStyle/>
-                    <a:p>
-                      <a:pPr lvl="0" indent="0" marL="0">
-                        <a:buNone/>
-                      </a:pPr>
-                      <a:r>
-                        <a:rPr b="1"/>
-                        <a:t>Trace-Based Assurance</a:t>
-                      </a:r>
-                    </a:p>
-                  </a:txBody>
-                </a:tc>
-                <a:tc>
-                  <a:txBody>
-                    <a:bodyPr/>
-                    <a:lstStyle/>
-                    <a:p>
-                      <a:pPr lvl="0" indent="0" marL="0">
-                        <a:buNone/>
-                      </a:pPr>
-                      <a:r>
-                        <a:rPr/>
-                        <a:t>✅ Yes</a:t>
-                      </a:r>
-                    </a:p>
-                  </a:txBody>
-                </a:tc>
-                <a:tc>
-                  <a:txBody>
-                    <a:bodyPr/>
-                    <a:lstStyle/>
-                    <a:p>
-                      <a:pPr lvl="0" indent="0" marL="0">
-                        <a:buNone/>
-                      </a:pPr>
-                      <a:r>
-                        <a:rPr/>
-                        <a:t>—</a:t>
-                      </a:r>
-                    </a:p>
-                  </a:txBody>
-                </a:tc>
-                <a:tc>
-                  <a:txBody>
-                    <a:bodyPr/>
-                    <a:lstStyle/>
-                    <a:p>
-                      <a:pPr lvl="0" indent="0" marL="0">
-                        <a:buNone/>
-                      </a:pPr>
-                      <a:r>
-                        <a:rPr/>
-                        <a:t>Replay-based</a:t>
-                      </a:r>
-                    </a:p>
-                  </a:txBody>
-                </a:tc>
-                <a:tc>
-                  <a:txBody>
-                    <a:bodyPr/>
-                    <a:lstStyle/>
-                    <a:p>
-                      <a:pPr lvl="0" indent="0" marL="0">
-                        <a:buNone/>
-                      </a:pPr>
-                      <a:r>
-                        <a:rPr/>
-                        <a:t>⚠️ Complex</a:t>
-                      </a:r>
-                    </a:p>
-                  </a:txBody>
-                </a:tc>
-              </a:tr>
-              <a:tr h="0">
-                <a:tc>
-                  <a:txBody>
-                    <a:bodyPr/>
-                    <a:lstStyle/>
-                    <a:p>
-                      <a:pPr lvl="0" indent="0" marL="0">
-                        <a:buNone/>
-                      </a:pPr>
-                      <a:r>
-                        <a:rPr b="1"/>
-                        <a:t>BeSafe-Bench</a:t>
-                      </a:r>
-                    </a:p>
-                  </a:txBody>
-                </a:tc>
-                <a:tc>
-                  <a:txBody>
-                    <a:bodyPr/>
-                    <a:lstStyle/>
-                    <a:p>
-                      <a:pPr lvl="0" indent="0" marL="0">
-                        <a:buNone/>
-                      </a:pPr>
-                      <a:r>
-                        <a:rPr/>
-                        <a:t>❌ No</a:t>
-                      </a:r>
-                    </a:p>
-                  </a:txBody>
-                </a:tc>
-                <a:tc>
-                  <a:txBody>
-                    <a:bodyPr/>
-                    <a:lstStyle/>
-                    <a:p>
-                      <a:pPr lvl="0" indent="0" marL="0">
-                        <a:buNone/>
-                      </a:pPr>
-                      <a:r>
-                        <a:rPr/>
-                        <a:t>—</a:t>
-                      </a:r>
-                    </a:p>
-                  </a:txBody>
-                </a:tc>
-                <a:tc>
-                  <a:txBody>
-                    <a:bodyPr/>
-                    <a:lstStyle/>
-                    <a:p>
-                      <a:pPr lvl="0" indent="0" marL="0">
-                        <a:buNone/>
-                      </a:pPr>
-                      <a:r>
-                        <a:rPr/>
-                        <a:t>—</a:t>
-                      </a:r>
-                    </a:p>
-                  </a:txBody>
-                </a:tc>
-                <a:tc>
-                  <a:txBody>
-                    <a:bodyPr/>
-                    <a:lstStyle/>
-                    <a:p>
-                      <a:pPr lvl="0" indent="0" marL="0">
-                        <a:buNone/>
-                      </a:pPr>
-                      <a:r>
-                        <a:rPr/>
-                        <a:t>✅ Benchmark</a:t>
-                      </a:r>
-                    </a:p>
-                  </a:txBody>
-                </a:tc>
-              </a:tr>
-              <a:tr h="0">
-                <a:tc>
-                  <a:txBody>
-                    <a:bodyPr/>
-                    <a:lstStyle/>
-                    <a:p>
-                      <a:pPr lvl="0" indent="0" marL="0">
-                        <a:buNone/>
-                      </a:pPr>
-                      <a:r>
-                        <a:rPr b="1"/>
-                        <a:t>ST-WebAgentBench</a:t>
-                      </a:r>
-                    </a:p>
-                  </a:txBody>
-                </a:tc>
-                <a:tc>
-                  <a:txBody>
-                    <a:bodyPr/>
-                    <a:lstStyle/>
-                    <a:p>
-                      <a:pPr lvl="0" indent="0" marL="0">
-                        <a:buNone/>
-                      </a:pPr>
-                      <a:r>
-                        <a:rPr/>
-                        <a:t>❌ No</a:t>
-                      </a:r>
-                    </a:p>
-                  </a:txBody>
-                </a:tc>
-                <a:tc>
-                  <a:txBody>
-                    <a:bodyPr/>
-                    <a:lstStyle/>
-                    <a:p>
-                      <a:pPr lvl="0" indent="0" marL="0">
-                        <a:buNone/>
-                      </a:pPr>
-                      <a:r>
-                        <a:rPr/>
-                        <a:t>—</a:t>
-                      </a:r>
-                    </a:p>
-                  </a:txBody>
-                </a:tc>
-                <a:tc>
-                  <a:txBody>
-                    <a:bodyPr/>
-                    <a:lstStyle/>
-                    <a:p>
-                      <a:pPr lvl="0" indent="0" marL="0">
-                        <a:buNone/>
-                      </a:pPr>
-                      <a:r>
-                        <a:rPr/>
-                        <a:t>—</a:t>
-                      </a:r>
-                    </a:p>
-                  </a:txBody>
-                </a:tc>
-                <a:tc>
-                  <a:txBody>
-                    <a:bodyPr/>
-                    <a:lstStyle/>
-                    <a:p>
-                      <a:pPr lvl="0" indent="0" marL="0">
-                        <a:buNone/>
-                      </a:pPr>
-                      <a:r>
-                        <a:rPr/>
-                        <a:t>✅ Benchmark</a:t>
-                      </a:r>
-                    </a:p>
-                  </a:txBody>
-                </a:tc>
-              </a:tr>
-            </a:tbl>
-          </a:graphicData>
-        </a:graphic>
-      </p:graphicFrame>
     </p:spTree>
   </p:cSld>
 </p:sld>
@@ -4817,7 +4195,1015 @@
             </a:pPr>
             <a:r>
               <a:rPr b="1"/>
-              <a:t>What Is Missing (The Gap)</a:t>
+              <a:t>Comparison: Deterministic vs LLM-as-Judge Runtime Checking</a:t>
+            </a:r>
+          </a:p>
+        </p:txBody>
+      </p:sp>
+      <p:graphicFrame>
+        <p:nvGraphicFramePr>
+          <p:cNvPr id="6" name="Content Placeholder 5"/>
+          <p:cNvGraphicFramePr>
+            <a:graphicFrameLocks noGrp="1"/>
+          </p:cNvGraphicFramePr>
+          <p:nvPr>
+            <p:ph idx="1"/>
+          </p:nvPr>
+        </p:nvGraphicFramePr>
+        <p:xfrm>
+          <a:off x="3568700" y="203200"/>
+          <a:ext cx="5105400" cy="4381500"/>
+        </p:xfrm>
+        <a:graphic>
+          <a:graphicData uri="http://schemas.openxmlformats.org/drawingml/2006/table">
+            <a:tbl>
+              <a:tblPr firstRow="1" bandRow="1">
+                <a:tableStyleId>{5C22544A-7EE6-4342-B048-85BDC9FD1C3A}</a:tableStyleId>
+              </a:tblPr>
+              <a:tblGrid>
+                <a:gridCol w="850900"/>
+                <a:gridCol w="850900"/>
+                <a:gridCol w="850900"/>
+                <a:gridCol w="850900"/>
+                <a:gridCol w="850900"/>
+                <a:gridCol w="850900"/>
+              </a:tblGrid>
+              <a:tr h="0">
+                <a:tc>
+                  <a:txBody>
+                    <a:bodyPr/>
+                    <a:lstStyle/>
+                    <a:p>
+                      <a:pPr lvl="0" indent="0" marL="0">
+                        <a:buNone/>
+                      </a:pPr>
+                      <a:r>
+                        <a:rPr/>
+                        <a:t>Mechanism</a:t>
+                      </a:r>
+                    </a:p>
+                  </a:txBody>
+                  <a:tcPr/>
+                </a:tc>
+                <a:tc>
+                  <a:txBody>
+                    <a:bodyPr/>
+                    <a:lstStyle/>
+                    <a:p>
+                      <a:pPr lvl="0" indent="0" marL="0">
+                        <a:buNone/>
+                      </a:pPr>
+                      <a:r>
+                        <a:rPr/>
+                        <a:t>Scope</a:t>
+                      </a:r>
+                    </a:p>
+                  </a:txBody>
+                  <a:tcPr/>
+                </a:tc>
+                <a:tc>
+                  <a:txBody>
+                    <a:bodyPr/>
+                    <a:lstStyle/>
+                    <a:p>
+                      <a:pPr lvl="0" indent="0" marL="0">
+                        <a:buNone/>
+                      </a:pPr>
+                      <a:r>
+                        <a:rPr/>
+                        <a:t>Deterministic?</a:t>
+                      </a:r>
+                    </a:p>
+                  </a:txBody>
+                  <a:tcPr/>
+                </a:tc>
+                <a:tc>
+                  <a:txBody>
+                    <a:bodyPr/>
+                    <a:lstStyle/>
+                    <a:p>
+                      <a:pPr lvl="0" indent="0" marL="0">
+                        <a:buNone/>
+                      </a:pPr>
+                      <a:r>
+                        <a:rPr/>
+                        <a:t>Speed</a:t>
+                      </a:r>
+                    </a:p>
+                  </a:txBody>
+                  <a:tcPr/>
+                </a:tc>
+                <a:tc>
+                  <a:txBody>
+                    <a:bodyPr/>
+                    <a:lstStyle/>
+                    <a:p>
+                      <a:pPr lvl="0" indent="0" marL="0">
+                        <a:buNone/>
+                      </a:pPr>
+                      <a:r>
+                        <a:rPr/>
+                        <a:t>Formal Verification</a:t>
+                      </a:r>
+                    </a:p>
+                  </a:txBody>
+                  <a:tcPr/>
+                </a:tc>
+                <a:tc>
+                  <a:txBody>
+                    <a:bodyPr/>
+                    <a:lstStyle/>
+                    <a:p>
+                      <a:pPr lvl="0" indent="0" marL="0">
+                        <a:buNone/>
+                      </a:pPr>
+                      <a:r>
+                        <a:rPr/>
+                        <a:t>Production Ready</a:t>
+                      </a:r>
+                    </a:p>
+                  </a:txBody>
+                  <a:tcPr/>
+                </a:tc>
+              </a:tr>
+              <a:tr h="0">
+                <a:tc>
+                  <a:txBody>
+                    <a:bodyPr/>
+                    <a:lstStyle/>
+                    <a:p>
+                      <a:pPr lvl="0" indent="0" marL="0">
+                        <a:buNone/>
+                      </a:pPr>
+                      <a:r>
+                        <a:rPr b="1"/>
+                        <a:t>ZipperGen</a:t>
+                      </a:r>
+                    </a:p>
+                  </a:txBody>
+                </a:tc>
+                <a:tc>
+                  <a:txBody>
+                    <a:bodyPr/>
+                    <a:lstStyle/>
+                    <a:p>
+                      <a:pPr lvl="0" indent="0" marL="0">
+                        <a:buNone/>
+                      </a:pPr>
+                      <a:r>
+                        <a:rPr b="1"/>
+                        <a:t>Multi-agent</a:t>
+                      </a:r>
+                    </a:p>
+                  </a:txBody>
+                </a:tc>
+                <a:tc>
+                  <a:txBody>
+                    <a:bodyPr/>
+                    <a:lstStyle/>
+                    <a:p>
+                      <a:pPr lvl="0" indent="0" marL="0">
+                        <a:buNone/>
+                      </a:pPr>
+                      <a:r>
+                        <a:rPr/>
+                        <a:t>✅ Yes (coordination structure)</a:t>
+                      </a:r>
+                    </a:p>
+                  </a:txBody>
+                </a:tc>
+                <a:tc>
+                  <a:txBody>
+                    <a:bodyPr/>
+                    <a:lstStyle/>
+                    <a:p>
+                      <a:pPr lvl="0" indent="0" marL="0">
+                        <a:buNone/>
+                      </a:pPr>
+                      <a:r>
+                        <a:rPr/>
+                        <a:t>—</a:t>
+                      </a:r>
+                    </a:p>
+                  </a:txBody>
+                </a:tc>
+                <a:tc>
+                  <a:txBody>
+                    <a:bodyPr/>
+                    <a:lstStyle/>
+                    <a:p>
+                      <a:pPr lvl="0" indent="0" marL="0">
+                        <a:buNone/>
+                      </a:pPr>
+                      <a:r>
+                        <a:rPr/>
+                        <a:t>Structural induction proof</a:t>
+                      </a:r>
+                    </a:p>
+                  </a:txBody>
+                </a:tc>
+                <a:tc>
+                  <a:txBody>
+                    <a:bodyPr/>
+                    <a:lstStyle/>
+                    <a:p>
+                      <a:pPr lvl="0" indent="0" marL="0">
+                        <a:buNone/>
+                      </a:pPr>
+                      <a:r>
+                        <a:rPr/>
+                        <a:t>✅ Python impl</a:t>
+                      </a:r>
+                    </a:p>
+                  </a:txBody>
+                </a:tc>
+              </a:tr>
+              <a:tr h="0">
+                <a:tc>
+                  <a:txBody>
+                    <a:bodyPr/>
+                    <a:lstStyle/>
+                    <a:p>
+                      <a:pPr lvl="0" indent="0" marL="0">
+                        <a:buNone/>
+                      </a:pPr>
+                      <a:r>
+                        <a:rPr b="1"/>
+                        <a:t>ACP</a:t>
+                      </a:r>
+                    </a:p>
+                  </a:txBody>
+                </a:tc>
+                <a:tc>
+                  <a:txBody>
+                    <a:bodyPr/>
+                    <a:lstStyle/>
+                    <a:p>
+                      <a:pPr lvl="0" indent="0" marL="0">
+                        <a:buNone/>
+                      </a:pPr>
+                      <a:r>
+                        <a:rPr/>
+                        <a:t>Single-agent</a:t>
+                      </a:r>
+                    </a:p>
+                  </a:txBody>
+                </a:tc>
+                <a:tc>
+                  <a:txBody>
+                    <a:bodyPr/>
+                    <a:lstStyle/>
+                    <a:p>
+                      <a:pPr lvl="0" indent="0" marL="0">
+                        <a:buNone/>
+                      </a:pPr>
+                      <a:r>
+                        <a:rPr/>
+                        <a:t>✅ Yes</a:t>
+                      </a:r>
+                    </a:p>
+                  </a:txBody>
+                </a:tc>
+                <a:tc>
+                  <a:txBody>
+                    <a:bodyPr/>
+                    <a:lstStyle/>
+                    <a:p>
+                      <a:pPr lvl="0" indent="0" marL="0">
+                        <a:buNone/>
+                      </a:pPr>
+                      <a:r>
+                        <a:rPr/>
+                        <a:t>739-832 ns</a:t>
+                      </a:r>
+                    </a:p>
+                  </a:txBody>
+                </a:tc>
+                <a:tc>
+                  <a:txBody>
+                    <a:bodyPr/>
+                    <a:lstStyle/>
+                    <a:p>
+                      <a:pPr lvl="0" indent="0" marL="0">
+                        <a:buNone/>
+                      </a:pPr>
+                      <a:r>
+                        <a:rPr/>
+                        <a:t>TLA+ (4.2B states)</a:t>
+                      </a:r>
+                    </a:p>
+                  </a:txBody>
+                </a:tc>
+                <a:tc>
+                  <a:txBody>
+                    <a:bodyPr/>
+                    <a:lstStyle/>
+                    <a:p>
+                      <a:pPr lvl="0" indent="0" marL="0">
+                        <a:buNone/>
+                      </a:pPr>
+                      <a:r>
+                        <a:rPr/>
+                        <a:t>✅ Go impl</a:t>
+                      </a:r>
+                    </a:p>
+                  </a:txBody>
+                </a:tc>
+              </a:tr>
+              <a:tr h="0">
+                <a:tc>
+                  <a:txBody>
+                    <a:bodyPr/>
+                    <a:lstStyle/>
+                    <a:p>
+                      <a:pPr lvl="0" indent="0" marL="0">
+                        <a:buNone/>
+                      </a:pPr>
+                      <a:r>
+                        <a:rPr b="1"/>
+                        <a:t>ABC / AgentAssert</a:t>
+                      </a:r>
+                    </a:p>
+                  </a:txBody>
+                </a:tc>
+                <a:tc>
+                  <a:txBody>
+                    <a:bodyPr/>
+                    <a:lstStyle/>
+                    <a:p>
+                      <a:pPr lvl="0" indent="0" marL="0">
+                        <a:buNone/>
+                      </a:pPr>
+                      <a:r>
+                        <a:rPr/>
+                        <a:t>Single-agent</a:t>
+                      </a:r>
+                    </a:p>
+                  </a:txBody>
+                </a:tc>
+                <a:tc>
+                  <a:txBody>
+                    <a:bodyPr/>
+                    <a:lstStyle/>
+                    <a:p>
+                      <a:pPr lvl="0" indent="0" marL="0">
+                        <a:buNone/>
+                      </a:pPr>
+                      <a:r>
+                        <a:rPr/>
+                        <a:t>✅ Mostly</a:t>
+                      </a:r>
+                    </a:p>
+                  </a:txBody>
+                </a:tc>
+                <a:tc>
+                  <a:txBody>
+                    <a:bodyPr/>
+                    <a:lstStyle/>
+                    <a:p>
+                      <a:pPr lvl="0" indent="0" marL="0">
+                        <a:buNone/>
+                      </a:pPr>
+                      <a:r>
+                        <a:rPr/>
+                        <a:t>&lt;10 ms</a:t>
+                      </a:r>
+                    </a:p>
+                  </a:txBody>
+                </a:tc>
+                <a:tc>
+                  <a:txBody>
+                    <a:bodyPr/>
+                    <a:lstStyle/>
+                    <a:p>
+                      <a:pPr lvl="0" indent="0" marL="0">
+                        <a:buNone/>
+                      </a:pPr>
+                      <a:r>
+                        <a:rPr/>
+                        <a:t>Drift Bounds Theorem</a:t>
+                      </a:r>
+                    </a:p>
+                  </a:txBody>
+                </a:tc>
+                <a:tc>
+                  <a:txBody>
+                    <a:bodyPr/>
+                    <a:lstStyle/>
+                    <a:p>
+                      <a:pPr lvl="0" indent="0" marL="0">
+                        <a:buNone/>
+                      </a:pPr>
+                      <a:r>
+                        <a:rPr/>
+                        <a:t>✅ Library</a:t>
+                      </a:r>
+                    </a:p>
+                  </a:txBody>
+                </a:tc>
+              </a:tr>
+              <a:tr h="0">
+                <a:tc>
+                  <a:txBody>
+                    <a:bodyPr/>
+                    <a:lstStyle/>
+                    <a:p>
+                      <a:pPr lvl="0" indent="0" marL="0">
+                        <a:buNone/>
+                      </a:pPr>
+                      <a:r>
+                        <a:rPr b="1"/>
+                        <a:t>Runtime Governance</a:t>
+                      </a:r>
+                    </a:p>
+                  </a:txBody>
+                </a:tc>
+                <a:tc>
+                  <a:txBody>
+                    <a:bodyPr/>
+                    <a:lstStyle/>
+                    <a:p>
+                      <a:pPr lvl="0" indent="0" marL="0">
+                        <a:buNone/>
+                      </a:pPr>
+                      <a:r>
+                        <a:rPr/>
+                        <a:t>Single-agent</a:t>
+                      </a:r>
+                    </a:p>
+                  </a:txBody>
+                </a:tc>
+                <a:tc>
+                  <a:txBody>
+                    <a:bodyPr/>
+                    <a:lstStyle/>
+                    <a:p>
+                      <a:pPr lvl="0" indent="0" marL="0">
+                        <a:buNone/>
+                      </a:pPr>
+                      <a:r>
+                        <a:rPr/>
+                        <a:t>✅ Yes</a:t>
+                      </a:r>
+                    </a:p>
+                  </a:txBody>
+                </a:tc>
+                <a:tc>
+                  <a:txBody>
+                    <a:bodyPr/>
+                    <a:lstStyle/>
+                    <a:p>
+                      <a:pPr lvl="0" indent="0" marL="0">
+                        <a:buNone/>
+                      </a:pPr>
+                      <a:r>
+                        <a:rPr/>
+                        <a:t>Polynomial</a:t>
+                      </a:r>
+                    </a:p>
+                  </a:txBody>
+                </a:tc>
+                <a:tc>
+                  <a:txBody>
+                    <a:bodyPr/>
+                    <a:lstStyle/>
+                    <a:p>
+                      <a:pPr lvl="0" indent="0" marL="0">
+                        <a:buNone/>
+                      </a:pPr>
+                      <a:r>
+                        <a:rPr/>
+                        <a:t>Framework</a:t>
+                      </a:r>
+                    </a:p>
+                  </a:txBody>
+                </a:tc>
+                <a:tc>
+                  <a:txBody>
+                    <a:bodyPr/>
+                    <a:lstStyle/>
+                    <a:p>
+                      <a:pPr lvl="0" indent="0" marL="0">
+                        <a:buNone/>
+                      </a:pPr>
+                      <a:r>
+                        <a:rPr/>
+                        <a:t>⚠️ Proposed</a:t>
+                      </a:r>
+                    </a:p>
+                  </a:txBody>
+                </a:tc>
+              </a:tr>
+              <a:tr h="0">
+                <a:tc>
+                  <a:txBody>
+                    <a:bodyPr/>
+                    <a:lstStyle/>
+                    <a:p>
+                      <a:pPr lvl="0" indent="0" marL="0">
+                        <a:buNone/>
+                      </a:pPr>
+                      <a:r>
+                        <a:rPr b="1"/>
+                        <a:t>AgentVerify</a:t>
+                      </a:r>
+                    </a:p>
+                  </a:txBody>
+                </a:tc>
+                <a:tc>
+                  <a:txBody>
+                    <a:bodyPr/>
+                    <a:lstStyle/>
+                    <a:p>
+                      <a:pPr lvl="0" indent="0" marL="0">
+                        <a:buNone/>
+                      </a:pPr>
+                      <a:r>
+                        <a:rPr/>
+                        <a:t>Single-agent</a:t>
+                      </a:r>
+                    </a:p>
+                  </a:txBody>
+                </a:tc>
+                <a:tc>
+                  <a:txBody>
+                    <a:bodyPr/>
+                    <a:lstStyle/>
+                    <a:p>
+                      <a:pPr lvl="0" indent="0" marL="0">
+                        <a:buNone/>
+                      </a:pPr>
+                      <a:r>
+                        <a:rPr/>
+                        <a:t>⚠️ Hybrid</a:t>
+                      </a:r>
+                    </a:p>
+                  </a:txBody>
+                </a:tc>
+                <a:tc>
+                  <a:txBody>
+                    <a:bodyPr/>
+                    <a:lstStyle/>
+                    <a:p>
+                      <a:pPr lvl="0" indent="0" marL="0">
+                        <a:buNone/>
+                      </a:pPr>
+                      <a:r>
+                        <a:rPr/>
+                        <a:t>O(1) monitor</a:t>
+                      </a:r>
+                    </a:p>
+                  </a:txBody>
+                </a:tc>
+                <a:tc>
+                  <a:txBody>
+                    <a:bodyPr/>
+                    <a:lstStyle/>
+                    <a:p>
+                      <a:pPr lvl="0" indent="0" marL="0">
+                        <a:buNone/>
+                      </a:pPr>
+                      <a:r>
+                        <a:rPr/>
+                        <a:t>LTL model checking</a:t>
+                      </a:r>
+                    </a:p>
+                  </a:txBody>
+                </a:tc>
+                <a:tc>
+                  <a:txBody>
+                    <a:bodyPr/>
+                    <a:lstStyle/>
+                    <a:p>
+                      <a:pPr lvl="0" indent="0" marL="0">
+                        <a:buNone/>
+                      </a:pPr>
+                      <a:r>
+                        <a:rPr/>
+                        <a:t>⚠️ Research</a:t>
+                      </a:r>
+                    </a:p>
+                  </a:txBody>
+                </a:tc>
+              </a:tr>
+              <a:tr h="0">
+                <a:tc>
+                  <a:txBody>
+                    <a:bodyPr/>
+                    <a:lstStyle/>
+                    <a:p>
+                      <a:pPr lvl="0" indent="0" marL="0">
+                        <a:buNone/>
+                      </a:pPr>
+                      <a:r>
+                        <a:rPr b="1"/>
+                        <a:t>SentinelAgent</a:t>
+                      </a:r>
+                    </a:p>
+                  </a:txBody>
+                </a:tc>
+                <a:tc>
+                  <a:txBody>
+                    <a:bodyPr/>
+                    <a:lstStyle/>
+                    <a:p>
+                      <a:pPr lvl="0" indent="0" marL="0">
+                        <a:buNone/>
+                      </a:pPr>
+                      <a:r>
+                        <a:rPr/>
+                        <a:t>Single-agent</a:t>
+                      </a:r>
+                    </a:p>
+                  </a:txBody>
+                </a:tc>
+                <a:tc>
+                  <a:txBody>
+                    <a:bodyPr/>
+                    <a:lstStyle/>
+                    <a:p>
+                      <a:pPr lvl="0" indent="0" marL="0">
+                        <a:buNone/>
+                      </a:pPr>
+                      <a:r>
+                        <a:rPr/>
+                        <a:t>✅ Yes</a:t>
+                      </a:r>
+                    </a:p>
+                  </a:txBody>
+                </a:tc>
+                <a:tc>
+                  <a:txBody>
+                    <a:bodyPr/>
+                    <a:lstStyle/>
+                    <a:p>
+                      <a:pPr lvl="0" indent="0" marL="0">
+                        <a:buNone/>
+                      </a:pPr>
+                      <a:r>
+                        <a:rPr/>
+                        <a:t>—</a:t>
+                      </a:r>
+                    </a:p>
+                  </a:txBody>
+                </a:tc>
+                <a:tc>
+                  <a:txBody>
+                    <a:bodyPr/>
+                    <a:lstStyle/>
+                    <a:p>
+                      <a:pPr lvl="0" indent="0" marL="0">
+                        <a:buNone/>
+                      </a:pPr>
+                      <a:r>
+                        <a:rPr/>
+                        <a:t>TLA+ (2.7M states)</a:t>
+                      </a:r>
+                    </a:p>
+                  </a:txBody>
+                </a:tc>
+                <a:tc>
+                  <a:txBody>
+                    <a:bodyPr/>
+                    <a:lstStyle/>
+                    <a:p>
+                      <a:pPr lvl="0" indent="0" marL="0">
+                        <a:buNone/>
+                      </a:pPr>
+                      <a:r>
+                        <a:rPr/>
+                        <a:t>⚠️ Research</a:t>
+                      </a:r>
+                    </a:p>
+                  </a:txBody>
+                </a:tc>
+              </a:tr>
+              <a:tr h="0">
+                <a:tc>
+                  <a:txBody>
+                    <a:bodyPr/>
+                    <a:lstStyle/>
+                    <a:p>
+                      <a:pPr lvl="0" indent="0" marL="0">
+                        <a:buNone/>
+                      </a:pPr>
+                      <a:r>
+                        <a:rPr b="1"/>
+                        <a:t>Trace-Based Assurance</a:t>
+                      </a:r>
+                    </a:p>
+                  </a:txBody>
+                </a:tc>
+                <a:tc>
+                  <a:txBody>
+                    <a:bodyPr/>
+                    <a:lstStyle/>
+                    <a:p>
+                      <a:pPr lvl="0" indent="0" marL="0">
+                        <a:buNone/>
+                      </a:pPr>
+                      <a:r>
+                        <a:rPr/>
+                        <a:t>Single-agent</a:t>
+                      </a:r>
+                    </a:p>
+                  </a:txBody>
+                </a:tc>
+                <a:tc>
+                  <a:txBody>
+                    <a:bodyPr/>
+                    <a:lstStyle/>
+                    <a:p>
+                      <a:pPr lvl="0" indent="0" marL="0">
+                        <a:buNone/>
+                      </a:pPr>
+                      <a:r>
+                        <a:rPr/>
+                        <a:t>✅ Yes</a:t>
+                      </a:r>
+                    </a:p>
+                  </a:txBody>
+                </a:tc>
+                <a:tc>
+                  <a:txBody>
+                    <a:bodyPr/>
+                    <a:lstStyle/>
+                    <a:p>
+                      <a:pPr lvl="0" indent="0" marL="0">
+                        <a:buNone/>
+                      </a:pPr>
+                      <a:r>
+                        <a:rPr/>
+                        <a:t>—</a:t>
+                      </a:r>
+                    </a:p>
+                  </a:txBody>
+                </a:tc>
+                <a:tc>
+                  <a:txBody>
+                    <a:bodyPr/>
+                    <a:lstStyle/>
+                    <a:p>
+                      <a:pPr lvl="0" indent="0" marL="0">
+                        <a:buNone/>
+                      </a:pPr>
+                      <a:r>
+                        <a:rPr/>
+                        <a:t>Replay-based</a:t>
+                      </a:r>
+                    </a:p>
+                  </a:txBody>
+                </a:tc>
+                <a:tc>
+                  <a:txBody>
+                    <a:bodyPr/>
+                    <a:lstStyle/>
+                    <a:p>
+                      <a:pPr lvl="0" indent="0" marL="0">
+                        <a:buNone/>
+                      </a:pPr>
+                      <a:r>
+                        <a:rPr/>
+                        <a:t>⚠️ Complex</a:t>
+                      </a:r>
+                    </a:p>
+                  </a:txBody>
+                </a:tc>
+              </a:tr>
+              <a:tr h="0">
+                <a:tc>
+                  <a:txBody>
+                    <a:bodyPr/>
+                    <a:lstStyle/>
+                    <a:p>
+                      <a:pPr lvl="0" indent="0" marL="0">
+                        <a:buNone/>
+                      </a:pPr>
+                      <a:r>
+                        <a:rPr b="1"/>
+                        <a:t>BeSafe-Bench</a:t>
+                      </a:r>
+                    </a:p>
+                  </a:txBody>
+                </a:tc>
+                <a:tc>
+                  <a:txBody>
+                    <a:bodyPr/>
+                    <a:lstStyle/>
+                    <a:p>
+                      <a:pPr lvl="0" indent="0" marL="0">
+                        <a:buNone/>
+                      </a:pPr>
+                      <a:r>
+                        <a:rPr/>
+                        <a:t>Benchmark</a:t>
+                      </a:r>
+                    </a:p>
+                  </a:txBody>
+                </a:tc>
+                <a:tc>
+                  <a:txBody>
+                    <a:bodyPr/>
+                    <a:lstStyle/>
+                    <a:p>
+                      <a:pPr lvl="0" indent="0" marL="0">
+                        <a:buNone/>
+                      </a:pPr>
+                      <a:r>
+                        <a:rPr/>
+                        <a:t>❌ No</a:t>
+                      </a:r>
+                    </a:p>
+                  </a:txBody>
+                </a:tc>
+                <a:tc>
+                  <a:txBody>
+                    <a:bodyPr/>
+                    <a:lstStyle/>
+                    <a:p>
+                      <a:pPr lvl="0" indent="0" marL="0">
+                        <a:buNone/>
+                      </a:pPr>
+                      <a:r>
+                        <a:rPr/>
+                        <a:t>—</a:t>
+                      </a:r>
+                    </a:p>
+                  </a:txBody>
+                </a:tc>
+                <a:tc>
+                  <a:txBody>
+                    <a:bodyPr/>
+                    <a:lstStyle/>
+                    <a:p>
+                      <a:pPr lvl="0" indent="0" marL="0">
+                        <a:buNone/>
+                      </a:pPr>
+                      <a:r>
+                        <a:rPr/>
+                        <a:t>—</a:t>
+                      </a:r>
+                    </a:p>
+                  </a:txBody>
+                </a:tc>
+                <a:tc>
+                  <a:txBody>
+                    <a:bodyPr/>
+                    <a:lstStyle/>
+                    <a:p>
+                      <a:pPr lvl="0" indent="0" marL="0">
+                        <a:buNone/>
+                      </a:pPr>
+                      <a:r>
+                        <a:rPr/>
+                        <a:t>✅ Benchmark</a:t>
+                      </a:r>
+                    </a:p>
+                  </a:txBody>
+                </a:tc>
+              </a:tr>
+              <a:tr h="0">
+                <a:tc>
+                  <a:txBody>
+                    <a:bodyPr/>
+                    <a:lstStyle/>
+                    <a:p>
+                      <a:pPr lvl="0" indent="0" marL="0">
+                        <a:buNone/>
+                      </a:pPr>
+                      <a:r>
+                        <a:rPr b="1"/>
+                        <a:t>ST-WebAgentBench</a:t>
+                      </a:r>
+                    </a:p>
+                  </a:txBody>
+                </a:tc>
+                <a:tc>
+                  <a:txBody>
+                    <a:bodyPr/>
+                    <a:lstStyle/>
+                    <a:p>
+                      <a:pPr lvl="0" indent="0" marL="0">
+                        <a:buNone/>
+                      </a:pPr>
+                      <a:r>
+                        <a:rPr/>
+                        <a:t>Benchmark</a:t>
+                      </a:r>
+                    </a:p>
+                  </a:txBody>
+                </a:tc>
+                <a:tc>
+                  <a:txBody>
+                    <a:bodyPr/>
+                    <a:lstStyle/>
+                    <a:p>
+                      <a:pPr lvl="0" indent="0" marL="0">
+                        <a:buNone/>
+                      </a:pPr>
+                      <a:r>
+                        <a:rPr/>
+                        <a:t>❌ No</a:t>
+                      </a:r>
+                    </a:p>
+                  </a:txBody>
+                </a:tc>
+                <a:tc>
+                  <a:txBody>
+                    <a:bodyPr/>
+                    <a:lstStyle/>
+                    <a:p>
+                      <a:pPr lvl="0" indent="0" marL="0">
+                        <a:buNone/>
+                      </a:pPr>
+                      <a:r>
+                        <a:rPr/>
+                        <a:t>—</a:t>
+                      </a:r>
+                    </a:p>
+                  </a:txBody>
+                </a:tc>
+                <a:tc>
+                  <a:txBody>
+                    <a:bodyPr/>
+                    <a:lstStyle/>
+                    <a:p>
+                      <a:pPr lvl="0" indent="0" marL="0">
+                        <a:buNone/>
+                      </a:pPr>
+                      <a:r>
+                        <a:rPr/>
+                        <a:t>—</a:t>
+                      </a:r>
+                    </a:p>
+                  </a:txBody>
+                </a:tc>
+                <a:tc>
+                  <a:txBody>
+                    <a:bodyPr/>
+                    <a:lstStyle/>
+                    <a:p>
+                      <a:pPr lvl="0" indent="0" marL="0">
+                        <a:buNone/>
+                      </a:pPr>
+                      <a:r>
+                        <a:rPr/>
+                        <a:t>✅ Benchmark</a:t>
+                      </a:r>
+                    </a:p>
+                  </a:txBody>
+                </a:tc>
+              </a:tr>
+            </a:tbl>
+          </a:graphicData>
+        </a:graphic>
+      </p:graphicFrame>
+    </p:spTree>
+  </p:cSld>
+</p:sld>
+</file>
+
+<file path=ppt/slides/slide16.xml><?xml version="1.0" encoding="utf-8"?>
+<p:sld xmlns:a="http://schemas.openxmlformats.org/drawingml/2006/main" xmlns:r="http://schemas.openxmlformats.org/officeDocument/2006/relationships" xmlns:p="http://schemas.openxmlformats.org/presentationml/2006/main">
+  <p:cSld>
+    <p:spTree>
+      <p:nvGrpSpPr>
+        <p:cNvPr id="1" name=""/>
+        <p:cNvGrpSpPr/>
+        <p:nvPr/>
+      </p:nvGrpSpPr>
+      <p:grpSpPr>
+        <a:xfrm>
+          <a:off x="0" y="0"/>
+          <a:ext cx="0" cy="0"/>
+          <a:chOff x="0" y="0"/>
+          <a:chExt cx="0" cy="0"/>
+        </a:xfrm>
+      </p:grpSpPr>
+      <p:sp>
+        <p:nvSpPr>
+          <p:cNvPr id="4" name="Text Placeholder 3"/>
+          <p:cNvSpPr>
+            <a:spLocks noGrp="1"/>
+          </p:cNvSpPr>
+          <p:nvPr>
+            <p:ph idx="2" sz="half" type="body"/>
+          </p:nvPr>
+        </p:nvSpPr>
+        <p:spPr/>
+        <p:txBody>
+          <a:bodyPr/>
+          <a:lstStyle/>
+          <a:p>
+            <a:pPr lvl="0" indent="0" marL="0">
+              <a:spcBef>
+                <a:spcPts val="3000"/>
+              </a:spcBef>
+              <a:buNone/>
+            </a:pPr>
+            <a:r>
+              <a:rPr b="1"/>
+              <a:t>What Is Missing (The Gap) — UPDATED with ZipperGen</a:t>
             </a:r>
           </a:p>
         </p:txBody>
@@ -4938,7 +5324,7 @@
                       </a:pPr>
                       <a:r>
                         <a:rPr/>
-                        <a:t>ABC, ACP, Runtime Governance</a:t>
+                        <a:t>ABC, ACP, Runtime Governance (single-agent)</a:t>
                       </a:r>
                     </a:p>
                   </a:txBody>
@@ -4955,7 +5341,7 @@
                       </a:pPr>
                       <a:r>
                         <a:rPr b="1"/>
-                        <a:t>Sub-microsecond enforcement</a:t>
+                        <a:t>Deterministic multi-agent coordination enforcement</a:t>
                       </a:r>
                     </a:p>
                   </a:txBody>
@@ -4984,8 +5370,12 @@
                         <a:buNone/>
                       </a:pPr>
                       <a:r>
-                        <a:rPr/>
-                        <a:t>ACP (739-832 ns)</a:t>
+                        <a:rPr b="1"/>
+                        <a:t>ZipperGen</a:t>
+                      </a:r>
+                      <a:r>
+                        <a:rPr/>
+                        <a:t> — message structure guaranteed correct; action content remains opaque</a:t>
                       </a:r>
                     </a:p>
                   </a:txBody>
@@ -5002,7 +5392,7 @@
                       </a:pPr>
                       <a:r>
                         <a:rPr b="1"/>
-                        <a:t>Formally verified runtime</a:t>
+                        <a:t>Sub-microsecond enforcement</a:t>
                       </a:r>
                     </a:p>
                   </a:txBody>
@@ -5032,7 +5422,7 @@
                       </a:pPr>
                       <a:r>
                         <a:rPr/>
-                        <a:t>ACP (TLA+), SentinelAgent (TLA+)</a:t>
+                        <a:t>ACP (739-832 ns)</a:t>
                       </a:r>
                     </a:p>
                   </a:txBody>
@@ -5049,37 +5439,37 @@
                       </a:pPr>
                       <a:r>
                         <a:rPr b="1"/>
-                        <a:t>MPST-style session type enforcement</a:t>
-                      </a:r>
-                    </a:p>
-                  </a:txBody>
-                </a:tc>
-                <a:tc>
-                  <a:txBody>
-                    <a:bodyPr/>
-                    <a:lstStyle/>
-                    <a:p>
-                      <a:pPr lvl="0" indent="0" marL="0">
-                        <a:buNone/>
-                      </a:pPr>
-                      <a:r>
-                        <a:rPr/>
-                        <a:t>❌ No</a:t>
-                      </a:r>
-                    </a:p>
-                  </a:txBody>
-                </a:tc>
-                <a:tc>
-                  <a:txBody>
-                    <a:bodyPr/>
-                    <a:lstStyle/>
-                    <a:p>
-                      <a:pPr lvl="0" indent="0" marL="0">
-                        <a:buNone/>
-                      </a:pPr>
-                      <a:r>
-                        <a:rPr/>
-                        <a:t>No multi-party session type checking at runtime</a:t>
+                        <a:t>Formally verified runtime</a:t>
+                      </a:r>
+                    </a:p>
+                  </a:txBody>
+                </a:tc>
+                <a:tc>
+                  <a:txBody>
+                    <a:bodyPr/>
+                    <a:lstStyle/>
+                    <a:p>
+                      <a:pPr lvl="0" indent="0" marL="0">
+                        <a:buNone/>
+                      </a:pPr>
+                      <a:r>
+                        <a:rPr/>
+                        <a:t>✅ Yes</a:t>
+                      </a:r>
+                    </a:p>
+                  </a:txBody>
+                </a:tc>
+                <a:tc>
+                  <a:txBody>
+                    <a:bodyPr/>
+                    <a:lstStyle/>
+                    <a:p>
+                      <a:pPr lvl="0" indent="0" marL="0">
+                        <a:buNone/>
+                      </a:pPr>
+                      <a:r>
+                        <a:rPr/>
+                        <a:t>ACP (TLA+), SentinelAgent (TLA+), ZipperGen (structural induction)</a:t>
                       </a:r>
                     </a:p>
                   </a:txBody>
@@ -5096,6 +5486,104 @@
                       </a:pPr>
                       <a:r>
                         <a:rPr b="1"/>
+                        <a:t>MPST-style session type enforcement</a:t>
+                      </a:r>
+                    </a:p>
+                  </a:txBody>
+                </a:tc>
+                <a:tc>
+                  <a:txBody>
+                    <a:bodyPr/>
+                    <a:lstStyle/>
+                    <a:p>
+                      <a:pPr lvl="0" indent="0" marL="0">
+                        <a:buNone/>
+                      </a:pPr>
+                      <a:r>
+                        <a:rPr/>
+                        <a:t>✅ Yes</a:t>
+                      </a:r>
+                    </a:p>
+                  </a:txBody>
+                </a:tc>
+                <a:tc>
+                  <a:txBody>
+                    <a:bodyPr/>
+                    <a:lstStyle/>
+                    <a:p>
+                      <a:pPr lvl="0" indent="0" marL="0">
+                        <a:buNone/>
+                      </a:pPr>
+                      <a:r>
+                        <a:rPr b="1"/>
+                        <a:t>ZipperGen</a:t>
+                      </a:r>
+                      <a:r>
+                        <a:rPr/>
+                        <a:t> — MSC-based DSL with syntax-directed projection</a:t>
+                      </a:r>
+                    </a:p>
+                  </a:txBody>
+                </a:tc>
+              </a:tr>
+              <a:tr h="0">
+                <a:tc>
+                  <a:txBody>
+                    <a:bodyPr/>
+                    <a:lstStyle/>
+                    <a:p>
+                      <a:pPr lvl="0" indent="0" marL="0">
+                        <a:buNone/>
+                      </a:pPr>
+                      <a:r>
+                        <a:rPr b="1"/>
+                        <a:t>Behavioral typing of message content</a:t>
+                      </a:r>
+                    </a:p>
+                  </a:txBody>
+                </a:tc>
+                <a:tc>
+                  <a:txBody>
+                    <a:bodyPr/>
+                    <a:lstStyle/>
+                    <a:p>
+                      <a:pPr lvl="0" indent="0" marL="0">
+                        <a:buNone/>
+                      </a:pPr>
+                      <a:r>
+                        <a:rPr/>
+                        <a:t>❌ No</a:t>
+                      </a:r>
+                    </a:p>
+                  </a:txBody>
+                </a:tc>
+                <a:tc>
+                  <a:txBody>
+                    <a:bodyPr/>
+                    <a:lstStyle/>
+                    <a:p>
+                      <a:pPr lvl="0" indent="0" marL="0">
+                        <a:buNone/>
+                      </a:pPr>
+                      <a:r>
+                        <a:rPr/>
+                        <a:t>ZipperGen checks structure, not what LLMs put inside messages</a:t>
+                      </a:r>
+                    </a:p>
+                  </a:txBody>
+                </a:tc>
+              </a:tr>
+              <a:tr h="0">
+                <a:tc>
+                  <a:txBody>
+                    <a:bodyPr/>
+                    <a:lstStyle/>
+                    <a:p>
+                      <a:pPr lvl="0" indent="0" marL="0">
+                        <a:buNone/>
+                      </a:pPr>
+                      <a:r>
+                        <a:rPr b="1"/>
                         <a:t>Deterministic skill composition verification</a:t>
                       </a:r>
                     </a:p>
@@ -5126,7 +5614,7 @@
                       </a:pPr>
                       <a:r>
                         <a:rPr/>
-                        <a:t>No runtime checking that composed skills preserve invariants</a:t>
+                        <a:t>No static analysis of how multiple skills compose within a single agent</a:t>
                       </a:r>
                     </a:p>
                   </a:txBody>
@@ -5235,7 +5723,7 @@
 </p:sld>
 </file>
 
-<file path=ppt/slides/slide16.xml><?xml version="1.0" encoding="utf-8"?>
+<file path=ppt/slides/slide17.xml><?xml version="1.0" encoding="utf-8"?>
 <p:sld xmlns:a="http://schemas.openxmlformats.org/drawingml/2006/main" xmlns:r="http://schemas.openxmlformats.org/officeDocument/2006/relationships" xmlns:p="http://schemas.openxmlformats.org/presentationml/2006/main">
   <p:cSld>
     <p:spTree>
@@ -5284,7 +5772,7 @@
             </a:pPr>
             <a:r>
               <a:rPr sz="2000" b="1"/>
-              <a:t>Deterministic runtime enforcement exists and is production-ready (ACP, ABC/AgentAssert). These are not LLM-as-judge — they use formal risk scoring, temporal logic, and contract enforcement. The fastest (ACP) is sub-microsecond with TLA+ formal verification. However, MPST-style multi-party session type enforcement and automatic rollback are still research gaps.</a:t>
+              <a:t>Deterministic runtime enforcement exists at both single-agent (ACP, ABC/AgentAssert) and multi-agent (ZipperGen) levels. ZipperGen is the breakthrough: it guarantees deadlock-free coordination regardless of LLM nondeterminism, by separating deterministic message structure (enforced) from stochastic actions (opaque). The remaining gap is not “does MPST exist for agents?” — it does — but “can we type-check the content of LLM actions within that structure?”</a:t>
             </a:r>
           </a:p>
         </p:txBody>
@@ -5294,7 +5782,7 @@
 </p:sld>
 </file>
 
-<file path=ppt/slides/slide17.xml><?xml version="1.0" encoding="utf-8"?>
+<file path=ppt/slides/slide18.xml><?xml version="1.0" encoding="utf-8"?>
 <p:sld xmlns:a="http://schemas.openxmlformats.org/drawingml/2006/main" xmlns:r="http://schemas.openxmlformats.org/officeDocument/2006/relationships" xmlns:p="http://schemas.openxmlformats.org/presentationml/2006/main">
   <p:cSld>
     <p:spTree>
@@ -5436,7 +5924,7 @@
                       </a:pPr>
                       <a:r>
                         <a:rPr/>
-                        <a:t>Gap</a:t>
+                        <a:t>What ZipperGen Changes</a:t>
                       </a:r>
                     </a:p>
                   </a:txBody>
@@ -5499,7 +5987,7 @@
                       </a:pPr>
                       <a:r>
                         <a:rPr/>
-                        <a:t>No formal guarantee without L3 enforcement</a:t>
+                        <a:t>ZipperGen does not directly address this, but its runtime planning extension shows LLMs can generate coordination structures that are formally guaranteed</a:t>
                       </a:r>
                     </a:p>
                   </a:txBody>
@@ -5531,37 +6019,45 @@
                       </a:pPr>
                       <a:r>
                         <a:rPr/>
-                        <a:t>⚠️ Partial</a:t>
-                      </a:r>
-                    </a:p>
-                  </a:txBody>
-                </a:tc>
-                <a:tc>
-                  <a:txBody>
-                    <a:bodyPr/>
-                    <a:lstStyle/>
-                    <a:p>
-                      <a:pPr lvl="0" indent="0" marL="0">
-                        <a:buNone/>
-                      </a:pPr>
-                      <a:r>
-                        <a:rPr/>
-                        <a:t>SkillFortify, SkCC, GovernSpec</a:t>
-                      </a:r>
-                    </a:p>
-                  </a:txBody>
-                </a:tc>
-                <a:tc>
-                  <a:txBody>
-                    <a:bodyPr/>
-                    <a:lstStyle/>
-                    <a:p>
-                      <a:pPr lvl="0" indent="0" marL="0">
-                        <a:buNone/>
-                      </a:pPr>
-                      <a:r>
-                        <a:rPr/>
-                        <a:t>No formal type system for NL skills; no MPST static checking</a:t>
+                        <a:t>✅ Yes for multi-agent</a:t>
+                      </a:r>
+                    </a:p>
+                  </a:txBody>
+                </a:tc>
+                <a:tc>
+                  <a:txBody>
+                    <a:bodyPr/>
+                    <a:lstStyle/>
+                    <a:p>
+                      <a:pPr lvl="0" indent="0" marL="0">
+                        <a:buNone/>
+                      </a:pPr>
+                      <a:r>
+                        <a:rPr b="1"/>
+                        <a:t>ZipperGen</a:t>
+                      </a:r>
+                      <a:r>
+                        <a:rPr/>
+                        <a:t> — formal well-typedness checks, deadlock-free by construction</a:t>
+                      </a:r>
+                    </a:p>
+                  </a:txBody>
+                </a:tc>
+                <a:tc>
+                  <a:txBody>
+                    <a:bodyPr/>
+                    <a:lstStyle/>
+                    <a:p>
+                      <a:pPr lvl="0" indent="0" marL="0">
+                        <a:buNone/>
+                      </a:pPr>
+                      <a:r>
+                        <a:rPr b="1"/>
+                        <a:t>Closes the MPST gap:</a:t>
+                      </a:r>
+                      <a:r>
+                        <a:rPr/>
+                        <a:t> formal global specs + deterministic local projection</a:t>
                       </a:r>
                     </a:p>
                   </a:txBody>
@@ -5593,37 +6089,45 @@
                       </a:pPr>
                       <a:r>
                         <a:rPr/>
-                        <a:t>✅ Yes</a:t>
-                      </a:r>
-                    </a:p>
-                  </a:txBody>
-                </a:tc>
-                <a:tc>
-                  <a:txBody>
-                    <a:bodyPr/>
-                    <a:lstStyle/>
-                    <a:p>
-                      <a:pPr lvl="0" indent="0" marL="0">
-                        <a:buNone/>
-                      </a:pPr>
-                      <a:r>
-                        <a:rPr/>
-                        <a:t>ACP, ABC/AgentAssert, Runtime Governance</a:t>
-                      </a:r>
-                    </a:p>
-                  </a:txBody>
-                </a:tc>
-                <a:tc>
-                  <a:txBody>
-                    <a:bodyPr/>
-                    <a:lstStyle/>
-                    <a:p>
-                      <a:pPr lvl="0" indent="0" marL="0">
-                        <a:buNone/>
-                      </a:pPr>
-                      <a:r>
-                        <a:rPr/>
-                        <a:t>No MPST runtime enforcement; no automatic rollback</a:t>
+                        <a:t>✅ Yes for multi-agent</a:t>
+                      </a:r>
+                    </a:p>
+                  </a:txBody>
+                </a:tc>
+                <a:tc>
+                  <a:txBody>
+                    <a:bodyPr/>
+                    <a:lstStyle/>
+                    <a:p>
+                      <a:pPr lvl="0" indent="0" marL="0">
+                        <a:buNone/>
+                      </a:pPr>
+                      <a:r>
+                        <a:rPr b="1"/>
+                        <a:t>ZipperGen</a:t>
+                      </a:r>
+                      <a:r>
+                        <a:rPr/>
+                        <a:t> — coordination structure enforced deterministically, independent of LLM nondeterminism</a:t>
+                      </a:r>
+                    </a:p>
+                  </a:txBody>
+                </a:tc>
+                <a:tc>
+                  <a:txBody>
+                    <a:bodyPr/>
+                    <a:lstStyle/>
+                    <a:p>
+                      <a:pPr lvl="0" indent="0" marL="0">
+                        <a:buNone/>
+                      </a:pPr>
+                      <a:r>
+                        <a:rPr b="1"/>
+                        <a:t>Closes the multi-agent gap:</a:t>
+                      </a:r>
+                      <a:r>
+                        <a:rPr/>
+                        <a:t> the only paper that guarantees correct multi-agent coordination regardless of LLM stochasticity</a:t>
                       </a:r>
                     </a:p>
                   </a:txBody>
@@ -5633,156 +6137,6 @@
           </a:graphicData>
         </a:graphic>
       </p:graphicFrame>
-    </p:spTree>
-  </p:cSld>
-</p:sld>
-</file>
-
-<file path=ppt/slides/slide18.xml><?xml version="1.0" encoding="utf-8"?>
-<p:sld xmlns:a="http://schemas.openxmlformats.org/drawingml/2006/main" xmlns:r="http://schemas.openxmlformats.org/officeDocument/2006/relationships" xmlns:p="http://schemas.openxmlformats.org/presentationml/2006/main">
-  <p:cSld>
-    <p:spTree>
-      <p:nvGrpSpPr>
-        <p:cNvPr id="1" name=""/>
-        <p:cNvGrpSpPr/>
-        <p:nvPr/>
-      </p:nvGrpSpPr>
-      <p:grpSpPr>
-        <a:xfrm>
-          <a:off x="0" y="0"/>
-          <a:ext cx="0" cy="0"/>
-          <a:chOff x="0" y="0"/>
-          <a:chExt cx="0" cy="0"/>
-        </a:xfrm>
-      </p:grpSpPr>
-      <p:sp>
-        <p:nvSpPr>
-          <p:cNvPr id="3" name="Content Placeholder 2"/>
-          <p:cNvSpPr>
-            <a:spLocks noGrp="1"/>
-          </p:cNvSpPr>
-          <p:nvPr>
-            <p:ph idx="1"/>
-          </p:nvPr>
-        </p:nvSpPr>
-        <p:spPr/>
-        <p:txBody>
-          <a:bodyPr/>
-          <a:lstStyle/>
-          <a:p>
-            <a:pPr lvl="0" indent="0" marL="0">
-              <a:spcBef>
-                <a:spcPts val="3000"/>
-              </a:spcBef>
-              <a:buNone/>
-            </a:pPr>
-            <a:r>
-              <a:rPr b="1"/>
-              <a:t>The MPST Opportunity</a:t>
-            </a:r>
-          </a:p>
-          <a:p>
-            <a:pPr lvl="0" indent="0" marL="0">
-              <a:buNone/>
-            </a:pPr>
-            <a:r>
-              <a:rPr/>
-              <a:t>Your intuition is correct: </a:t>
-            </a:r>
-            <a:r>
-              <a:rPr b="1"/>
-              <a:t>the gap is at the intersection of all three.</a:t>
-            </a:r>
-          </a:p>
-          <a:p>
-            <a:pPr lvl="0" indent="0" marL="0">
-              <a:buNone/>
-            </a:pPr>
-            <a:r>
-              <a:rPr/>
-              <a:t>What doesn’t exist yet: - </a:t>
-            </a:r>
-            <a:r>
-              <a:rPr b="1"/>
-              <a:t>Static:</a:t>
-            </a:r>
-            <a:r>
-              <a:rPr/>
-              <a:t> MPST session types for multi-agent skill interactions, checked before runtime - </a:t>
-            </a:r>
-            <a:r>
-              <a:rPr b="1"/>
-              <a:t>Runtime:</a:t>
-            </a:r>
-            <a:r>
-              <a:rPr/>
-              <a:t> Deterministic enforcement of MPST protocols with blame assignment and rollback - </a:t>
-            </a:r>
-            <a:r>
-              <a:rPr b="1"/>
-              <a:t>Behavioral guarantee:</a:t>
-            </a:r>
-            <a:r>
-              <a:rPr/>
-              <a:t> Proof that if all agents follow the protocol, global invariants hold</a:t>
-            </a:r>
-          </a:p>
-          <a:p>
-            <a:pPr lvl="0" indent="0" marL="0">
-              <a:buNone/>
-            </a:pPr>
-            <a:r>
-              <a:rPr/>
-              <a:t>The closest existing work: - </a:t>
-            </a:r>
-            <a:r>
-              <a:rPr b="1"/>
-              <a:t>ACP</a:t>
-            </a:r>
-            <a:r>
-              <a:rPr/>
-              <a:t> — fast, formally verified, temporal admission control (single agent) - </a:t>
-            </a:r>
-            <a:r>
-              <a:rPr b="1"/>
-              <a:t>ABC</a:t>
-            </a:r>
-            <a:r>
-              <a:rPr/>
-              <a:t> — behavioral contracts with probabilistic compliance (single agent) - </a:t>
-            </a:r>
-            <a:r>
-              <a:rPr b="1"/>
-              <a:t>SentinelAgent</a:t>
-            </a:r>
-            <a:r>
-              <a:rPr/>
-              <a:t> — formal delegation chain verification (multi-agent, but not general protocols) - </a:t>
-            </a:r>
-            <a:r>
-              <a:rPr b="1"/>
-              <a:t>Runtime Governance</a:t>
-            </a:r>
-            <a:r>
-              <a:rPr/>
-              <a:t> — temporal predicates on paths (expressive, but not yet multi-agent)</a:t>
-            </a:r>
-          </a:p>
-          <a:p>
-            <a:pPr lvl="0" indent="0" marL="0">
-              <a:buNone/>
-            </a:pPr>
-            <a:r>
-              <a:rPr b="1"/>
-              <a:t>The research opportunity:</a:t>
-            </a:r>
-            <a:r>
-              <a:rPr/>
-              <a:t> Extend MPST to the agent skill domain — static session type checking for skill composition, plus deterministic runtime enforcement with sub-microsecond overhead and formal verification.</a:t>
-            </a:r>
-          </a:p>
-        </p:txBody>
-      </p:sp>
     </p:spTree>
   </p:cSld>
 </p:sld>
@@ -5821,11 +6175,273 @@
           <a:lstStyle/>
           <a:p>
             <a:pPr lvl="0" indent="0" marL="0">
+              <a:spcBef>
+                <a:spcPts val="3000"/>
+              </a:spcBef>
               <a:buNone/>
             </a:pPr>
             <a:r>
+              <a:rPr b="1"/>
+              <a:t>The MPST Opportunity — REVISED</a:t>
+            </a:r>
+          </a:p>
+          <a:p>
+            <a:pPr lvl="0" indent="0" marL="0">
+              <a:buNone/>
+            </a:pPr>
+            <a:r>
+              <a:rPr b="1"/>
+              <a:t>The MPST gap is now partially closed by ZipperGen.</a:t>
+            </a:r>
+            <a:r>
+              <a:rPr/>
+              <a:t> Here is what exists and what remains:</a:t>
+            </a:r>
+          </a:p>
+          <a:p>
+            <a:pPr lvl="0" indent="0" marL="0">
+              <a:buNone/>
+            </a:pPr>
+            <a:r>
+              <a:rPr b="1"/>
+              <a:t>What ZipperGen provides (2026):</a:t>
+            </a:r>
+            <a:r>
+              <a:rPr/>
+              <a:t> - ✅ </a:t>
+            </a:r>
+            <a:r>
+              <a:rPr b="1"/>
+              <a:t>Formal global specifications</a:t>
+            </a:r>
+            <a:r>
+              <a:rPr/>
+              <a:t> for multi-agent coordination (MSC-based DSL) - ✅ </a:t>
+            </a:r>
+            <a:r>
+              <a:rPr b="1"/>
+              <a:t>Static well-typedness checking</a:t>
+            </a:r>
+            <a:r>
+              <a:rPr/>
+              <a:t> before runtime (payload matching, type correctness, control condition consistency) - ✅ </a:t>
+            </a:r>
+            <a:r>
+              <a:rPr b="1"/>
+              <a:t>Deadlock-free by construction</a:t>
+            </a:r>
+            <a:r>
+              <a:rPr/>
+              <a:t> — guaranteed via syntax-directed projection, not runtime detection - ✅ </a:t>
+            </a:r>
+            <a:r>
+              <a:rPr b="1"/>
+              <a:t>Runtime execution</a:t>
+            </a:r>
+            <a:r>
+              <a:rPr/>
+              <a:t> of projected local programs — deterministic finite-state programs, no LLM-as-judge for coordination - ✅ </a:t>
+            </a:r>
+            <a:r>
+              <a:rPr b="1"/>
+              <a:t>LLM runtime planning</a:t>
+            </a:r>
+            <a:r>
+              <a:rPr/>
+              <a:t> — an LLM can dynamically generate coordination workflows and the same guarantees apply - ✅ </a:t>
+            </a:r>
+            <a:r>
+              <a:rPr b="1"/>
+              <a:t>Open-source implementation</a:t>
+            </a:r>
+            <a:r>
+              <a:rPr/>
+              <a:t> — https://zippergen.io</a:t>
+            </a:r>
+          </a:p>
+          <a:p>
+            <a:pPr lvl="0" indent="0" marL="0">
+              <a:buNone/>
+            </a:pPr>
+            <a:r>
+              <a:rPr b="1"/>
+              <a:t>What remains missing (the new frontier):</a:t>
+            </a:r>
+            <a:r>
+              <a:rPr/>
+              <a:t> - ❌ </a:t>
+            </a:r>
+            <a:r>
+              <a:rPr b="1"/>
+              <a:t>Behavioral typing of LLM actions</a:t>
+            </a:r>
+            <a:r>
+              <a:rPr/>
+              <a:t> — ZipperGen treats LLM actions as opaque blocks; it does not verify </a:t>
+            </a:r>
+            <a:r>
               <a:rPr i="1"/>
-              <a:t>Compiled by EvaPaper | Based on 28 papers across the Three-Layer Governance Stack</a:t>
+              <a:t>what</a:t>
+            </a:r>
+            <a:r>
+              <a:rPr/>
+              <a:t> the LLM computes inside them - ❌ </a:t>
+            </a:r>
+            <a:r>
+              <a:rPr b="1"/>
+              <a:t>Skill-skill composition within a single agent</a:t>
+            </a:r>
+            <a:r>
+              <a:rPr/>
+              <a:t> — ZipperGen verifies multi-agent coordination, not how skills compose within one agent - ❌ </a:t>
+            </a:r>
+            <a:r>
+              <a:rPr b="1"/>
+              <a:t>Blame assignment</a:t>
+            </a:r>
+            <a:r>
+              <a:rPr/>
+              <a:t> — When coordination fails, ZipperGen does not identify which agent (or which LLM action) is at fault - ❌ </a:t>
+            </a:r>
+            <a:r>
+              <a:rPr b="1"/>
+              <a:t>Runtime behavioral enforcement</a:t>
+            </a:r>
+            <a:r>
+              <a:rPr/>
+              <a:t> — ZipperGen enforces message structure, not behavior (e.g., “this agent must not send credit card numbers”) - ❌ </a:t>
+            </a:r>
+            <a:r>
+              <a:rPr b="1"/>
+              <a:t>Automatic rollback</a:t>
+            </a:r>
+            <a:r>
+              <a:rPr/>
+              <a:t> — No mechanism to revert multi-agent execution when a violation is detected</a:t>
+            </a:r>
+          </a:p>
+          <a:p>
+            <a:pPr lvl="0" indent="0" marL="0">
+              <a:buNone/>
+            </a:pPr>
+            <a:r>
+              <a:rPr b="1"/>
+              <a:t>The research opportunity is now sharper:</a:t>
+            </a:r>
+          </a:p>
+          <a:p>
+            <a:pPr lvl="0" indent="0" marL="0">
+              <a:buNone/>
+            </a:pPr>
+            <a:r>
+              <a:rPr/>
+              <a:t>Before ZipperGen: “Does MPST for LLM agents exist?” → No. After ZipperGen: “How do we add behavioral typing, blame, and rollback to the ZipperGen framework?”</a:t>
+            </a:r>
+          </a:p>
+          <a:p>
+            <a:pPr lvl="0" indent="0" marL="0">
+              <a:buNone/>
+            </a:pPr>
+            <a:r>
+              <a:rPr/>
+              <a:t>Specifically: 1. </a:t>
+            </a:r>
+            <a:r>
+              <a:rPr b="1"/>
+              <a:t>Action-level contracts:</a:t>
+            </a:r>
+            <a:r>
+              <a:rPr/>
+              <a:t> Extend ZipperGen’s action blocks from opaque </a:t>
+            </a:r>
+            <a:r>
+              <a:rPr>
+                <a:latin typeface="Courier"/>
+              </a:rPr>
+              <a:t>act A: y = f(x)</a:t>
+            </a:r>
+            <a:r>
+              <a:rPr/>
+              <a:t> to contract-typed </a:t>
+            </a:r>
+            <a:r>
+              <a:rPr>
+                <a:latin typeface="Courier"/>
+              </a:rPr>
+              <a:t>act A: y = f(x) requires P ensures Q</a:t>
+            </a:r>
+            <a:r>
+              <a:rPr/>
+              <a:t> — where P/Q are pre/postconditions enforced by ABC/AgentAssert or ACP 2. </a:t>
+            </a:r>
+            <a:r>
+              <a:rPr b="1"/>
+              <a:t>Skill composition:</a:t>
+            </a:r>
+            <a:r>
+              <a:rPr/>
+              <a:t> Apply ZipperGen’s projection logic to intra-agent skill composition (e.g., when two skills loaded by the same agent interact via tool calls) 3. </a:t>
+            </a:r>
+            <a:r>
+              <a:rPr b="1"/>
+              <a:t>Blame and rollback:</a:t>
+            </a:r>
+            <a:r>
+              <a:rPr/>
+              <a:t> Add sentinel actions that monitor message payloads and trigger rollback protocols when violations are detected</a:t>
+            </a:r>
+          </a:p>
+          <a:p>
+            <a:pPr lvl="0" indent="0" marL="0">
+              <a:buNone/>
+            </a:pPr>
+            <a:r>
+              <a:rPr b="1"/>
+              <a:t>The architecture of the future:</a:t>
+            </a:r>
+          </a:p>
+          <a:p>
+            <a:pPr lvl="0" indent="0">
+              <a:buNone/>
+            </a:pPr>
+            <a:r>
+              <a:rPr>
+                <a:latin typeface="Courier"/>
+              </a:rPr>
+              <a:t>Global Specification (ZipperGen MSC)
+    ↓ Syntax-directed projection
+Local Agent Programs (deadlock-free by construction)
+    ↓ Runtime execution
+    ├─ Message passing (deterministic, guaranteed)
+    └─ Action blocks (opaque LLM calls)
+         ↓ ABC/ACP enforcement inside each action
+         Behavior contracts (pre/postconditions)
+         Admission control (risk scoring)</a:t>
+            </a:r>
+          </a:p>
+          <a:p>
+            <a:pPr lvl="0" indent="0" marL="0">
+              <a:buNone/>
+            </a:pPr>
+            <a:r>
+              <a:rPr/>
+              <a:t>ZipperGen is the </a:t>
+            </a:r>
+            <a:r>
+              <a:rPr b="1"/>
+              <a:t>coordination layer</a:t>
+            </a:r>
+            <a:r>
+              <a:rPr/>
+              <a:t>. ABC/ACP is the </a:t>
+            </a:r>
+            <a:r>
+              <a:rPr b="1"/>
+              <a:t>behavioral layer</a:t>
+            </a:r>
+            <a:r>
+              <a:rPr/>
+              <a:t>. Together they form the complete multi-agent governance stack.</a:t>
             </a:r>
           </a:p>
         </p:txBody>
@@ -5913,6 +6529,53 @@
             <a:r>
               <a:rPr/>
               <a:t>. No paper proves formal behavioral mandate — what exists is empirical demonstration of influence.</a:t>
+            </a:r>
+          </a:p>
+        </p:txBody>
+      </p:sp>
+    </p:spTree>
+  </p:cSld>
+</p:sld>
+</file>
+
+<file path=ppt/slides/slide20.xml><?xml version="1.0" encoding="utf-8"?>
+<p:sld xmlns:a="http://schemas.openxmlformats.org/drawingml/2006/main" xmlns:r="http://schemas.openxmlformats.org/officeDocument/2006/relationships" xmlns:p="http://schemas.openxmlformats.org/presentationml/2006/main">
+  <p:cSld>
+    <p:spTree>
+      <p:nvGrpSpPr>
+        <p:cNvPr id="1" name=""/>
+        <p:cNvGrpSpPr/>
+        <p:nvPr/>
+      </p:nvGrpSpPr>
+      <p:grpSpPr>
+        <a:xfrm>
+          <a:off x="0" y="0"/>
+          <a:ext cx="0" cy="0"/>
+          <a:chOff x="0" y="0"/>
+          <a:chExt cx="0" cy="0"/>
+        </a:xfrm>
+      </p:grpSpPr>
+      <p:sp>
+        <p:nvSpPr>
+          <p:cNvPr id="3" name="Content Placeholder 2"/>
+          <p:cNvSpPr>
+            <a:spLocks noGrp="1"/>
+          </p:cNvSpPr>
+          <p:nvPr>
+            <p:ph idx="1"/>
+          </p:nvPr>
+        </p:nvSpPr>
+        <p:spPr/>
+        <p:txBody>
+          <a:bodyPr/>
+          <a:lstStyle/>
+          <a:p>
+            <a:pPr lvl="0" indent="0" marL="0">
+              <a:buNone/>
+            </a:pPr>
+            <a:r>
+              <a:rPr i="1"/>
+              <a:t>Compiled by EvaPaper | Based on 29 papers across the Three-Layer Governance Stack</a:t>
             </a:r>
           </a:p>
         </p:txBody>
@@ -6793,7 +7456,7 @@
             </a:pPr>
             <a:r>
               <a:rPr b="1"/>
-              <a:t>Short Answer: Yes, multiple approaches exist — but none are universally deployed.</a:t>
+              <a:t>Short Answer: Yes — and ZipperGen (arXiv:2604.17612) is the breakthrough for multi-agent coordination.</a:t>
             </a:r>
           </a:p>
         </p:txBody>
@@ -6855,7 +7518,85 @@
             </a:pPr>
             <a:r>
               <a:rPr b="1"/>
-              <a:t>1. SkillFortify (arXiv:2603.00195, Layer 0/1) — Most Advanced</a:t>
+              <a:t>1. ZipperGen / Provable Coordination for LLM Agents via MSCs (arXiv:2604.17612, Cross-layer Layer 0+1) — Multi-Agent Coordination</a:t>
+            </a:r>
+          </a:p>
+          <a:p>
+            <a:pPr lvl="0"/>
+            <a:r>
+              <a:rPr b="1"/>
+              <a:t>What it does:</a:t>
+            </a:r>
+            <a:r>
+              <a:rPr/>
+              <a:t> Domain-specific language (DSL) for specifying multi-agent coordination using Message Sequence Charts (MSCs). Syntax-directed projection generates deadlock-free local agent programs from global coordination specifications.</a:t>
+            </a:r>
+          </a:p>
+          <a:p>
+            <a:pPr lvl="0"/>
+            <a:r>
+              <a:rPr b="1"/>
+              <a:t>Static analysis:</a:t>
+            </a:r>
+            <a:r>
+              <a:rPr/>
+              <a:t> Well-typedness checks (Definition 5) — payload matching, local type correctness, control condition well-typedness — all checked before any agent executes. The global workflow is a formal specification that is statically verified before projection.</a:t>
+            </a:r>
+          </a:p>
+          <a:p>
+            <a:pPr lvl="0"/>
+            <a:r>
+              <a:rPr b="1"/>
+              <a:t>Formal guarantee:</a:t>
+            </a:r>
+            <a:r>
+              <a:rPr/>
+              <a:t> Deadlock-free by construction (Theorem in Section 5). The projection is a structural recursion with correctness proof by structural induction.</a:t>
+            </a:r>
+          </a:p>
+          <a:p>
+            <a:pPr lvl="0"/>
+            <a:r>
+              <a:rPr b="1"/>
+              <a:t>Key insight:</a:t>
+            </a:r>
+            <a:r>
+              <a:rPr/>
+              <a:t> Separates deterministic message-passing structure (formally specified, statically verified) from stochastic LLM actions (opaque, unpredictable). The coordination structure is guaranteed correct regardless of LLM nondeterminism.</a:t>
+            </a:r>
+          </a:p>
+          <a:p>
+            <a:pPr lvl="0"/>
+            <a:r>
+              <a:rPr b="1"/>
+              <a:t>Open source:</a:t>
+            </a:r>
+            <a:r>
+              <a:rPr/>
+              <a:t> ZipperGen — https://zippergen.io</a:t>
+            </a:r>
+          </a:p>
+          <a:p>
+            <a:pPr lvl="0"/>
+            <a:r>
+              <a:rPr b="1"/>
+              <a:t>Gap:</a:t>
+            </a:r>
+            <a:r>
+              <a:rPr/>
+              <a:t> Only verifies coordination structure, not LLM action content. No behavioral type checking for the content of messages or actions.</a:t>
+            </a:r>
+          </a:p>
+          <a:p>
+            <a:pPr lvl="0" indent="0" marL="0">
+              <a:spcBef>
+                <a:spcPts val="3000"/>
+              </a:spcBef>
+              <a:buNone/>
+            </a:pPr>
+            <a:r>
+              <a:rPr b="1"/>
+              <a:t>2. SkillFortify (arXiv:2603.00195, Layer 0/1) — Most Advanced for Single-Agent Skills</a:t>
             </a:r>
           </a:p>
           <a:p>
@@ -6942,7 +7683,7 @@
             </a:r>
             <a:r>
               <a:rPr/>
-              <a:t> Analyzes code, not natural language skill descriptions</a:t>
+              <a:t> Analyzes code, not natural language skill descriptions; single-agent only</a:t>
             </a:r>
           </a:p>
           <a:p>
@@ -6954,7 +7695,7 @@
             </a:pPr>
             <a:r>
               <a:rPr b="1"/>
-              <a:t>2. SkCC / Skill Compilation (arXiv:2605.03353, Layer 1/2)</a:t>
+              <a:t>3. SkCC / Skill Compilation (arXiv:2605.03353, Layer 1/2)</a:t>
             </a:r>
           </a:p>
           <a:p>
@@ -7009,7 +7750,7 @@
             </a:r>
             <a:r>
               <a:rPr/>
-              <a:t> Requires skills to be written in SkIR, not natural language markdown</a:t>
+              <a:t> Requires skills to be written in SkIR, not natural language markdown; single-agent only</a:t>
             </a:r>
           </a:p>
           <a:p>
@@ -7021,7 +7762,7 @@
             </a:pPr>
             <a:r>
               <a:rPr b="1"/>
-              <a:t>3. GovernSpec / Contractual Skills (arXiv:2605.22634, Layer 0)</a:t>
+              <a:t>4. GovernSpec / Contractual Skills (arXiv:2605.22634, Layer 0)</a:t>
             </a:r>
           </a:p>
           <a:p>
@@ -7054,7 +7795,7 @@
             </a:r>
             <a:r>
               <a:rPr/>
-              <a:t> Contracts are natural language with structured sections, not formal logic; no type system</a:t>
+              <a:t> Contracts are natural language with structured sections, not formal logic; no type system; single-agent only</a:t>
             </a:r>
           </a:p>
           <a:p>
@@ -7066,7 +7807,7 @@
             </a:pPr>
             <a:r>
               <a:rPr b="1"/>
-              <a:t>4. SSL Representation (arXiv:2604.24026, Layer 0)</a:t>
+              <a:t>5. SSL Representation (arXiv:2604.24026, Layer 0)</a:t>
             </a:r>
           </a:p>
           <a:p>
@@ -7099,7 +7840,7 @@
             </a:r>
             <a:r>
               <a:rPr/>
-              <a:t> 87% accuracy vs expert annotations; not a formal type system</a:t>
+              <a:t> 87% accuracy vs expert annotations; not a formal type system; single-agent only</a:t>
             </a:r>
           </a:p>
           <a:p>
@@ -7111,7 +7852,7 @@
             </a:pPr>
             <a:r>
               <a:rPr b="1"/>
-              <a:t>5. AgentVerify (preprints.org, 2026, Layer 1/2)</a:t>
+              <a:t>6. AgentVerify (preprints.org, 2026, Layer 1/2)</a:t>
             </a:r>
           </a:p>
           <a:p>
@@ -7155,7 +7896,7 @@
             </a:r>
             <a:r>
               <a:rPr/>
-              <a:t> Post-hoc analysis, not pre-runtime type checking; requires model checking expertise</a:t>
+              <a:t> Post-hoc analysis, not pre-runtime type checking; requires model checking expertise; single-agent only</a:t>
             </a:r>
           </a:p>
           <a:p>
@@ -7167,7 +7908,7 @@
             </a:pPr>
             <a:r>
               <a:rPr b="1"/>
-              <a:t>6. Skilldex (arXiv:2604.16911, Layer 0)</a:t>
+              <a:t>7. Skilldex (arXiv:2604.16911, Layer 0)</a:t>
             </a:r>
           </a:p>
           <a:p>
@@ -7211,7 +7952,7 @@
             </a:r>
             <a:r>
               <a:rPr/>
-              <a:t> Schema-level, not behavioral type checking</a:t>
+              <a:t> Schema-level, not behavioral type checking; single-agent only</a:t>
             </a:r>
           </a:p>
           <a:p>
@@ -7223,7 +7964,7 @@
             </a:pPr>
             <a:r>
               <a:rPr b="1"/>
-              <a:t>7. MIGT / Machine Identity Governance (arXiv:2604.06148, Layer 1/3)</a:t>
+              <a:t>8. MIGT / Machine Identity Governance (arXiv:2604.06148, Layer 1/3)</a:t>
             </a:r>
           </a:p>
           <a:p>
@@ -7256,7 +7997,7 @@
             </a:r>
             <a:r>
               <a:rPr/>
-              <a:t> Identity verification, not behavioral type checking</a:t>
+              <a:t> Identity verification, not behavioral type checking; single-agent only</a:t>
             </a:r>
           </a:p>
         </p:txBody>
@@ -7306,7 +8047,7 @@
             </a:pPr>
             <a:r>
               <a:rPr b="1"/>
-              <a:t>What Is Missing (The Gap)</a:t>
+              <a:t>What Is Missing (The Gap) — UPDATED with ZipperGen</a:t>
             </a:r>
           </a:p>
         </p:txBody>
@@ -7444,7 +8185,7 @@
                       </a:pPr>
                       <a:r>
                         <a:rPr b="1"/>
-                        <a:t>Static behavioral type checking</a:t>
+                        <a:t>Static behavioral type checking (single-agent)</a:t>
                       </a:r>
                     </a:p>
                   </a:txBody>
@@ -7491,37 +8232,37 @@
                       </a:pPr>
                       <a:r>
                         <a:rPr b="1"/>
-                        <a:t>Protocol compatibility checking</a:t>
-                      </a:r>
-                    </a:p>
-                  </a:txBody>
-                </a:tc>
-                <a:tc>
-                  <a:txBody>
-                    <a:bodyPr/>
-                    <a:lstStyle/>
-                    <a:p>
-                      <a:pPr lvl="0" indent="0" marL="0">
-                        <a:buNone/>
-                      </a:pPr>
-                      <a:r>
-                        <a:rPr/>
-                        <a:t>❌ No</a:t>
-                      </a:r>
-                    </a:p>
-                  </a:txBody>
-                </a:tc>
-                <a:tc>
-                  <a:txBody>
-                    <a:bodyPr/>
-                    <a:lstStyle/>
-                    <a:p>
-                      <a:pPr lvl="0" indent="0" marL="0">
-                        <a:buNone/>
-                      </a:pPr>
-                      <a:r>
-                        <a:rPr/>
-                        <a:t>No MPST-style session type checking for multi-agent interactions</a:t>
+                        <a:t>Static behavioral type checking (multi-agent)</a:t>
+                      </a:r>
+                    </a:p>
+                  </a:txBody>
+                </a:tc>
+                <a:tc>
+                  <a:txBody>
+                    <a:bodyPr/>
+                    <a:lstStyle/>
+                    <a:p>
+                      <a:pPr lvl="0" indent="0" marL="0">
+                        <a:buNone/>
+                      </a:pPr>
+                      <a:r>
+                        <a:rPr/>
+                        <a:t>⚠️ Partial</a:t>
+                      </a:r>
+                    </a:p>
+                  </a:txBody>
+                </a:tc>
+                <a:tc>
+                  <a:txBody>
+                    <a:bodyPr/>
+                    <a:lstStyle/>
+                    <a:p>
+                      <a:pPr lvl="0" indent="0" marL="0">
+                        <a:buNone/>
+                      </a:pPr>
+                      <a:r>
+                        <a:rPr/>
+                        <a:t>ZipperGen provides formal coordination structure checking, but not behavioral typing of message content</a:t>
                       </a:r>
                     </a:p>
                   </a:txBody>
@@ -7538,37 +8279,41 @@
                       </a:pPr>
                       <a:r>
                         <a:rPr b="1"/>
-                        <a:t>Pre-runtime deadlock detection</a:t>
-                      </a:r>
-                    </a:p>
-                  </a:txBody>
-                </a:tc>
-                <a:tc>
-                  <a:txBody>
-                    <a:bodyPr/>
-                    <a:lstStyle/>
-                    <a:p>
-                      <a:pPr lvl="0" indent="0" marL="0">
-                        <a:buNone/>
-                      </a:pPr>
-                      <a:r>
-                        <a:rPr/>
-                        <a:t>❌ No</a:t>
-                      </a:r>
-                    </a:p>
-                  </a:txBody>
-                </a:tc>
-                <a:tc>
-                  <a:txBody>
-                    <a:bodyPr/>
-                    <a:lstStyle/>
-                    <a:p>
-                      <a:pPr lvl="0" indent="0" marL="0">
-                        <a:buNone/>
-                      </a:pPr>
-                      <a:r>
-                        <a:rPr/>
-                        <a:t>Not addressed in any paper</a:t>
+                        <a:t>Protocol compatibility checking (multi-agent)</a:t>
+                      </a:r>
+                    </a:p>
+                  </a:txBody>
+                </a:tc>
+                <a:tc>
+                  <a:txBody>
+                    <a:bodyPr/>
+                    <a:lstStyle/>
+                    <a:p>
+                      <a:pPr lvl="0" indent="0" marL="0">
+                        <a:buNone/>
+                      </a:pPr>
+                      <a:r>
+                        <a:rPr/>
+                        <a:t>✅ Yes</a:t>
+                      </a:r>
+                    </a:p>
+                  </a:txBody>
+                </a:tc>
+                <a:tc>
+                  <a:txBody>
+                    <a:bodyPr/>
+                    <a:lstStyle/>
+                    <a:p>
+                      <a:pPr lvl="0" indent="0" marL="0">
+                        <a:buNone/>
+                      </a:pPr>
+                      <a:r>
+                        <a:rPr b="1"/>
+                        <a:t>ZipperGen</a:t>
+                      </a:r>
+                      <a:r>
+                        <a:rPr/>
+                        <a:t> — MSC-based DSL with syntax-directed projection and well-typedness checks</a:t>
                       </a:r>
                     </a:p>
                   </a:txBody>
@@ -7585,6 +8330,57 @@
                       </a:pPr>
                       <a:r>
                         <a:rPr b="1"/>
+                        <a:t>Pre-runtime deadlock detection</a:t>
+                      </a:r>
+                    </a:p>
+                  </a:txBody>
+                </a:tc>
+                <a:tc>
+                  <a:txBody>
+                    <a:bodyPr/>
+                    <a:lstStyle/>
+                    <a:p>
+                      <a:pPr lvl="0" indent="0" marL="0">
+                        <a:buNone/>
+                      </a:pPr>
+                      <a:r>
+                        <a:rPr/>
+                        <a:t>✅ Yes</a:t>
+                      </a:r>
+                    </a:p>
+                  </a:txBody>
+                </a:tc>
+                <a:tc>
+                  <a:txBody>
+                    <a:bodyPr/>
+                    <a:lstStyle/>
+                    <a:p>
+                      <a:pPr lvl="0" indent="0" marL="0">
+                        <a:buNone/>
+                      </a:pPr>
+                      <a:r>
+                        <a:rPr b="1"/>
+                        <a:t>ZipperGen</a:t>
+                      </a:r>
+                      <a:r>
+                        <a:rPr/>
+                        <a:t> — deadlock-free by construction from global specs</a:t>
+                      </a:r>
+                    </a:p>
+                  </a:txBody>
+                </a:tc>
+              </a:tr>
+              <a:tr h="0">
+                <a:tc>
+                  <a:txBody>
+                    <a:bodyPr/>
+                    <a:lstStyle/>
+                    <a:p>
+                      <a:pPr lvl="0" indent="0" marL="0">
+                        <a:buNone/>
+                      </a:pPr>
+                      <a:r>
+                        <a:rPr b="1"/>
                         <a:t>Skill-skill interaction verification</a:t>
                       </a:r>
                     </a:p>
@@ -7615,7 +8411,7 @@
                       </a:pPr>
                       <a:r>
                         <a:rPr/>
-                        <a:t>No static analysis of how multiple skills compose</a:t>
+                        <a:t>No static analysis of how multiple skills compose within a single agent</a:t>
                       </a:r>
                     </a:p>
                   </a:txBody>

</xml_diff>

<commit_message>
Complete rewrite of Three Questions Synthesis with comprehensive overall assessment table, layer mapping, and conclusion
</commit_message>
<xml_diff>
--- a/Agent_Governance_Three_Questions_Synthesis.pptx
+++ b/Agent_Governance_Three_Questions_Synthesis.pptx
@@ -25,6 +25,7 @@
     <p:sldId id="273" r:id="rId19"/>
     <p:sldId id="274" r:id="rId20"/>
     <p:sldId id="275" r:id="rId21"/>
+    <p:sldId id="276" r:id="rId22"/>
   </p:sldIdLst>
   <p:sldSz cx="9144000" cy="5143500" type="screen16x9"/>
   <p:notesSz cx="6858000" cy="9144000"/>
@@ -3154,7 +3155,7 @@
             </a:pPr>
             <a:r>
               <a:rPr sz="2000"/>
-              <a:t>Compiled by EvaPaper | June 6, 2026 Based on 28 papers across the Three-Layer Governance Stack</a:t>
+              <a:t>Compiled by EvaPaper | June 6, 2026 Based on 29 papers across the Three-Layer Governance Stack</a:t>
             </a:r>
           </a:p>
         </p:txBody>
@@ -4069,12 +4070,12 @@
       </p:grpSpPr>
       <p:sp>
         <p:nvSpPr>
-          <p:cNvPr id="3" name="Content Placeholder 2"/>
+          <p:cNvPr id="4" name="Text Placeholder 3"/>
           <p:cNvSpPr>
             <a:spLocks noGrp="1"/>
           </p:cNvSpPr>
           <p:nvPr>
-            <p:ph idx="1"/>
+            <p:ph idx="2" sz="half" type="body"/>
           </p:nvPr>
         </p:nvSpPr>
         <p:spPr/>
@@ -4090,66 +4091,969 @@
             </a:pPr>
             <a:r>
               <a:rPr b="1"/>
-              <a:t>10. ZipperGen / Provable Coordination for LLM Agents via MSCs (arXiv:2604.17612, Cross-layer Layer 0+1)</a:t>
-            </a:r>
-          </a:p>
-          <a:p>
-            <a:pPr lvl="0"/>
-            <a:r>
-              <a:rPr b="1"/>
-              <a:t>Deterministic:</a:t>
-            </a:r>
-            <a:r>
-              <a:rPr/>
-              <a:t> Yes — message-passing structure is formally specified; LLM actions remain opaque</a:t>
-            </a:r>
-          </a:p>
-          <a:p>
-            <a:pPr lvl="0"/>
-            <a:r>
-              <a:rPr b="1"/>
-              <a:t>Mechanism:</a:t>
-            </a:r>
-            <a:r>
-              <a:rPr/>
-              <a:t> Domain-specific language based on Message Sequence Charts (MSCs). Syntax-directed projection generates deadlock-free local agent programs from global coordination specifications. Owned control flow with explicit deciders. Control broadcasts ensure non-owner lifelines observe branch choices.</a:t>
-            </a:r>
-          </a:p>
-          <a:p>
-            <a:pPr lvl="0"/>
-            <a:r>
-              <a:rPr b="1"/>
-              <a:t>Results:</a:t>
-            </a:r>
-            <a:r>
-              <a:rPr/>
-              <a:t> Deadlock-free by construction. Coordination properties established independently of LLM nondeterminism. Runtime planning extension: LLM generates workflows with same structural guarantees.</a:t>
-            </a:r>
-          </a:p>
-          <a:p>
-            <a:pPr lvl="0"/>
-            <a:r>
-              <a:rPr b="1"/>
-              <a:t>Open source:</a:t>
-            </a:r>
-            <a:r>
-              <a:rPr/>
-              <a:t> ZipperGen — https://zippergen.io</a:t>
-            </a:r>
-          </a:p>
-          <a:p>
-            <a:pPr lvl="0"/>
-            <a:r>
-              <a:rPr b="1"/>
-              <a:t>Gap:</a:t>
-            </a:r>
-            <a:r>
-              <a:rPr/>
-              <a:t> Does not verify LLM action content (opaque by design). No runtime behavioral enforcement beyond coordination structure.</a:t>
+              <a:t>Comparison: Deterministic vs LLM-as-Judge Runtime Checking</a:t>
             </a:r>
           </a:p>
         </p:txBody>
       </p:sp>
+      <p:graphicFrame>
+        <p:nvGraphicFramePr>
+          <p:cNvPr id="6" name="Content Placeholder 5"/>
+          <p:cNvGraphicFramePr>
+            <a:graphicFrameLocks noGrp="1"/>
+          </p:cNvGraphicFramePr>
+          <p:nvPr>
+            <p:ph idx="1"/>
+          </p:nvPr>
+        </p:nvGraphicFramePr>
+        <p:xfrm>
+          <a:off x="3568700" y="203200"/>
+          <a:ext cx="5105400" cy="4381500"/>
+        </p:xfrm>
+        <a:graphic>
+          <a:graphicData uri="http://schemas.openxmlformats.org/drawingml/2006/table">
+            <a:tbl>
+              <a:tblPr firstRow="1" bandRow="1">
+                <a:tableStyleId>{5C22544A-7EE6-4342-B048-85BDC9FD1C3A}</a:tableStyleId>
+              </a:tblPr>
+              <a:tblGrid>
+                <a:gridCol w="850900"/>
+                <a:gridCol w="850900"/>
+                <a:gridCol w="850900"/>
+                <a:gridCol w="850900"/>
+                <a:gridCol w="850900"/>
+                <a:gridCol w="850900"/>
+              </a:tblGrid>
+              <a:tr h="0">
+                <a:tc>
+                  <a:txBody>
+                    <a:bodyPr/>
+                    <a:lstStyle/>
+                    <a:p>
+                      <a:pPr lvl="0" indent="0" marL="0">
+                        <a:buNone/>
+                      </a:pPr>
+                      <a:r>
+                        <a:rPr/>
+                        <a:t>Mechanism</a:t>
+                      </a:r>
+                    </a:p>
+                  </a:txBody>
+                  <a:tcPr/>
+                </a:tc>
+                <a:tc>
+                  <a:txBody>
+                    <a:bodyPr/>
+                    <a:lstStyle/>
+                    <a:p>
+                      <a:pPr lvl="0" indent="0" marL="0">
+                        <a:buNone/>
+                      </a:pPr>
+                      <a:r>
+                        <a:rPr/>
+                        <a:t>Scope</a:t>
+                      </a:r>
+                    </a:p>
+                  </a:txBody>
+                  <a:tcPr/>
+                </a:tc>
+                <a:tc>
+                  <a:txBody>
+                    <a:bodyPr/>
+                    <a:lstStyle/>
+                    <a:p>
+                      <a:pPr lvl="0" indent="0" marL="0">
+                        <a:buNone/>
+                      </a:pPr>
+                      <a:r>
+                        <a:rPr/>
+                        <a:t>Deterministic?</a:t>
+                      </a:r>
+                    </a:p>
+                  </a:txBody>
+                  <a:tcPr/>
+                </a:tc>
+                <a:tc>
+                  <a:txBody>
+                    <a:bodyPr/>
+                    <a:lstStyle/>
+                    <a:p>
+                      <a:pPr lvl="0" indent="0" marL="0">
+                        <a:buNone/>
+                      </a:pPr>
+                      <a:r>
+                        <a:rPr/>
+                        <a:t>Speed</a:t>
+                      </a:r>
+                    </a:p>
+                  </a:txBody>
+                  <a:tcPr/>
+                </a:tc>
+                <a:tc>
+                  <a:txBody>
+                    <a:bodyPr/>
+                    <a:lstStyle/>
+                    <a:p>
+                      <a:pPr lvl="0" indent="0" marL="0">
+                        <a:buNone/>
+                      </a:pPr>
+                      <a:r>
+                        <a:rPr/>
+                        <a:t>Formal Verification</a:t>
+                      </a:r>
+                    </a:p>
+                  </a:txBody>
+                  <a:tcPr/>
+                </a:tc>
+                <a:tc>
+                  <a:txBody>
+                    <a:bodyPr/>
+                    <a:lstStyle/>
+                    <a:p>
+                      <a:pPr lvl="0" indent="0" marL="0">
+                        <a:buNone/>
+                      </a:pPr>
+                      <a:r>
+                        <a:rPr/>
+                        <a:t>Production Ready</a:t>
+                      </a:r>
+                    </a:p>
+                  </a:txBody>
+                  <a:tcPr/>
+                </a:tc>
+              </a:tr>
+              <a:tr h="0">
+                <a:tc>
+                  <a:txBody>
+                    <a:bodyPr/>
+                    <a:lstStyle/>
+                    <a:p>
+                      <a:pPr lvl="0" indent="0" marL="0">
+                        <a:buNone/>
+                      </a:pPr>
+                      <a:r>
+                        <a:rPr b="1"/>
+                        <a:t>ZipperGen</a:t>
+                      </a:r>
+                    </a:p>
+                  </a:txBody>
+                </a:tc>
+                <a:tc>
+                  <a:txBody>
+                    <a:bodyPr/>
+                    <a:lstStyle/>
+                    <a:p>
+                      <a:pPr lvl="0" indent="0" marL="0">
+                        <a:buNone/>
+                      </a:pPr>
+                      <a:r>
+                        <a:rPr b="1"/>
+                        <a:t>Multi-agent</a:t>
+                      </a:r>
+                    </a:p>
+                  </a:txBody>
+                </a:tc>
+                <a:tc>
+                  <a:txBody>
+                    <a:bodyPr/>
+                    <a:lstStyle/>
+                    <a:p>
+                      <a:pPr lvl="0" indent="0" marL="0">
+                        <a:buNone/>
+                      </a:pPr>
+                      <a:r>
+                        <a:rPr/>
+                        <a:t>✅ Yes (coordination structure)</a:t>
+                      </a:r>
+                    </a:p>
+                  </a:txBody>
+                </a:tc>
+                <a:tc>
+                  <a:txBody>
+                    <a:bodyPr/>
+                    <a:lstStyle/>
+                    <a:p>
+                      <a:pPr lvl="0" indent="0" marL="0">
+                        <a:buNone/>
+                      </a:pPr>
+                      <a:r>
+                        <a:rPr/>
+                        <a:t>—</a:t>
+                      </a:r>
+                    </a:p>
+                  </a:txBody>
+                </a:tc>
+                <a:tc>
+                  <a:txBody>
+                    <a:bodyPr/>
+                    <a:lstStyle/>
+                    <a:p>
+                      <a:pPr lvl="0" indent="0" marL="0">
+                        <a:buNone/>
+                      </a:pPr>
+                      <a:r>
+                        <a:rPr/>
+                        <a:t>Structural induction proof</a:t>
+                      </a:r>
+                    </a:p>
+                  </a:txBody>
+                </a:tc>
+                <a:tc>
+                  <a:txBody>
+                    <a:bodyPr/>
+                    <a:lstStyle/>
+                    <a:p>
+                      <a:pPr lvl="0" indent="0" marL="0">
+                        <a:buNone/>
+                      </a:pPr>
+                      <a:r>
+                        <a:rPr/>
+                        <a:t>✅ Python impl</a:t>
+                      </a:r>
+                    </a:p>
+                  </a:txBody>
+                </a:tc>
+              </a:tr>
+              <a:tr h="0">
+                <a:tc>
+                  <a:txBody>
+                    <a:bodyPr/>
+                    <a:lstStyle/>
+                    <a:p>
+                      <a:pPr lvl="0" indent="0" marL="0">
+                        <a:buNone/>
+                      </a:pPr>
+                      <a:r>
+                        <a:rPr b="1"/>
+                        <a:t>ACP</a:t>
+                      </a:r>
+                    </a:p>
+                  </a:txBody>
+                </a:tc>
+                <a:tc>
+                  <a:txBody>
+                    <a:bodyPr/>
+                    <a:lstStyle/>
+                    <a:p>
+                      <a:pPr lvl="0" indent="0" marL="0">
+                        <a:buNone/>
+                      </a:pPr>
+                      <a:r>
+                        <a:rPr/>
+                        <a:t>Single-agent</a:t>
+                      </a:r>
+                    </a:p>
+                  </a:txBody>
+                </a:tc>
+                <a:tc>
+                  <a:txBody>
+                    <a:bodyPr/>
+                    <a:lstStyle/>
+                    <a:p>
+                      <a:pPr lvl="0" indent="0" marL="0">
+                        <a:buNone/>
+                      </a:pPr>
+                      <a:r>
+                        <a:rPr/>
+                        <a:t>✅ Yes</a:t>
+                      </a:r>
+                    </a:p>
+                  </a:txBody>
+                </a:tc>
+                <a:tc>
+                  <a:txBody>
+                    <a:bodyPr/>
+                    <a:lstStyle/>
+                    <a:p>
+                      <a:pPr lvl="0" indent="0" marL="0">
+                        <a:buNone/>
+                      </a:pPr>
+                      <a:r>
+                        <a:rPr/>
+                        <a:t>739-832 ns</a:t>
+                      </a:r>
+                    </a:p>
+                  </a:txBody>
+                </a:tc>
+                <a:tc>
+                  <a:txBody>
+                    <a:bodyPr/>
+                    <a:lstStyle/>
+                    <a:p>
+                      <a:pPr lvl="0" indent="0" marL="0">
+                        <a:buNone/>
+                      </a:pPr>
+                      <a:r>
+                        <a:rPr/>
+                        <a:t>TLA+ (4.2B states)</a:t>
+                      </a:r>
+                    </a:p>
+                  </a:txBody>
+                </a:tc>
+                <a:tc>
+                  <a:txBody>
+                    <a:bodyPr/>
+                    <a:lstStyle/>
+                    <a:p>
+                      <a:pPr lvl="0" indent="0" marL="0">
+                        <a:buNone/>
+                      </a:pPr>
+                      <a:r>
+                        <a:rPr/>
+                        <a:t>✅ Go impl</a:t>
+                      </a:r>
+                    </a:p>
+                  </a:txBody>
+                </a:tc>
+              </a:tr>
+              <a:tr h="0">
+                <a:tc>
+                  <a:txBody>
+                    <a:bodyPr/>
+                    <a:lstStyle/>
+                    <a:p>
+                      <a:pPr lvl="0" indent="0" marL="0">
+                        <a:buNone/>
+                      </a:pPr>
+                      <a:r>
+                        <a:rPr b="1"/>
+                        <a:t>ABC / AgentAssert</a:t>
+                      </a:r>
+                    </a:p>
+                  </a:txBody>
+                </a:tc>
+                <a:tc>
+                  <a:txBody>
+                    <a:bodyPr/>
+                    <a:lstStyle/>
+                    <a:p>
+                      <a:pPr lvl="0" indent="0" marL="0">
+                        <a:buNone/>
+                      </a:pPr>
+                      <a:r>
+                        <a:rPr/>
+                        <a:t>Single-agent</a:t>
+                      </a:r>
+                    </a:p>
+                  </a:txBody>
+                </a:tc>
+                <a:tc>
+                  <a:txBody>
+                    <a:bodyPr/>
+                    <a:lstStyle/>
+                    <a:p>
+                      <a:pPr lvl="0" indent="0" marL="0">
+                        <a:buNone/>
+                      </a:pPr>
+                      <a:r>
+                        <a:rPr/>
+                        <a:t>✅ Mostly</a:t>
+                      </a:r>
+                    </a:p>
+                  </a:txBody>
+                </a:tc>
+                <a:tc>
+                  <a:txBody>
+                    <a:bodyPr/>
+                    <a:lstStyle/>
+                    <a:p>
+                      <a:pPr lvl="0" indent="0" marL="0">
+                        <a:buNone/>
+                      </a:pPr>
+                      <a:r>
+                        <a:rPr/>
+                        <a:t>&lt;10 ms</a:t>
+                      </a:r>
+                    </a:p>
+                  </a:txBody>
+                </a:tc>
+                <a:tc>
+                  <a:txBody>
+                    <a:bodyPr/>
+                    <a:lstStyle/>
+                    <a:p>
+                      <a:pPr lvl="0" indent="0" marL="0">
+                        <a:buNone/>
+                      </a:pPr>
+                      <a:r>
+                        <a:rPr/>
+                        <a:t>Drift Bounds Theorem</a:t>
+                      </a:r>
+                    </a:p>
+                  </a:txBody>
+                </a:tc>
+                <a:tc>
+                  <a:txBody>
+                    <a:bodyPr/>
+                    <a:lstStyle/>
+                    <a:p>
+                      <a:pPr lvl="0" indent="0" marL="0">
+                        <a:buNone/>
+                      </a:pPr>
+                      <a:r>
+                        <a:rPr/>
+                        <a:t>✅ Library</a:t>
+                      </a:r>
+                    </a:p>
+                  </a:txBody>
+                </a:tc>
+              </a:tr>
+              <a:tr h="0">
+                <a:tc>
+                  <a:txBody>
+                    <a:bodyPr/>
+                    <a:lstStyle/>
+                    <a:p>
+                      <a:pPr lvl="0" indent="0" marL="0">
+                        <a:buNone/>
+                      </a:pPr>
+                      <a:r>
+                        <a:rPr b="1"/>
+                        <a:t>Runtime Governance</a:t>
+                      </a:r>
+                    </a:p>
+                  </a:txBody>
+                </a:tc>
+                <a:tc>
+                  <a:txBody>
+                    <a:bodyPr/>
+                    <a:lstStyle/>
+                    <a:p>
+                      <a:pPr lvl="0" indent="0" marL="0">
+                        <a:buNone/>
+                      </a:pPr>
+                      <a:r>
+                        <a:rPr/>
+                        <a:t>Single-agent</a:t>
+                      </a:r>
+                    </a:p>
+                  </a:txBody>
+                </a:tc>
+                <a:tc>
+                  <a:txBody>
+                    <a:bodyPr/>
+                    <a:lstStyle/>
+                    <a:p>
+                      <a:pPr lvl="0" indent="0" marL="0">
+                        <a:buNone/>
+                      </a:pPr>
+                      <a:r>
+                        <a:rPr/>
+                        <a:t>✅ Yes</a:t>
+                      </a:r>
+                    </a:p>
+                  </a:txBody>
+                </a:tc>
+                <a:tc>
+                  <a:txBody>
+                    <a:bodyPr/>
+                    <a:lstStyle/>
+                    <a:p>
+                      <a:pPr lvl="0" indent="0" marL="0">
+                        <a:buNone/>
+                      </a:pPr>
+                      <a:r>
+                        <a:rPr/>
+                        <a:t>Polynomial</a:t>
+                      </a:r>
+                    </a:p>
+                  </a:txBody>
+                </a:tc>
+                <a:tc>
+                  <a:txBody>
+                    <a:bodyPr/>
+                    <a:lstStyle/>
+                    <a:p>
+                      <a:pPr lvl="0" indent="0" marL="0">
+                        <a:buNone/>
+                      </a:pPr>
+                      <a:r>
+                        <a:rPr/>
+                        <a:t>Framework</a:t>
+                      </a:r>
+                    </a:p>
+                  </a:txBody>
+                </a:tc>
+                <a:tc>
+                  <a:txBody>
+                    <a:bodyPr/>
+                    <a:lstStyle/>
+                    <a:p>
+                      <a:pPr lvl="0" indent="0" marL="0">
+                        <a:buNone/>
+                      </a:pPr>
+                      <a:r>
+                        <a:rPr/>
+                        <a:t>⚠️ Proposed</a:t>
+                      </a:r>
+                    </a:p>
+                  </a:txBody>
+                </a:tc>
+              </a:tr>
+              <a:tr h="0">
+                <a:tc>
+                  <a:txBody>
+                    <a:bodyPr/>
+                    <a:lstStyle/>
+                    <a:p>
+                      <a:pPr lvl="0" indent="0" marL="0">
+                        <a:buNone/>
+                      </a:pPr>
+                      <a:r>
+                        <a:rPr b="1"/>
+                        <a:t>AgentVerify</a:t>
+                      </a:r>
+                    </a:p>
+                  </a:txBody>
+                </a:tc>
+                <a:tc>
+                  <a:txBody>
+                    <a:bodyPr/>
+                    <a:lstStyle/>
+                    <a:p>
+                      <a:pPr lvl="0" indent="0" marL="0">
+                        <a:buNone/>
+                      </a:pPr>
+                      <a:r>
+                        <a:rPr/>
+                        <a:t>Single-agent</a:t>
+                      </a:r>
+                    </a:p>
+                  </a:txBody>
+                </a:tc>
+                <a:tc>
+                  <a:txBody>
+                    <a:bodyPr/>
+                    <a:lstStyle/>
+                    <a:p>
+                      <a:pPr lvl="0" indent="0" marL="0">
+                        <a:buNone/>
+                      </a:pPr>
+                      <a:r>
+                        <a:rPr/>
+                        <a:t>⚠️ Hybrid</a:t>
+                      </a:r>
+                    </a:p>
+                  </a:txBody>
+                </a:tc>
+                <a:tc>
+                  <a:txBody>
+                    <a:bodyPr/>
+                    <a:lstStyle/>
+                    <a:p>
+                      <a:pPr lvl="0" indent="0" marL="0">
+                        <a:buNone/>
+                      </a:pPr>
+                      <a:r>
+                        <a:rPr/>
+                        <a:t>O(1) monitor</a:t>
+                      </a:r>
+                    </a:p>
+                  </a:txBody>
+                </a:tc>
+                <a:tc>
+                  <a:txBody>
+                    <a:bodyPr/>
+                    <a:lstStyle/>
+                    <a:p>
+                      <a:pPr lvl="0" indent="0" marL="0">
+                        <a:buNone/>
+                      </a:pPr>
+                      <a:r>
+                        <a:rPr/>
+                        <a:t>LTL model checking</a:t>
+                      </a:r>
+                    </a:p>
+                  </a:txBody>
+                </a:tc>
+                <a:tc>
+                  <a:txBody>
+                    <a:bodyPr/>
+                    <a:lstStyle/>
+                    <a:p>
+                      <a:pPr lvl="0" indent="0" marL="0">
+                        <a:buNone/>
+                      </a:pPr>
+                      <a:r>
+                        <a:rPr/>
+                        <a:t>⚠️ Research</a:t>
+                      </a:r>
+                    </a:p>
+                  </a:txBody>
+                </a:tc>
+              </a:tr>
+              <a:tr h="0">
+                <a:tc>
+                  <a:txBody>
+                    <a:bodyPr/>
+                    <a:lstStyle/>
+                    <a:p>
+                      <a:pPr lvl="0" indent="0" marL="0">
+                        <a:buNone/>
+                      </a:pPr>
+                      <a:r>
+                        <a:rPr b="1"/>
+                        <a:t>SentinelAgent</a:t>
+                      </a:r>
+                    </a:p>
+                  </a:txBody>
+                </a:tc>
+                <a:tc>
+                  <a:txBody>
+                    <a:bodyPr/>
+                    <a:lstStyle/>
+                    <a:p>
+                      <a:pPr lvl="0" indent="0" marL="0">
+                        <a:buNone/>
+                      </a:pPr>
+                      <a:r>
+                        <a:rPr/>
+                        <a:t>Single-agent</a:t>
+                      </a:r>
+                    </a:p>
+                  </a:txBody>
+                </a:tc>
+                <a:tc>
+                  <a:txBody>
+                    <a:bodyPr/>
+                    <a:lstStyle/>
+                    <a:p>
+                      <a:pPr lvl="0" indent="0" marL="0">
+                        <a:buNone/>
+                      </a:pPr>
+                      <a:r>
+                        <a:rPr/>
+                        <a:t>✅ Yes</a:t>
+                      </a:r>
+                    </a:p>
+                  </a:txBody>
+                </a:tc>
+                <a:tc>
+                  <a:txBody>
+                    <a:bodyPr/>
+                    <a:lstStyle/>
+                    <a:p>
+                      <a:pPr lvl="0" indent="0" marL="0">
+                        <a:buNone/>
+                      </a:pPr>
+                      <a:r>
+                        <a:rPr/>
+                        <a:t>—</a:t>
+                      </a:r>
+                    </a:p>
+                  </a:txBody>
+                </a:tc>
+                <a:tc>
+                  <a:txBody>
+                    <a:bodyPr/>
+                    <a:lstStyle/>
+                    <a:p>
+                      <a:pPr lvl="0" indent="0" marL="0">
+                        <a:buNone/>
+                      </a:pPr>
+                      <a:r>
+                        <a:rPr/>
+                        <a:t>TLA+ (2.7M states)</a:t>
+                      </a:r>
+                    </a:p>
+                  </a:txBody>
+                </a:tc>
+                <a:tc>
+                  <a:txBody>
+                    <a:bodyPr/>
+                    <a:lstStyle/>
+                    <a:p>
+                      <a:pPr lvl="0" indent="0" marL="0">
+                        <a:buNone/>
+                      </a:pPr>
+                      <a:r>
+                        <a:rPr/>
+                        <a:t>⚠️ Research</a:t>
+                      </a:r>
+                    </a:p>
+                  </a:txBody>
+                </a:tc>
+              </a:tr>
+              <a:tr h="0">
+                <a:tc>
+                  <a:txBody>
+                    <a:bodyPr/>
+                    <a:lstStyle/>
+                    <a:p>
+                      <a:pPr lvl="0" indent="0" marL="0">
+                        <a:buNone/>
+                      </a:pPr>
+                      <a:r>
+                        <a:rPr b="1"/>
+                        <a:t>Trace-Based Assurance</a:t>
+                      </a:r>
+                    </a:p>
+                  </a:txBody>
+                </a:tc>
+                <a:tc>
+                  <a:txBody>
+                    <a:bodyPr/>
+                    <a:lstStyle/>
+                    <a:p>
+                      <a:pPr lvl="0" indent="0" marL="0">
+                        <a:buNone/>
+                      </a:pPr>
+                      <a:r>
+                        <a:rPr/>
+                        <a:t>Single-agent</a:t>
+                      </a:r>
+                    </a:p>
+                  </a:txBody>
+                </a:tc>
+                <a:tc>
+                  <a:txBody>
+                    <a:bodyPr/>
+                    <a:lstStyle/>
+                    <a:p>
+                      <a:pPr lvl="0" indent="0" marL="0">
+                        <a:buNone/>
+                      </a:pPr>
+                      <a:r>
+                        <a:rPr/>
+                        <a:t>✅ Yes</a:t>
+                      </a:r>
+                    </a:p>
+                  </a:txBody>
+                </a:tc>
+                <a:tc>
+                  <a:txBody>
+                    <a:bodyPr/>
+                    <a:lstStyle/>
+                    <a:p>
+                      <a:pPr lvl="0" indent="0" marL="0">
+                        <a:buNone/>
+                      </a:pPr>
+                      <a:r>
+                        <a:rPr/>
+                        <a:t>—</a:t>
+                      </a:r>
+                    </a:p>
+                  </a:txBody>
+                </a:tc>
+                <a:tc>
+                  <a:txBody>
+                    <a:bodyPr/>
+                    <a:lstStyle/>
+                    <a:p>
+                      <a:pPr lvl="0" indent="0" marL="0">
+                        <a:buNone/>
+                      </a:pPr>
+                      <a:r>
+                        <a:rPr/>
+                        <a:t>Replay-based</a:t>
+                      </a:r>
+                    </a:p>
+                  </a:txBody>
+                </a:tc>
+                <a:tc>
+                  <a:txBody>
+                    <a:bodyPr/>
+                    <a:lstStyle/>
+                    <a:p>
+                      <a:pPr lvl="0" indent="0" marL="0">
+                        <a:buNone/>
+                      </a:pPr>
+                      <a:r>
+                        <a:rPr/>
+                        <a:t>⚠️ Complex</a:t>
+                      </a:r>
+                    </a:p>
+                  </a:txBody>
+                </a:tc>
+              </a:tr>
+              <a:tr h="0">
+                <a:tc>
+                  <a:txBody>
+                    <a:bodyPr/>
+                    <a:lstStyle/>
+                    <a:p>
+                      <a:pPr lvl="0" indent="0" marL="0">
+                        <a:buNone/>
+                      </a:pPr>
+                      <a:r>
+                        <a:rPr b="1"/>
+                        <a:t>BeSafe-Bench</a:t>
+                      </a:r>
+                    </a:p>
+                  </a:txBody>
+                </a:tc>
+                <a:tc>
+                  <a:txBody>
+                    <a:bodyPr/>
+                    <a:lstStyle/>
+                    <a:p>
+                      <a:pPr lvl="0" indent="0" marL="0">
+                        <a:buNone/>
+                      </a:pPr>
+                      <a:r>
+                        <a:rPr/>
+                        <a:t>Benchmark</a:t>
+                      </a:r>
+                    </a:p>
+                  </a:txBody>
+                </a:tc>
+                <a:tc>
+                  <a:txBody>
+                    <a:bodyPr/>
+                    <a:lstStyle/>
+                    <a:p>
+                      <a:pPr lvl="0" indent="0" marL="0">
+                        <a:buNone/>
+                      </a:pPr>
+                      <a:r>
+                        <a:rPr/>
+                        <a:t>❌ No</a:t>
+                      </a:r>
+                    </a:p>
+                  </a:txBody>
+                </a:tc>
+                <a:tc>
+                  <a:txBody>
+                    <a:bodyPr/>
+                    <a:lstStyle/>
+                    <a:p>
+                      <a:pPr lvl="0" indent="0" marL="0">
+                        <a:buNone/>
+                      </a:pPr>
+                      <a:r>
+                        <a:rPr/>
+                        <a:t>—</a:t>
+                      </a:r>
+                    </a:p>
+                  </a:txBody>
+                </a:tc>
+                <a:tc>
+                  <a:txBody>
+                    <a:bodyPr/>
+                    <a:lstStyle/>
+                    <a:p>
+                      <a:pPr lvl="0" indent="0" marL="0">
+                        <a:buNone/>
+                      </a:pPr>
+                      <a:r>
+                        <a:rPr/>
+                        <a:t>—</a:t>
+                      </a:r>
+                    </a:p>
+                  </a:txBody>
+                </a:tc>
+                <a:tc>
+                  <a:txBody>
+                    <a:bodyPr/>
+                    <a:lstStyle/>
+                    <a:p>
+                      <a:pPr lvl="0" indent="0" marL="0">
+                        <a:buNone/>
+                      </a:pPr>
+                      <a:r>
+                        <a:rPr/>
+                        <a:t>✅ Benchmark</a:t>
+                      </a:r>
+                    </a:p>
+                  </a:txBody>
+                </a:tc>
+              </a:tr>
+              <a:tr h="0">
+                <a:tc>
+                  <a:txBody>
+                    <a:bodyPr/>
+                    <a:lstStyle/>
+                    <a:p>
+                      <a:pPr lvl="0" indent="0" marL="0">
+                        <a:buNone/>
+                      </a:pPr>
+                      <a:r>
+                        <a:rPr b="1"/>
+                        <a:t>ST-WebAgentBench</a:t>
+                      </a:r>
+                    </a:p>
+                  </a:txBody>
+                </a:tc>
+                <a:tc>
+                  <a:txBody>
+                    <a:bodyPr/>
+                    <a:lstStyle/>
+                    <a:p>
+                      <a:pPr lvl="0" indent="0" marL="0">
+                        <a:buNone/>
+                      </a:pPr>
+                      <a:r>
+                        <a:rPr/>
+                        <a:t>Benchmark</a:t>
+                      </a:r>
+                    </a:p>
+                  </a:txBody>
+                </a:tc>
+                <a:tc>
+                  <a:txBody>
+                    <a:bodyPr/>
+                    <a:lstStyle/>
+                    <a:p>
+                      <a:pPr lvl="0" indent="0" marL="0">
+                        <a:buNone/>
+                      </a:pPr>
+                      <a:r>
+                        <a:rPr/>
+                        <a:t>❌ No</a:t>
+                      </a:r>
+                    </a:p>
+                  </a:txBody>
+                </a:tc>
+                <a:tc>
+                  <a:txBody>
+                    <a:bodyPr/>
+                    <a:lstStyle/>
+                    <a:p>
+                      <a:pPr lvl="0" indent="0" marL="0">
+                        <a:buNone/>
+                      </a:pPr>
+                      <a:r>
+                        <a:rPr/>
+                        <a:t>—</a:t>
+                      </a:r>
+                    </a:p>
+                  </a:txBody>
+                </a:tc>
+                <a:tc>
+                  <a:txBody>
+                    <a:bodyPr/>
+                    <a:lstStyle/>
+                    <a:p>
+                      <a:pPr lvl="0" indent="0" marL="0">
+                        <a:buNone/>
+                      </a:pPr>
+                      <a:r>
+                        <a:rPr/>
+                        <a:t>—</a:t>
+                      </a:r>
+                    </a:p>
+                  </a:txBody>
+                </a:tc>
+                <a:tc>
+                  <a:txBody>
+                    <a:bodyPr/>
+                    <a:lstStyle/>
+                    <a:p>
+                      <a:pPr lvl="0" indent="0" marL="0">
+                        <a:buNone/>
+                      </a:pPr>
+                      <a:r>
+                        <a:rPr/>
+                        <a:t>✅ Benchmark</a:t>
+                      </a:r>
+                    </a:p>
+                  </a:txBody>
+                </a:tc>
+              </a:tr>
+            </a:tbl>
+          </a:graphicData>
+        </a:graphic>
+      </p:graphicFrame>
     </p:spTree>
   </p:cSld>
 </p:sld>
@@ -4195,7 +5099,7 @@
             </a:pPr>
             <a:r>
               <a:rPr b="1"/>
-              <a:t>Comparison: Deterministic vs LLM-as-Judge Runtime Checking</a:t>
+              <a:t>What Is Missing (The Gap) — UPDATED with ZipperGen</a:t>
             </a:r>
           </a:p>
         </p:txBody>
@@ -4221,12 +5125,9 @@
                 <a:tableStyleId>{5C22544A-7EE6-4342-B048-85BDC9FD1C3A}</a:tableStyleId>
               </a:tblPr>
               <a:tblGrid>
-                <a:gridCol w="850900"/>
-                <a:gridCol w="850900"/>
-                <a:gridCol w="850900"/>
-                <a:gridCol w="850900"/>
-                <a:gridCol w="850900"/>
-                <a:gridCol w="850900"/>
+                <a:gridCol w="1701800"/>
+                <a:gridCol w="1701800"/>
+                <a:gridCol w="1701800"/>
               </a:tblGrid>
               <a:tr h="0">
                 <a:tc>
@@ -4239,7 +5140,7 @@
                       </a:pPr>
                       <a:r>
                         <a:rPr/>
-                        <a:t>Mechanism</a:t>
+                        <a:t>Capability</a:t>
                       </a:r>
                     </a:p>
                   </a:txBody>
@@ -4255,7 +5156,7 @@
                       </a:pPr>
                       <a:r>
                         <a:rPr/>
-                        <a:t>Scope</a:t>
+                        <a:t>Exists?</a:t>
                       </a:r>
                     </a:p>
                   </a:txBody>
@@ -4271,55 +5172,7 @@
                       </a:pPr>
                       <a:r>
                         <a:rPr/>
-                        <a:t>Deterministic?</a:t>
-                      </a:r>
-                    </a:p>
-                  </a:txBody>
-                  <a:tcPr/>
-                </a:tc>
-                <a:tc>
-                  <a:txBody>
-                    <a:bodyPr/>
-                    <a:lstStyle/>
-                    <a:p>
-                      <a:pPr lvl="0" indent="0" marL="0">
-                        <a:buNone/>
-                      </a:pPr>
-                      <a:r>
-                        <a:rPr/>
-                        <a:t>Speed</a:t>
-                      </a:r>
-                    </a:p>
-                  </a:txBody>
-                  <a:tcPr/>
-                </a:tc>
-                <a:tc>
-                  <a:txBody>
-                    <a:bodyPr/>
-                    <a:lstStyle/>
-                    <a:p>
-                      <a:pPr lvl="0" indent="0" marL="0">
-                        <a:buNone/>
-                      </a:pPr>
-                      <a:r>
-                        <a:rPr/>
-                        <a:t>Formal Verification</a:t>
-                      </a:r>
-                    </a:p>
-                  </a:txBody>
-                  <a:tcPr/>
-                </a:tc>
-                <a:tc>
-                  <a:txBody>
-                    <a:bodyPr/>
-                    <a:lstStyle/>
-                    <a:p>
-                      <a:pPr lvl="0" indent="0" marL="0">
-                        <a:buNone/>
-                      </a:pPr>
-                      <a:r>
-                        <a:rPr/>
-                        <a:t>Production Ready</a:t>
+                        <a:t>Notes</a:t>
                       </a:r>
                     </a:p>
                   </a:txBody>
@@ -4337,82 +5190,37 @@
                       </a:pPr>
                       <a:r>
                         <a:rPr b="1"/>
-                        <a:t>ZipperGen</a:t>
-                      </a:r>
-                    </a:p>
-                  </a:txBody>
-                </a:tc>
-                <a:tc>
-                  <a:txBody>
-                    <a:bodyPr/>
-                    <a:lstStyle/>
-                    <a:p>
-                      <a:pPr lvl="0" indent="0" marL="0">
-                        <a:buNone/>
-                      </a:pPr>
-                      <a:r>
-                        <a:rPr b="1"/>
-                        <a:t>Multi-agent</a:t>
-                      </a:r>
-                    </a:p>
-                  </a:txBody>
-                </a:tc>
-                <a:tc>
-                  <a:txBody>
-                    <a:bodyPr/>
-                    <a:lstStyle/>
-                    <a:p>
-                      <a:pPr lvl="0" indent="0" marL="0">
-                        <a:buNone/>
-                      </a:pPr>
-                      <a:r>
-                        <a:rPr/>
-                        <a:t>✅ Yes (coordination structure)</a:t>
-                      </a:r>
-                    </a:p>
-                  </a:txBody>
-                </a:tc>
-                <a:tc>
-                  <a:txBody>
-                    <a:bodyPr/>
-                    <a:lstStyle/>
-                    <a:p>
-                      <a:pPr lvl="0" indent="0" marL="0">
-                        <a:buNone/>
-                      </a:pPr>
-                      <a:r>
-                        <a:rPr/>
-                        <a:t>—</a:t>
-                      </a:r>
-                    </a:p>
-                  </a:txBody>
-                </a:tc>
-                <a:tc>
-                  <a:txBody>
-                    <a:bodyPr/>
-                    <a:lstStyle/>
-                    <a:p>
-                      <a:pPr lvl="0" indent="0" marL="0">
-                        <a:buNone/>
-                      </a:pPr>
-                      <a:r>
-                        <a:rPr/>
-                        <a:t>Structural induction proof</a:t>
-                      </a:r>
-                    </a:p>
-                  </a:txBody>
-                </a:tc>
-                <a:tc>
-                  <a:txBody>
-                    <a:bodyPr/>
-                    <a:lstStyle/>
-                    <a:p>
-                      <a:pPr lvl="0" indent="0" marL="0">
-                        <a:buNone/>
-                      </a:pPr>
-                      <a:r>
-                        <a:rPr/>
-                        <a:t>✅ Python impl</a:t>
+                        <a:t>Deterministic skill-level policy enforcement</a:t>
+                      </a:r>
+                    </a:p>
+                  </a:txBody>
+                </a:tc>
+                <a:tc>
+                  <a:txBody>
+                    <a:bodyPr/>
+                    <a:lstStyle/>
+                    <a:p>
+                      <a:pPr lvl="0" indent="0" marL="0">
+                        <a:buNone/>
+                      </a:pPr>
+                      <a:r>
+                        <a:rPr/>
+                        <a:t>✅ Yes</a:t>
+                      </a:r>
+                    </a:p>
+                  </a:txBody>
+                </a:tc>
+                <a:tc>
+                  <a:txBody>
+                    <a:bodyPr/>
+                    <a:lstStyle/>
+                    <a:p>
+                      <a:pPr lvl="0" indent="0" marL="0">
+                        <a:buNone/>
+                      </a:pPr>
+                      <a:r>
+                        <a:rPr/>
+                        <a:t>ABC, ACP, Runtime Governance (single-agent)</a:t>
                       </a:r>
                     </a:p>
                   </a:txBody>
@@ -4429,22 +5237,7 @@
                       </a:pPr>
                       <a:r>
                         <a:rPr b="1"/>
-                        <a:t>ACP</a:t>
-                      </a:r>
-                    </a:p>
-                  </a:txBody>
-                </a:tc>
-                <a:tc>
-                  <a:txBody>
-                    <a:bodyPr/>
-                    <a:lstStyle/>
-                    <a:p>
-                      <a:pPr lvl="0" indent="0" marL="0">
-                        <a:buNone/>
-                      </a:pPr>
-                      <a:r>
-                        <a:rPr/>
-                        <a:t>Single-agent</a:t>
+                        <a:t>Deterministic multi-agent coordination enforcement</a:t>
                       </a:r>
                     </a:p>
                   </a:txBody>
@@ -4473,38 +5266,12 @@
                         <a:buNone/>
                       </a:pPr>
                       <a:r>
-                        <a:rPr/>
-                        <a:t>739-832 ns</a:t>
-                      </a:r>
-                    </a:p>
-                  </a:txBody>
-                </a:tc>
-                <a:tc>
-                  <a:txBody>
-                    <a:bodyPr/>
-                    <a:lstStyle/>
-                    <a:p>
-                      <a:pPr lvl="0" indent="0" marL="0">
-                        <a:buNone/>
-                      </a:pPr>
-                      <a:r>
-                        <a:rPr/>
-                        <a:t>TLA+ (4.2B states)</a:t>
-                      </a:r>
-                    </a:p>
-                  </a:txBody>
-                </a:tc>
-                <a:tc>
-                  <a:txBody>
-                    <a:bodyPr/>
-                    <a:lstStyle/>
-                    <a:p>
-                      <a:pPr lvl="0" indent="0" marL="0">
-                        <a:buNone/>
-                      </a:pPr>
-                      <a:r>
-                        <a:rPr/>
-                        <a:t>✅ Go impl</a:t>
+                        <a:rPr b="1"/>
+                        <a:t>ZipperGen</a:t>
+                      </a:r>
+                      <a:r>
+                        <a:rPr/>
+                        <a:t> — message structure guaranteed correct; action content remains opaque</a:t>
                       </a:r>
                     </a:p>
                   </a:txBody>
@@ -4521,82 +5288,37 @@
                       </a:pPr>
                       <a:r>
                         <a:rPr b="1"/>
-                        <a:t>ABC / AgentAssert</a:t>
-                      </a:r>
-                    </a:p>
-                  </a:txBody>
-                </a:tc>
-                <a:tc>
-                  <a:txBody>
-                    <a:bodyPr/>
-                    <a:lstStyle/>
-                    <a:p>
-                      <a:pPr lvl="0" indent="0" marL="0">
-                        <a:buNone/>
-                      </a:pPr>
-                      <a:r>
-                        <a:rPr/>
-                        <a:t>Single-agent</a:t>
-                      </a:r>
-                    </a:p>
-                  </a:txBody>
-                </a:tc>
-                <a:tc>
-                  <a:txBody>
-                    <a:bodyPr/>
-                    <a:lstStyle/>
-                    <a:p>
-                      <a:pPr lvl="0" indent="0" marL="0">
-                        <a:buNone/>
-                      </a:pPr>
-                      <a:r>
-                        <a:rPr/>
-                        <a:t>✅ Mostly</a:t>
-                      </a:r>
-                    </a:p>
-                  </a:txBody>
-                </a:tc>
-                <a:tc>
-                  <a:txBody>
-                    <a:bodyPr/>
-                    <a:lstStyle/>
-                    <a:p>
-                      <a:pPr lvl="0" indent="0" marL="0">
-                        <a:buNone/>
-                      </a:pPr>
-                      <a:r>
-                        <a:rPr/>
-                        <a:t>&lt;10 ms</a:t>
-                      </a:r>
-                    </a:p>
-                  </a:txBody>
-                </a:tc>
-                <a:tc>
-                  <a:txBody>
-                    <a:bodyPr/>
-                    <a:lstStyle/>
-                    <a:p>
-                      <a:pPr lvl="0" indent="0" marL="0">
-                        <a:buNone/>
-                      </a:pPr>
-                      <a:r>
-                        <a:rPr/>
-                        <a:t>Drift Bounds Theorem</a:t>
-                      </a:r>
-                    </a:p>
-                  </a:txBody>
-                </a:tc>
-                <a:tc>
-                  <a:txBody>
-                    <a:bodyPr/>
-                    <a:lstStyle/>
-                    <a:p>
-                      <a:pPr lvl="0" indent="0" marL="0">
-                        <a:buNone/>
-                      </a:pPr>
-                      <a:r>
-                        <a:rPr/>
-                        <a:t>✅ Library</a:t>
+                        <a:t>Sub-microsecond enforcement</a:t>
+                      </a:r>
+                    </a:p>
+                  </a:txBody>
+                </a:tc>
+                <a:tc>
+                  <a:txBody>
+                    <a:bodyPr/>
+                    <a:lstStyle/>
+                    <a:p>
+                      <a:pPr lvl="0" indent="0" marL="0">
+                        <a:buNone/>
+                      </a:pPr>
+                      <a:r>
+                        <a:rPr/>
+                        <a:t>✅ Yes</a:t>
+                      </a:r>
+                    </a:p>
+                  </a:txBody>
+                </a:tc>
+                <a:tc>
+                  <a:txBody>
+                    <a:bodyPr/>
+                    <a:lstStyle/>
+                    <a:p>
+                      <a:pPr lvl="0" indent="0" marL="0">
+                        <a:buNone/>
+                      </a:pPr>
+                      <a:r>
+                        <a:rPr/>
+                        <a:t>ACP (739-832 ns)</a:t>
                       </a:r>
                     </a:p>
                   </a:txBody>
@@ -4613,22 +5335,7 @@
                       </a:pPr>
                       <a:r>
                         <a:rPr b="1"/>
-                        <a:t>Runtime Governance</a:t>
-                      </a:r>
-                    </a:p>
-                  </a:txBody>
-                </a:tc>
-                <a:tc>
-                  <a:txBody>
-                    <a:bodyPr/>
-                    <a:lstStyle/>
-                    <a:p>
-                      <a:pPr lvl="0" indent="0" marL="0">
-                        <a:buNone/>
-                      </a:pPr>
-                      <a:r>
-                        <a:rPr/>
-                        <a:t>Single-agent</a:t>
+                        <a:t>Formally verified runtime</a:t>
                       </a:r>
                     </a:p>
                   </a:txBody>
@@ -4658,37 +5365,7 @@
                       </a:pPr>
                       <a:r>
                         <a:rPr/>
-                        <a:t>Polynomial</a:t>
-                      </a:r>
-                    </a:p>
-                  </a:txBody>
-                </a:tc>
-                <a:tc>
-                  <a:txBody>
-                    <a:bodyPr/>
-                    <a:lstStyle/>
-                    <a:p>
-                      <a:pPr lvl="0" indent="0" marL="0">
-                        <a:buNone/>
-                      </a:pPr>
-                      <a:r>
-                        <a:rPr/>
-                        <a:t>Framework</a:t>
-                      </a:r>
-                    </a:p>
-                  </a:txBody>
-                </a:tc>
-                <a:tc>
-                  <a:txBody>
-                    <a:bodyPr/>
-                    <a:lstStyle/>
-                    <a:p>
-                      <a:pPr lvl="0" indent="0" marL="0">
-                        <a:buNone/>
-                      </a:pPr>
-                      <a:r>
-                        <a:rPr/>
-                        <a:t>⚠️ Proposed</a:t>
+                        <a:t>ACP (TLA+), SentinelAgent (TLA+), ZipperGen (structural induction)</a:t>
                       </a:r>
                     </a:p>
                   </a:txBody>
@@ -4705,82 +5382,41 @@
                       </a:pPr>
                       <a:r>
                         <a:rPr b="1"/>
-                        <a:t>AgentVerify</a:t>
-                      </a:r>
-                    </a:p>
-                  </a:txBody>
-                </a:tc>
-                <a:tc>
-                  <a:txBody>
-                    <a:bodyPr/>
-                    <a:lstStyle/>
-                    <a:p>
-                      <a:pPr lvl="0" indent="0" marL="0">
-                        <a:buNone/>
-                      </a:pPr>
-                      <a:r>
-                        <a:rPr/>
-                        <a:t>Single-agent</a:t>
-                      </a:r>
-                    </a:p>
-                  </a:txBody>
-                </a:tc>
-                <a:tc>
-                  <a:txBody>
-                    <a:bodyPr/>
-                    <a:lstStyle/>
-                    <a:p>
-                      <a:pPr lvl="0" indent="0" marL="0">
-                        <a:buNone/>
-                      </a:pPr>
-                      <a:r>
-                        <a:rPr/>
-                        <a:t>⚠️ Hybrid</a:t>
-                      </a:r>
-                    </a:p>
-                  </a:txBody>
-                </a:tc>
-                <a:tc>
-                  <a:txBody>
-                    <a:bodyPr/>
-                    <a:lstStyle/>
-                    <a:p>
-                      <a:pPr lvl="0" indent="0" marL="0">
-                        <a:buNone/>
-                      </a:pPr>
-                      <a:r>
-                        <a:rPr/>
-                        <a:t>O(1) monitor</a:t>
-                      </a:r>
-                    </a:p>
-                  </a:txBody>
-                </a:tc>
-                <a:tc>
-                  <a:txBody>
-                    <a:bodyPr/>
-                    <a:lstStyle/>
-                    <a:p>
-                      <a:pPr lvl="0" indent="0" marL="0">
-                        <a:buNone/>
-                      </a:pPr>
-                      <a:r>
-                        <a:rPr/>
-                        <a:t>LTL model checking</a:t>
-                      </a:r>
-                    </a:p>
-                  </a:txBody>
-                </a:tc>
-                <a:tc>
-                  <a:txBody>
-                    <a:bodyPr/>
-                    <a:lstStyle/>
-                    <a:p>
-                      <a:pPr lvl="0" indent="0" marL="0">
-                        <a:buNone/>
-                      </a:pPr>
-                      <a:r>
-                        <a:rPr/>
-                        <a:t>⚠️ Research</a:t>
+                        <a:t>MPST-style session type enforcement</a:t>
+                      </a:r>
+                    </a:p>
+                  </a:txBody>
+                </a:tc>
+                <a:tc>
+                  <a:txBody>
+                    <a:bodyPr/>
+                    <a:lstStyle/>
+                    <a:p>
+                      <a:pPr lvl="0" indent="0" marL="0">
+                        <a:buNone/>
+                      </a:pPr>
+                      <a:r>
+                        <a:rPr/>
+                        <a:t>✅ Yes</a:t>
+                      </a:r>
+                    </a:p>
+                  </a:txBody>
+                </a:tc>
+                <a:tc>
+                  <a:txBody>
+                    <a:bodyPr/>
+                    <a:lstStyle/>
+                    <a:p>
+                      <a:pPr lvl="0" indent="0" marL="0">
+                        <a:buNone/>
+                      </a:pPr>
+                      <a:r>
+                        <a:rPr b="1"/>
+                        <a:t>ZipperGen</a:t>
+                      </a:r>
+                      <a:r>
+                        <a:rPr/>
+                        <a:t> — MSC-based DSL with syntax-directed projection</a:t>
                       </a:r>
                     </a:p>
                   </a:txBody>
@@ -4797,82 +5433,37 @@
                       </a:pPr>
                       <a:r>
                         <a:rPr b="1"/>
-                        <a:t>SentinelAgent</a:t>
-                      </a:r>
-                    </a:p>
-                  </a:txBody>
-                </a:tc>
-                <a:tc>
-                  <a:txBody>
-                    <a:bodyPr/>
-                    <a:lstStyle/>
-                    <a:p>
-                      <a:pPr lvl="0" indent="0" marL="0">
-                        <a:buNone/>
-                      </a:pPr>
-                      <a:r>
-                        <a:rPr/>
-                        <a:t>Single-agent</a:t>
-                      </a:r>
-                    </a:p>
-                  </a:txBody>
-                </a:tc>
-                <a:tc>
-                  <a:txBody>
-                    <a:bodyPr/>
-                    <a:lstStyle/>
-                    <a:p>
-                      <a:pPr lvl="0" indent="0" marL="0">
-                        <a:buNone/>
-                      </a:pPr>
-                      <a:r>
-                        <a:rPr/>
-                        <a:t>✅ Yes</a:t>
-                      </a:r>
-                    </a:p>
-                  </a:txBody>
-                </a:tc>
-                <a:tc>
-                  <a:txBody>
-                    <a:bodyPr/>
-                    <a:lstStyle/>
-                    <a:p>
-                      <a:pPr lvl="0" indent="0" marL="0">
-                        <a:buNone/>
-                      </a:pPr>
-                      <a:r>
-                        <a:rPr/>
-                        <a:t>—</a:t>
-                      </a:r>
-                    </a:p>
-                  </a:txBody>
-                </a:tc>
-                <a:tc>
-                  <a:txBody>
-                    <a:bodyPr/>
-                    <a:lstStyle/>
-                    <a:p>
-                      <a:pPr lvl="0" indent="0" marL="0">
-                        <a:buNone/>
-                      </a:pPr>
-                      <a:r>
-                        <a:rPr/>
-                        <a:t>TLA+ (2.7M states)</a:t>
-                      </a:r>
-                    </a:p>
-                  </a:txBody>
-                </a:tc>
-                <a:tc>
-                  <a:txBody>
-                    <a:bodyPr/>
-                    <a:lstStyle/>
-                    <a:p>
-                      <a:pPr lvl="0" indent="0" marL="0">
-                        <a:buNone/>
-                      </a:pPr>
-                      <a:r>
-                        <a:rPr/>
-                        <a:t>⚠️ Research</a:t>
+                        <a:t>Behavioral typing of message content</a:t>
+                      </a:r>
+                    </a:p>
+                  </a:txBody>
+                </a:tc>
+                <a:tc>
+                  <a:txBody>
+                    <a:bodyPr/>
+                    <a:lstStyle/>
+                    <a:p>
+                      <a:pPr lvl="0" indent="0" marL="0">
+                        <a:buNone/>
+                      </a:pPr>
+                      <a:r>
+                        <a:rPr/>
+                        <a:t>❌ No</a:t>
+                      </a:r>
+                    </a:p>
+                  </a:txBody>
+                </a:tc>
+                <a:tc>
+                  <a:txBody>
+                    <a:bodyPr/>
+                    <a:lstStyle/>
+                    <a:p>
+                      <a:pPr lvl="0" indent="0" marL="0">
+                        <a:buNone/>
+                      </a:pPr>
+                      <a:r>
+                        <a:rPr/>
+                        <a:t>ZipperGen checks structure, not what LLMs put inside messages</a:t>
                       </a:r>
                     </a:p>
                   </a:txBody>
@@ -4889,82 +5480,37 @@
                       </a:pPr>
                       <a:r>
                         <a:rPr b="1"/>
-                        <a:t>Trace-Based Assurance</a:t>
-                      </a:r>
-                    </a:p>
-                  </a:txBody>
-                </a:tc>
-                <a:tc>
-                  <a:txBody>
-                    <a:bodyPr/>
-                    <a:lstStyle/>
-                    <a:p>
-                      <a:pPr lvl="0" indent="0" marL="0">
-                        <a:buNone/>
-                      </a:pPr>
-                      <a:r>
-                        <a:rPr/>
-                        <a:t>Single-agent</a:t>
-                      </a:r>
-                    </a:p>
-                  </a:txBody>
-                </a:tc>
-                <a:tc>
-                  <a:txBody>
-                    <a:bodyPr/>
-                    <a:lstStyle/>
-                    <a:p>
-                      <a:pPr lvl="0" indent="0" marL="0">
-                        <a:buNone/>
-                      </a:pPr>
-                      <a:r>
-                        <a:rPr/>
-                        <a:t>✅ Yes</a:t>
-                      </a:r>
-                    </a:p>
-                  </a:txBody>
-                </a:tc>
-                <a:tc>
-                  <a:txBody>
-                    <a:bodyPr/>
-                    <a:lstStyle/>
-                    <a:p>
-                      <a:pPr lvl="0" indent="0" marL="0">
-                        <a:buNone/>
-                      </a:pPr>
-                      <a:r>
-                        <a:rPr/>
-                        <a:t>—</a:t>
-                      </a:r>
-                    </a:p>
-                  </a:txBody>
-                </a:tc>
-                <a:tc>
-                  <a:txBody>
-                    <a:bodyPr/>
-                    <a:lstStyle/>
-                    <a:p>
-                      <a:pPr lvl="0" indent="0" marL="0">
-                        <a:buNone/>
-                      </a:pPr>
-                      <a:r>
-                        <a:rPr/>
-                        <a:t>Replay-based</a:t>
-                      </a:r>
-                    </a:p>
-                  </a:txBody>
-                </a:tc>
-                <a:tc>
-                  <a:txBody>
-                    <a:bodyPr/>
-                    <a:lstStyle/>
-                    <a:p>
-                      <a:pPr lvl="0" indent="0" marL="0">
-                        <a:buNone/>
-                      </a:pPr>
-                      <a:r>
-                        <a:rPr/>
-                        <a:t>⚠️ Complex</a:t>
+                        <a:t>Deterministic skill composition verification</a:t>
+                      </a:r>
+                    </a:p>
+                  </a:txBody>
+                </a:tc>
+                <a:tc>
+                  <a:txBody>
+                    <a:bodyPr/>
+                    <a:lstStyle/>
+                    <a:p>
+                      <a:pPr lvl="0" indent="0" marL="0">
+                        <a:buNone/>
+                      </a:pPr>
+                      <a:r>
+                        <a:rPr/>
+                        <a:t>❌ No</a:t>
+                      </a:r>
+                    </a:p>
+                  </a:txBody>
+                </a:tc>
+                <a:tc>
+                  <a:txBody>
+                    <a:bodyPr/>
+                    <a:lstStyle/>
+                    <a:p>
+                      <a:pPr lvl="0" indent="0" marL="0">
+                        <a:buNone/>
+                      </a:pPr>
+                      <a:r>
+                        <a:rPr/>
+                        <a:t>No static analysis of how multiple skills compose within a single agent</a:t>
                       </a:r>
                     </a:p>
                   </a:txBody>
@@ -4981,22 +5527,7 @@
                       </a:pPr>
                       <a:r>
                         <a:rPr b="1"/>
-                        <a:t>BeSafe-Bench</a:t>
-                      </a:r>
-                    </a:p>
-                  </a:txBody>
-                </a:tc>
-                <a:tc>
-                  <a:txBody>
-                    <a:bodyPr/>
-                    <a:lstStyle/>
-                    <a:p>
-                      <a:pPr lvl="0" indent="0" marL="0">
-                        <a:buNone/>
-                      </a:pPr>
-                      <a:r>
-                        <a:rPr/>
-                        <a:t>Benchmark</a:t>
+                        <a:t>Behavioral typing with blame</a:t>
                       </a:r>
                     </a:p>
                   </a:txBody>
@@ -5026,37 +5557,7 @@
                       </a:pPr>
                       <a:r>
                         <a:rPr/>
-                        <a:t>—</a:t>
-                      </a:r>
-                    </a:p>
-                  </a:txBody>
-                </a:tc>
-                <a:tc>
-                  <a:txBody>
-                    <a:bodyPr/>
-                    <a:lstStyle/>
-                    <a:p>
-                      <a:pPr lvl="0" indent="0" marL="0">
-                        <a:buNone/>
-                      </a:pPr>
-                      <a:r>
-                        <a:rPr/>
-                        <a:t>—</a:t>
-                      </a:r>
-                    </a:p>
-                  </a:txBody>
-                </a:tc>
-                <a:tc>
-                  <a:txBody>
-                    <a:bodyPr/>
-                    <a:lstStyle/>
-                    <a:p>
-                      <a:pPr lvl="0" indent="0" marL="0">
-                        <a:buNone/>
-                      </a:pPr>
-                      <a:r>
-                        <a:rPr/>
-                        <a:t>✅ Benchmark</a:t>
+                        <a:t>No blame assignment when agents violate protocols</a:t>
                       </a:r>
                     </a:p>
                   </a:txBody>
@@ -5073,82 +5574,37 @@
                       </a:pPr>
                       <a:r>
                         <a:rPr b="1"/>
-                        <a:t>ST-WebAgentBench</a:t>
-                      </a:r>
-                    </a:p>
-                  </a:txBody>
-                </a:tc>
-                <a:tc>
-                  <a:txBody>
-                    <a:bodyPr/>
-                    <a:lstStyle/>
-                    <a:p>
-                      <a:pPr lvl="0" indent="0" marL="0">
-                        <a:buNone/>
-                      </a:pPr>
-                      <a:r>
-                        <a:rPr/>
-                        <a:t>Benchmark</a:t>
-                      </a:r>
-                    </a:p>
-                  </a:txBody>
-                </a:tc>
-                <a:tc>
-                  <a:txBody>
-                    <a:bodyPr/>
-                    <a:lstStyle/>
-                    <a:p>
-                      <a:pPr lvl="0" indent="0" marL="0">
-                        <a:buNone/>
-                      </a:pPr>
-                      <a:r>
-                        <a:rPr/>
-                        <a:t>❌ No</a:t>
-                      </a:r>
-                    </a:p>
-                  </a:txBody>
-                </a:tc>
-                <a:tc>
-                  <a:txBody>
-                    <a:bodyPr/>
-                    <a:lstStyle/>
-                    <a:p>
-                      <a:pPr lvl="0" indent="0" marL="0">
-                        <a:buNone/>
-                      </a:pPr>
-                      <a:r>
-                        <a:rPr/>
-                        <a:t>—</a:t>
-                      </a:r>
-                    </a:p>
-                  </a:txBody>
-                </a:tc>
-                <a:tc>
-                  <a:txBody>
-                    <a:bodyPr/>
-                    <a:lstStyle/>
-                    <a:p>
-                      <a:pPr lvl="0" indent="0" marL="0">
-                        <a:buNone/>
-                      </a:pPr>
-                      <a:r>
-                        <a:rPr/>
-                        <a:t>—</a:t>
-                      </a:r>
-                    </a:p>
-                  </a:txBody>
-                </a:tc>
-                <a:tc>
-                  <a:txBody>
-                    <a:bodyPr/>
-                    <a:lstStyle/>
-                    <a:p>
-                      <a:pPr lvl="0" indent="0" marL="0">
-                        <a:buNone/>
-                      </a:pPr>
-                      <a:r>
-                        <a:rPr/>
-                        <a:t>✅ Benchmark</a:t>
+                        <a:t>Real-time rollback on violation</a:t>
+                      </a:r>
+                    </a:p>
+                  </a:txBody>
+                </a:tc>
+                <a:tc>
+                  <a:txBody>
+                    <a:bodyPr/>
+                    <a:lstStyle/>
+                    <a:p>
+                      <a:pPr lvl="0" indent="0" marL="0">
+                        <a:buNone/>
+                      </a:pPr>
+                      <a:r>
+                        <a:rPr/>
+                        <a:t>⚠️ Partial</a:t>
+                      </a:r>
+                    </a:p>
+                  </a:txBody>
+                </a:tc>
+                <a:tc>
+                  <a:txBody>
+                    <a:bodyPr/>
+                    <a:lstStyle/>
+                    <a:p>
+                      <a:pPr lvl="0" indent="0" marL="0">
+                        <a:buNone/>
+                      </a:pPr>
+                      <a:r>
+                        <a:rPr/>
+                        <a:t>ABC has Recovery (R) contracts; not automatic rollback</a:t>
                       </a:r>
                     </a:p>
                   </a:txBody>
@@ -5164,6 +5620,65 @@
 </file>
 
 <file path=ppt/slides/slide16.xml><?xml version="1.0" encoding="utf-8"?>
+<p:sld xmlns:a="http://schemas.openxmlformats.org/drawingml/2006/main" xmlns:r="http://schemas.openxmlformats.org/officeDocument/2006/relationships" xmlns:p="http://schemas.openxmlformats.org/presentationml/2006/main">
+  <p:cSld>
+    <p:spTree>
+      <p:nvGrpSpPr>
+        <p:cNvPr id="1" name=""/>
+        <p:cNvGrpSpPr/>
+        <p:nvPr/>
+      </p:nvGrpSpPr>
+      <p:grpSpPr>
+        <a:xfrm>
+          <a:off x="0" y="0"/>
+          <a:ext cx="0" cy="0"/>
+          <a:chOff x="0" y="0"/>
+          <a:chExt cx="0" cy="0"/>
+        </a:xfrm>
+      </p:grpSpPr>
+      <p:sp>
+        <p:nvSpPr>
+          <p:cNvPr id="3" name="Content Placeholder 2"/>
+          <p:cNvSpPr>
+            <a:spLocks noGrp="1"/>
+          </p:cNvSpPr>
+          <p:nvPr>
+            <p:ph idx="1"/>
+          </p:nvPr>
+        </p:nvSpPr>
+        <p:spPr/>
+        <p:txBody>
+          <a:bodyPr/>
+          <a:lstStyle/>
+          <a:p>
+            <a:pPr lvl="0" indent="0" marL="0">
+              <a:spcBef>
+                <a:spcPts val="3000"/>
+              </a:spcBef>
+              <a:buNone/>
+            </a:pPr>
+            <a:r>
+              <a:rPr b="1"/>
+              <a:t>Verdict on Question 3</a:t>
+            </a:r>
+          </a:p>
+          <a:p>
+            <a:pPr lvl="0" indent="0" marL="1270000">
+              <a:buNone/>
+            </a:pPr>
+            <a:r>
+              <a:rPr sz="2000" b="1"/>
+              <a:t>Deterministic runtime enforcement exists at both single-agent (ACP, ABC/AgentAssert) and multi-agent (ZipperGen) levels. ZipperGen is the breakthrough: it guarantees deadlock-free coordination regardless of LLM nondeterminism, by separating deterministic message structure (enforced) from stochastic actions (opaque). The remaining gap is not “does MPST exist for agents?” — it does — but “can we type-check the content of LLM actions within that structure?”</a:t>
+            </a:r>
+          </a:p>
+        </p:txBody>
+      </p:sp>
+    </p:spTree>
+  </p:cSld>
+</p:sld>
+</file>
+
+<file path=ppt/slides/slide17.xml><?xml version="1.0" encoding="utf-8"?>
 <p:sld xmlns:a="http://schemas.openxmlformats.org/drawingml/2006/main" xmlns:r="http://schemas.openxmlformats.org/officeDocument/2006/relationships" xmlns:p="http://schemas.openxmlformats.org/presentationml/2006/main">
   <p:cSld>
     <p:spTree>
@@ -5203,7 +5718,19 @@
             </a:pPr>
             <a:r>
               <a:rPr b="1"/>
-              <a:t>What Is Missing (The Gap) — UPDATED with ZipperGen</a:t>
+              <a:t>Overall Assessment</a:t>
+            </a:r>
+          </a:p>
+          <a:p>
+            <a:pPr lvl="0" indent="0" marL="0">
+              <a:spcBef>
+                <a:spcPts val="3000"/>
+              </a:spcBef>
+              <a:buNone/>
+            </a:pPr>
+            <a:r>
+              <a:rPr b="1"/>
+              <a:t>The Three Questions — Comprehensive Synthesis</a:t>
             </a:r>
           </a:p>
         </p:txBody>
@@ -5229,9 +5756,11 @@
                 <a:tableStyleId>{5C22544A-7EE6-4342-B048-85BDC9FD1C3A}</a:tableStyleId>
               </a:tblPr>
               <a:tblGrid>
-                <a:gridCol w="1701800"/>
-                <a:gridCol w="1701800"/>
-                <a:gridCol w="1701800"/>
+                <a:gridCol w="1016000"/>
+                <a:gridCol w="1016000"/>
+                <a:gridCol w="1016000"/>
+                <a:gridCol w="1016000"/>
+                <a:gridCol w="1016000"/>
               </a:tblGrid>
               <a:tr h="0">
                 <a:tc>
@@ -5244,7 +5773,7 @@
                       </a:pPr>
                       <a:r>
                         <a:rPr/>
-                        <a:t>Capability</a:t>
+                        <a:t>Question</a:t>
                       </a:r>
                     </a:p>
                   </a:txBody>
@@ -5260,7 +5789,7 @@
                       </a:pPr>
                       <a:r>
                         <a:rPr/>
-                        <a:t>Exists?</a:t>
+                        <a:t>Status</a:t>
                       </a:r>
                     </a:p>
                   </a:txBody>
@@ -5276,7 +5805,39 @@
                       </a:pPr>
                       <a:r>
                         <a:rPr/>
-                        <a:t>Notes</a:t>
+                        <a:t>Best Existing Work</a:t>
+                      </a:r>
+                    </a:p>
+                  </a:txBody>
+                  <a:tcPr/>
+                </a:tc>
+                <a:tc>
+                  <a:txBody>
+                    <a:bodyPr/>
+                    <a:lstStyle/>
+                    <a:p>
+                      <a:pPr lvl="0" indent="0" marL="0">
+                        <a:buNone/>
+                      </a:pPr>
+                      <a:r>
+                        <a:rPr/>
+                        <a:t>What ZipperGen Changes</a:t>
+                      </a:r>
+                    </a:p>
+                  </a:txBody>
+                  <a:tcPr/>
+                </a:tc>
+                <a:tc>
+                  <a:txBody>
+                    <a:bodyPr/>
+                    <a:lstStyle/>
+                    <a:p>
+                      <a:pPr lvl="0" indent="0" marL="0">
+                        <a:buNone/>
+                      </a:pPr>
+                      <a:r>
+                        <a:rPr/>
+                        <a:t>What Remains Open</a:t>
                       </a:r>
                     </a:p>
                   </a:txBody>
@@ -5294,37 +5855,67 @@
                       </a:pPr>
                       <a:r>
                         <a:rPr b="1"/>
-                        <a:t>Deterministic skill-level policy enforcement</a:t>
-                      </a:r>
-                    </a:p>
-                  </a:txBody>
-                </a:tc>
-                <a:tc>
-                  <a:txBody>
-                    <a:bodyPr/>
-                    <a:lstStyle/>
-                    <a:p>
-                      <a:pPr lvl="0" indent="0" marL="0">
-                        <a:buNone/>
-                      </a:pPr>
-                      <a:r>
-                        <a:rPr/>
-                        <a:t>✅ Yes</a:t>
-                      </a:r>
-                    </a:p>
-                  </a:txBody>
-                </a:tc>
-                <a:tc>
-                  <a:txBody>
-                    <a:bodyPr/>
-                    <a:lstStyle/>
-                    <a:p>
-                      <a:pPr lvl="0" indent="0" marL="0">
-                        <a:buNone/>
-                      </a:pPr>
-                      <a:r>
-                        <a:rPr/>
-                        <a:t>ABC, ACP, Runtime Governance (single-agent)</a:t>
+                        <a:t>1. Do skills affect behavior?</a:t>
+                      </a:r>
+                    </a:p>
+                  </a:txBody>
+                </a:tc>
+                <a:tc>
+                  <a:txBody>
+                    <a:bodyPr/>
+                    <a:lstStyle/>
+                    <a:p>
+                      <a:pPr lvl="0" indent="0" marL="0">
+                        <a:buNone/>
+                      </a:pPr>
+                      <a:r>
+                        <a:rPr/>
+                        <a:t>✅ Yes, empirically</a:t>
+                      </a:r>
+                    </a:p>
+                  </a:txBody>
+                </a:tc>
+                <a:tc>
+                  <a:txBody>
+                    <a:bodyPr/>
+                    <a:lstStyle/>
+                    <a:p>
+                      <a:pPr lvl="0" indent="0" marL="0">
+                        <a:buNone/>
+                      </a:pPr>
+                      <a:r>
+                        <a:rPr/>
+                        <a:t>BIV, SSL Survey, GovernSpec</a:t>
+                      </a:r>
+                    </a:p>
+                  </a:txBody>
+                </a:tc>
+                <a:tc>
+                  <a:txBody>
+                    <a:bodyPr/>
+                    <a:lstStyle/>
+                    <a:p>
+                      <a:pPr lvl="0" indent="0" marL="0">
+                        <a:buNone/>
+                      </a:pPr>
+                      <a:r>
+                        <a:rPr/>
+                        <a:t>ZipperGen does not directly address this, but its runtime planning extension shows LLMs can generate coordination structures that are formally guaranteed</a:t>
+                      </a:r>
+                    </a:p>
+                  </a:txBody>
+                </a:tc>
+                <a:tc>
+                  <a:txBody>
+                    <a:bodyPr/>
+                    <a:lstStyle/>
+                    <a:p>
+                      <a:pPr lvl="0" indent="0" marL="0">
+                        <a:buNone/>
+                      </a:pPr>
+                      <a:r>
+                        <a:rPr/>
+                        <a:t>Proving deterministic mandate from skill markdown alone — impossible without L3 enforcement</a:t>
                       </a:r>
                     </a:p>
                   </a:txBody>
@@ -5341,22 +5932,22 @@
                       </a:pPr>
                       <a:r>
                         <a:rPr b="1"/>
-                        <a:t>Deterministic multi-agent coordination enforcement</a:t>
-                      </a:r>
-                    </a:p>
-                  </a:txBody>
-                </a:tc>
-                <a:tc>
-                  <a:txBody>
-                    <a:bodyPr/>
-                    <a:lstStyle/>
-                    <a:p>
-                      <a:pPr lvl="0" indent="0" marL="0">
-                        <a:buNone/>
-                      </a:pPr>
-                      <a:r>
-                        <a:rPr/>
-                        <a:t>✅ Yes</a:t>
+                        <a:t>2. Static type checking?</a:t>
+                      </a:r>
+                    </a:p>
+                  </a:txBody>
+                </a:tc>
+                <a:tc>
+                  <a:txBody>
+                    <a:bodyPr/>
+                    <a:lstStyle/>
+                    <a:p>
+                      <a:pPr lvl="0" indent="0" marL="0">
+                        <a:buNone/>
+                      </a:pPr>
+                      <a:r>
+                        <a:rPr/>
+                        <a:t>✅ Yes for multi-agent</a:t>
                       </a:r>
                     </a:p>
                   </a:txBody>
@@ -5375,7 +5966,41 @@
                       </a:r>
                       <a:r>
                         <a:rPr/>
-                        <a:t> — message structure guaranteed correct; action content remains opaque</a:t>
+                        <a:t> — formal well-typedness checks, deadlock-free by construction</a:t>
+                      </a:r>
+                    </a:p>
+                  </a:txBody>
+                </a:tc>
+                <a:tc>
+                  <a:txBody>
+                    <a:bodyPr/>
+                    <a:lstStyle/>
+                    <a:p>
+                      <a:pPr lvl="0" indent="0" marL="0">
+                        <a:buNone/>
+                      </a:pPr>
+                      <a:r>
+                        <a:rPr b="1"/>
+                        <a:t>Closes the MPST gap:</a:t>
+                      </a:r>
+                      <a:r>
+                        <a:rPr/>
+                        <a:t> formal global specs + deterministic local projection</a:t>
+                      </a:r>
+                    </a:p>
+                  </a:txBody>
+                </a:tc>
+                <a:tc>
+                  <a:txBody>
+                    <a:bodyPr/>
+                    <a:lstStyle/>
+                    <a:p>
+                      <a:pPr lvl="0" indent="0" marL="0">
+                        <a:buNone/>
+                      </a:pPr>
+                      <a:r>
+                        <a:rPr/>
+                        <a:t>Behavioral typing of LLM action content; skill-skill composition within single agent</a:t>
                       </a:r>
                     </a:p>
                   </a:txBody>
@@ -5392,116 +6017,22 @@
                       </a:pPr>
                       <a:r>
                         <a:rPr b="1"/>
-                        <a:t>Sub-microsecond enforcement</a:t>
-                      </a:r>
-                    </a:p>
-                  </a:txBody>
-                </a:tc>
-                <a:tc>
-                  <a:txBody>
-                    <a:bodyPr/>
-                    <a:lstStyle/>
-                    <a:p>
-                      <a:pPr lvl="0" indent="0" marL="0">
-                        <a:buNone/>
-                      </a:pPr>
-                      <a:r>
-                        <a:rPr/>
-                        <a:t>✅ Yes</a:t>
-                      </a:r>
-                    </a:p>
-                  </a:txBody>
-                </a:tc>
-                <a:tc>
-                  <a:txBody>
-                    <a:bodyPr/>
-                    <a:lstStyle/>
-                    <a:p>
-                      <a:pPr lvl="0" indent="0" marL="0">
-                        <a:buNone/>
-                      </a:pPr>
-                      <a:r>
-                        <a:rPr/>
-                        <a:t>ACP (739-832 ns)</a:t>
-                      </a:r>
-                    </a:p>
-                  </a:txBody>
-                </a:tc>
-              </a:tr>
-              <a:tr h="0">
-                <a:tc>
-                  <a:txBody>
-                    <a:bodyPr/>
-                    <a:lstStyle/>
-                    <a:p>
-                      <a:pPr lvl="0" indent="0" marL="0">
-                        <a:buNone/>
-                      </a:pPr>
-                      <a:r>
-                        <a:rPr b="1"/>
-                        <a:t>Formally verified runtime</a:t>
-                      </a:r>
-                    </a:p>
-                  </a:txBody>
-                </a:tc>
-                <a:tc>
-                  <a:txBody>
-                    <a:bodyPr/>
-                    <a:lstStyle/>
-                    <a:p>
-                      <a:pPr lvl="0" indent="0" marL="0">
-                        <a:buNone/>
-                      </a:pPr>
-                      <a:r>
-                        <a:rPr/>
-                        <a:t>✅ Yes</a:t>
-                      </a:r>
-                    </a:p>
-                  </a:txBody>
-                </a:tc>
-                <a:tc>
-                  <a:txBody>
-                    <a:bodyPr/>
-                    <a:lstStyle/>
-                    <a:p>
-                      <a:pPr lvl="0" indent="0" marL="0">
-                        <a:buNone/>
-                      </a:pPr>
-                      <a:r>
-                        <a:rPr/>
-                        <a:t>ACP (TLA+), SentinelAgent (TLA+), ZipperGen (structural induction)</a:t>
-                      </a:r>
-                    </a:p>
-                  </a:txBody>
-                </a:tc>
-              </a:tr>
-              <a:tr h="0">
-                <a:tc>
-                  <a:txBody>
-                    <a:bodyPr/>
-                    <a:lstStyle/>
-                    <a:p>
-                      <a:pPr lvl="0" indent="0" marL="0">
-                        <a:buNone/>
-                      </a:pPr>
-                      <a:r>
-                        <a:rPr b="1"/>
-                        <a:t>MPST-style session type enforcement</a:t>
-                      </a:r>
-                    </a:p>
-                  </a:txBody>
-                </a:tc>
-                <a:tc>
-                  <a:txBody>
-                    <a:bodyPr/>
-                    <a:lstStyle/>
-                    <a:p>
-                      <a:pPr lvl="0" indent="0" marL="0">
-                        <a:buNone/>
-                      </a:pPr>
-                      <a:r>
-                        <a:rPr/>
-                        <a:t>✅ Yes</a:t>
+                        <a:t>3. Deterministic runtime?</a:t>
+                      </a:r>
+                    </a:p>
+                  </a:txBody>
+                </a:tc>
+                <a:tc>
+                  <a:txBody>
+                    <a:bodyPr/>
+                    <a:lstStyle/>
+                    <a:p>
+                      <a:pPr lvl="0" indent="0" marL="0">
+                        <a:buNone/>
+                      </a:pPr>
+                      <a:r>
+                        <a:rPr/>
+                        <a:t>✅ Yes for multi-agent</a:t>
                       </a:r>
                     </a:p>
                   </a:txBody>
@@ -5520,13 +6051,11 @@
                       </a:r>
                       <a:r>
                         <a:rPr/>
-                        <a:t> — MSC-based DSL with syntax-directed projection</a:t>
-                      </a:r>
-                    </a:p>
-                  </a:txBody>
-                </a:tc>
-              </a:tr>
-              <a:tr h="0">
+                        <a:t> — coordination structure enforced deterministically, independent of LLM nondeterminism</a:t>
+                      </a:r>
+                    </a:p>
+                  </a:txBody>
+                </a:tc>
                 <a:tc>
                   <a:txBody>
                     <a:bodyPr/>
@@ -5537,178 +6066,26 @@
                       </a:pPr>
                       <a:r>
                         <a:rPr b="1"/>
-                        <a:t>Behavioral typing of message content</a:t>
-                      </a:r>
-                    </a:p>
-                  </a:txBody>
-                </a:tc>
-                <a:tc>
-                  <a:txBody>
-                    <a:bodyPr/>
-                    <a:lstStyle/>
-                    <a:p>
-                      <a:pPr lvl="0" indent="0" marL="0">
-                        <a:buNone/>
-                      </a:pPr>
-                      <a:r>
-                        <a:rPr/>
-                        <a:t>❌ No</a:t>
-                      </a:r>
-                    </a:p>
-                  </a:txBody>
-                </a:tc>
-                <a:tc>
-                  <a:txBody>
-                    <a:bodyPr/>
-                    <a:lstStyle/>
-                    <a:p>
-                      <a:pPr lvl="0" indent="0" marL="0">
-                        <a:buNone/>
-                      </a:pPr>
-                      <a:r>
-                        <a:rPr/>
-                        <a:t>ZipperGen checks structure, not what LLMs put inside messages</a:t>
-                      </a:r>
-                    </a:p>
-                  </a:txBody>
-                </a:tc>
-              </a:tr>
-              <a:tr h="0">
-                <a:tc>
-                  <a:txBody>
-                    <a:bodyPr/>
-                    <a:lstStyle/>
-                    <a:p>
-                      <a:pPr lvl="0" indent="0" marL="0">
-                        <a:buNone/>
-                      </a:pPr>
-                      <a:r>
-                        <a:rPr b="1"/>
-                        <a:t>Deterministic skill composition verification</a:t>
-                      </a:r>
-                    </a:p>
-                  </a:txBody>
-                </a:tc>
-                <a:tc>
-                  <a:txBody>
-                    <a:bodyPr/>
-                    <a:lstStyle/>
-                    <a:p>
-                      <a:pPr lvl="0" indent="0" marL="0">
-                        <a:buNone/>
-                      </a:pPr>
-                      <a:r>
-                        <a:rPr/>
-                        <a:t>❌ No</a:t>
-                      </a:r>
-                    </a:p>
-                  </a:txBody>
-                </a:tc>
-                <a:tc>
-                  <a:txBody>
-                    <a:bodyPr/>
-                    <a:lstStyle/>
-                    <a:p>
-                      <a:pPr lvl="0" indent="0" marL="0">
-                        <a:buNone/>
-                      </a:pPr>
-                      <a:r>
-                        <a:rPr/>
-                        <a:t>No static analysis of how multiple skills compose within a single agent</a:t>
-                      </a:r>
-                    </a:p>
-                  </a:txBody>
-                </a:tc>
-              </a:tr>
-              <a:tr h="0">
-                <a:tc>
-                  <a:txBody>
-                    <a:bodyPr/>
-                    <a:lstStyle/>
-                    <a:p>
-                      <a:pPr lvl="0" indent="0" marL="0">
-                        <a:buNone/>
-                      </a:pPr>
-                      <a:r>
-                        <a:rPr b="1"/>
-                        <a:t>Behavioral typing with blame</a:t>
-                      </a:r>
-                    </a:p>
-                  </a:txBody>
-                </a:tc>
-                <a:tc>
-                  <a:txBody>
-                    <a:bodyPr/>
-                    <a:lstStyle/>
-                    <a:p>
-                      <a:pPr lvl="0" indent="0" marL="0">
-                        <a:buNone/>
-                      </a:pPr>
-                      <a:r>
-                        <a:rPr/>
-                        <a:t>❌ No</a:t>
-                      </a:r>
-                    </a:p>
-                  </a:txBody>
-                </a:tc>
-                <a:tc>
-                  <a:txBody>
-                    <a:bodyPr/>
-                    <a:lstStyle/>
-                    <a:p>
-                      <a:pPr lvl="0" indent="0" marL="0">
-                        <a:buNone/>
-                      </a:pPr>
-                      <a:r>
-                        <a:rPr/>
-                        <a:t>No blame assignment when agents violate protocols</a:t>
-                      </a:r>
-                    </a:p>
-                  </a:txBody>
-                </a:tc>
-              </a:tr>
-              <a:tr h="0">
-                <a:tc>
-                  <a:txBody>
-                    <a:bodyPr/>
-                    <a:lstStyle/>
-                    <a:p>
-                      <a:pPr lvl="0" indent="0" marL="0">
-                        <a:buNone/>
-                      </a:pPr>
-                      <a:r>
-                        <a:rPr b="1"/>
-                        <a:t>Real-time rollback on violation</a:t>
-                      </a:r>
-                    </a:p>
-                  </a:txBody>
-                </a:tc>
-                <a:tc>
-                  <a:txBody>
-                    <a:bodyPr/>
-                    <a:lstStyle/>
-                    <a:p>
-                      <a:pPr lvl="0" indent="0" marL="0">
-                        <a:buNone/>
-                      </a:pPr>
-                      <a:r>
-                        <a:rPr/>
-                        <a:t>⚠️ Partial</a:t>
-                      </a:r>
-                    </a:p>
-                  </a:txBody>
-                </a:tc>
-                <a:tc>
-                  <a:txBody>
-                    <a:bodyPr/>
-                    <a:lstStyle/>
-                    <a:p>
-                      <a:pPr lvl="0" indent="0" marL="0">
-                        <a:buNone/>
-                      </a:pPr>
-                      <a:r>
-                        <a:rPr/>
-                        <a:t>ABC has Recovery (R) contracts; not automatic rollback</a:t>
+                        <a:t>Closes the multi-agent gap:</a:t>
+                      </a:r>
+                      <a:r>
+                        <a:rPr/>
+                        <a:t> the only paper that guarantees correct multi-agent coordination regardless of LLM stochasticity</a:t>
+                      </a:r>
+                    </a:p>
+                  </a:txBody>
+                </a:tc>
+                <a:tc>
+                  <a:txBody>
+                    <a:bodyPr/>
+                    <a:lstStyle/>
+                    <a:p>
+                      <a:pPr lvl="0" indent="0" marL="0">
+                        <a:buNone/>
+                      </a:pPr>
+                      <a:r>
+                        <a:rPr/>
+                        <a:t>Runtime enforcement of what LLMs do inside action blocks; blame assignment; automatic rollback</a:t>
                       </a:r>
                     </a:p>
                   </a:txBody>
@@ -5718,65 +6095,6 @@
           </a:graphicData>
         </a:graphic>
       </p:graphicFrame>
-    </p:spTree>
-  </p:cSld>
-</p:sld>
-</file>
-
-<file path=ppt/slides/slide17.xml><?xml version="1.0" encoding="utf-8"?>
-<p:sld xmlns:a="http://schemas.openxmlformats.org/drawingml/2006/main" xmlns:r="http://schemas.openxmlformats.org/officeDocument/2006/relationships" xmlns:p="http://schemas.openxmlformats.org/presentationml/2006/main">
-  <p:cSld>
-    <p:spTree>
-      <p:nvGrpSpPr>
-        <p:cNvPr id="1" name=""/>
-        <p:cNvGrpSpPr/>
-        <p:nvPr/>
-      </p:nvGrpSpPr>
-      <p:grpSpPr>
-        <a:xfrm>
-          <a:off x="0" y="0"/>
-          <a:ext cx="0" cy="0"/>
-          <a:chOff x="0" y="0"/>
-          <a:chExt cx="0" cy="0"/>
-        </a:xfrm>
-      </p:grpSpPr>
-      <p:sp>
-        <p:nvSpPr>
-          <p:cNvPr id="3" name="Content Placeholder 2"/>
-          <p:cNvSpPr>
-            <a:spLocks noGrp="1"/>
-          </p:cNvSpPr>
-          <p:nvPr>
-            <p:ph idx="1"/>
-          </p:nvPr>
-        </p:nvSpPr>
-        <p:spPr/>
-        <p:txBody>
-          <a:bodyPr/>
-          <a:lstStyle/>
-          <a:p>
-            <a:pPr lvl="0" indent="0" marL="0">
-              <a:spcBef>
-                <a:spcPts val="3000"/>
-              </a:spcBef>
-              <a:buNone/>
-            </a:pPr>
-            <a:r>
-              <a:rPr b="1"/>
-              <a:t>Verdict on Question 3</a:t>
-            </a:r>
-          </a:p>
-          <a:p>
-            <a:pPr lvl="0" indent="0" marL="1270000">
-              <a:buNone/>
-            </a:pPr>
-            <a:r>
-              <a:rPr sz="2000" b="1"/>
-              <a:t>Deterministic runtime enforcement exists at both single-agent (ACP, ABC/AgentAssert) and multi-agent (ZipperGen) levels. ZipperGen is the breakthrough: it guarantees deadlock-free coordination regardless of LLM nondeterminism, by separating deterministic message structure (enforced) from stochastic actions (opaque). The remaining gap is not “does MPST exist for agents?” — it does — but “can we type-check the content of LLM actions within that structure?”</a:t>
-            </a:r>
-          </a:p>
-        </p:txBody>
-      </p:sp>
     </p:spTree>
   </p:cSld>
 </p:sld>
@@ -5822,19 +6140,7 @@
             </a:pPr>
             <a:r>
               <a:rPr b="1"/>
-              <a:t>Overall Assessment</a:t>
-            </a:r>
-          </a:p>
-          <a:p>
-            <a:pPr lvl="0" indent="0" marL="0">
-              <a:spcBef>
-                <a:spcPts val="3000"/>
-              </a:spcBef>
-              <a:buNone/>
-            </a:pPr>
-            <a:r>
-              <a:rPr b="1"/>
-              <a:t>The Three Questions — Synthesis</a:t>
+              <a:t>The Three Questions — Layer Mapping</a:t>
             </a:r>
           </a:p>
         </p:txBody>
@@ -5892,7 +6198,7 @@
                       </a:pPr>
                       <a:r>
                         <a:rPr/>
-                        <a:t>Status</a:t>
+                        <a:t>Layer 0 (Spec)</a:t>
                       </a:r>
                     </a:p>
                   </a:txBody>
@@ -5908,7 +6214,7 @@
                       </a:pPr>
                       <a:r>
                         <a:rPr/>
-                        <a:t>Best Existing Work</a:t>
+                        <a:t>Layer 1 (Runtime)</a:t>
                       </a:r>
                     </a:p>
                   </a:txBody>
@@ -5924,7 +6230,7 @@
                       </a:pPr>
                       <a:r>
                         <a:rPr/>
-                        <a:t>What ZipperGen Changes</a:t>
+                        <a:t>Layer 2 (Behavioral)</a:t>
                       </a:r>
                     </a:p>
                   </a:txBody>
@@ -5942,52 +6248,52 @@
                       </a:pPr>
                       <a:r>
                         <a:rPr b="1"/>
-                        <a:t>1. Do skills affect behavior?</a:t>
-                      </a:r>
-                    </a:p>
-                  </a:txBody>
-                </a:tc>
-                <a:tc>
-                  <a:txBody>
-                    <a:bodyPr/>
-                    <a:lstStyle/>
-                    <a:p>
-                      <a:pPr lvl="0" indent="0" marL="0">
-                        <a:buNone/>
-                      </a:pPr>
-                      <a:r>
-                        <a:rPr/>
-                        <a:t>✅ Yes, empirically</a:t>
-                      </a:r>
-                    </a:p>
-                  </a:txBody>
-                </a:tc>
-                <a:tc>
-                  <a:txBody>
-                    <a:bodyPr/>
-                    <a:lstStyle/>
-                    <a:p>
-                      <a:pPr lvl="0" indent="0" marL="0">
-                        <a:buNone/>
-                      </a:pPr>
-                      <a:r>
-                        <a:rPr/>
-                        <a:t>BIV, SSL Survey, GovernSpec</a:t>
-                      </a:r>
-                    </a:p>
-                  </a:txBody>
-                </a:tc>
-                <a:tc>
-                  <a:txBody>
-                    <a:bodyPr/>
-                    <a:lstStyle/>
-                    <a:p>
-                      <a:pPr lvl="0" indent="0" marL="0">
-                        <a:buNone/>
-                      </a:pPr>
-                      <a:r>
-                        <a:rPr/>
-                        <a:t>ZipperGen does not directly address this, but its runtime planning extension shows LLMs can generate coordination structures that are formally guaranteed</a:t>
+                        <a:t>Q1: Do skills affect behavior?</a:t>
+                      </a:r>
+                    </a:p>
+                  </a:txBody>
+                </a:tc>
+                <a:tc>
+                  <a:txBody>
+                    <a:bodyPr/>
+                    <a:lstStyle/>
+                    <a:p>
+                      <a:pPr lvl="0" indent="0" marL="0">
+                        <a:buNone/>
+                      </a:pPr>
+                      <a:r>
+                        <a:rPr/>
+                        <a:t>BIV, SSL, GovernSpec (empirical evidence)</a:t>
+                      </a:r>
+                    </a:p>
+                  </a:txBody>
+                </a:tc>
+                <a:tc>
+                  <a:txBody>
+                    <a:bodyPr/>
+                    <a:lstStyle/>
+                    <a:p>
+                      <a:pPr lvl="0" indent="0" marL="0">
+                        <a:buNone/>
+                      </a:pPr>
+                      <a:r>
+                        <a:rPr/>
+                        <a:t>ClawHavoc (incident data)</a:t>
+                      </a:r>
+                    </a:p>
+                  </a:txBody>
+                </a:tc>
+                <a:tc>
+                  <a:txBody>
+                    <a:bodyPr/>
+                    <a:lstStyle/>
+                    <a:p>
+                      <a:pPr lvl="0" indent="0" marL="0">
+                        <a:buNone/>
+                      </a:pPr>
+                      <a:r>
+                        <a:rPr/>
+                        <a:t>—</a:t>
                       </a:r>
                     </a:p>
                   </a:txBody>
@@ -6004,22 +6310,7 @@
                       </a:pPr>
                       <a:r>
                         <a:rPr b="1"/>
-                        <a:t>2. Static type checking?</a:t>
-                      </a:r>
-                    </a:p>
-                  </a:txBody>
-                </a:tc>
-                <a:tc>
-                  <a:txBody>
-                    <a:bodyPr/>
-                    <a:lstStyle/>
-                    <a:p>
-                      <a:pPr lvl="0" indent="0" marL="0">
-                        <a:buNone/>
-                      </a:pPr>
-                      <a:r>
-                        <a:rPr/>
-                        <a:t>✅ Yes for multi-agent</a:t>
+                        <a:t>Q2: Static type checking?</a:t>
                       </a:r>
                     </a:p>
                   </a:txBody>
@@ -6038,26 +6329,37 @@
                       </a:r>
                       <a:r>
                         <a:rPr/>
-                        <a:t> — formal well-typedness checks, deadlock-free by construction</a:t>
-                      </a:r>
-                    </a:p>
-                  </a:txBody>
-                </a:tc>
-                <a:tc>
-                  <a:txBody>
-                    <a:bodyPr/>
-                    <a:lstStyle/>
-                    <a:p>
-                      <a:pPr lvl="0" indent="0" marL="0">
-                        <a:buNone/>
-                      </a:pPr>
-                      <a:r>
-                        <a:rPr b="1"/>
-                        <a:t>Closes the MPST gap:</a:t>
-                      </a:r>
-                      <a:r>
-                        <a:rPr/>
-                        <a:t> formal global specs + deterministic local projection</a:t>
+                        <a:t> (global specs), SkillFortify (code analysis), GovernSpec (contracts)</a:t>
+                      </a:r>
+                    </a:p>
+                  </a:txBody>
+                </a:tc>
+                <a:tc>
+                  <a:txBody>
+                    <a:bodyPr/>
+                    <a:lstStyle/>
+                    <a:p>
+                      <a:pPr lvl="0" indent="0" marL="0">
+                        <a:buNone/>
+                      </a:pPr>
+                      <a:r>
+                        <a:rPr/>
+                        <a:t>—</a:t>
+                      </a:r>
+                    </a:p>
+                  </a:txBody>
+                </a:tc>
+                <a:tc>
+                  <a:txBody>
+                    <a:bodyPr/>
+                    <a:lstStyle/>
+                    <a:p>
+                      <a:pPr lvl="0" indent="0" marL="0">
+                        <a:buNone/>
+                      </a:pPr>
+                      <a:r>
+                        <a:rPr/>
+                        <a:t>—</a:t>
                       </a:r>
                     </a:p>
                   </a:txBody>
@@ -6074,22 +6376,7 @@
                       </a:pPr>
                       <a:r>
                         <a:rPr b="1"/>
-                        <a:t>3. Deterministic runtime?</a:t>
-                      </a:r>
-                    </a:p>
-                  </a:txBody>
-                </a:tc>
-                <a:tc>
-                  <a:txBody>
-                    <a:bodyPr/>
-                    <a:lstStyle/>
-                    <a:p>
-                      <a:pPr lvl="0" indent="0" marL="0">
-                        <a:buNone/>
-                      </a:pPr>
-                      <a:r>
-                        <a:rPr/>
-                        <a:t>✅ Yes for multi-agent</a:t>
+                        <a:t>Q3: Deterministic runtime?</a:t>
                       </a:r>
                     </a:p>
                   </a:txBody>
@@ -6108,7 +6395,7 @@
                       </a:r>
                       <a:r>
                         <a:rPr/>
-                        <a:t> — coordination structure enforced deterministically, independent of LLM nondeterminism</a:t>
+                        <a:t> (projection)</a:t>
                       </a:r>
                     </a:p>
                   </a:txBody>
@@ -6123,11 +6410,26 @@
                       </a:pPr>
                       <a:r>
                         <a:rPr b="1"/>
-                        <a:t>Closes the multi-agent gap:</a:t>
-                      </a:r>
-                      <a:r>
-                        <a:rPr/>
-                        <a:t> the only paper that guarantees correct multi-agent coordination regardless of LLM stochasticity</a:t>
+                        <a:t>ZipperGen</a:t>
+                      </a:r>
+                      <a:r>
+                        <a:rPr/>
+                        <a:t> (local programs), ACP (admission control), ABC (contracts)</a:t>
+                      </a:r>
+                    </a:p>
+                  </a:txBody>
+                </a:tc>
+                <a:tc>
+                  <a:txBody>
+                    <a:bodyPr/>
+                    <a:lstStyle/>
+                    <a:p>
+                      <a:pPr lvl="0" indent="0" marL="0">
+                        <a:buNone/>
+                      </a:pPr>
+                      <a:r>
+                        <a:rPr/>
+                        <a:t>AgentVerify (hybrid), Trace-Based (replay)</a:t>
                       </a:r>
                     </a:p>
                   </a:txBody>
@@ -6412,7 +6714,7 @@
     ↓ Syntax-directed projection
 Local Agent Programs (deadlock-free by construction)
     ↓ Runtime execution
-    ├─ Message passing (deterministic, guaranteed)
+    ├─ Message passing (deterministic, guaranteed by ZipperGen)
     └─ Action blocks (opaque LLM calls)
          ↓ ABC/ACP enforcement inside each action
          Behavior contracts (pre/postconditions)
@@ -6539,6 +6841,263 @@
 </file>
 
 <file path=ppt/slides/slide20.xml><?xml version="1.0" encoding="utf-8"?>
+<p:sld xmlns:a="http://schemas.openxmlformats.org/drawingml/2006/main" xmlns:r="http://schemas.openxmlformats.org/officeDocument/2006/relationships" xmlns:p="http://schemas.openxmlformats.org/presentationml/2006/main">
+  <p:cSld>
+    <p:spTree>
+      <p:nvGrpSpPr>
+        <p:cNvPr id="1" name=""/>
+        <p:cNvGrpSpPr/>
+        <p:nvPr/>
+      </p:nvGrpSpPr>
+      <p:grpSpPr>
+        <a:xfrm>
+          <a:off x="0" y="0"/>
+          <a:ext cx="0" cy="0"/>
+          <a:chOff x="0" y="0"/>
+          <a:chExt cx="0" cy="0"/>
+        </a:xfrm>
+      </p:grpSpPr>
+      <p:sp>
+        <p:nvSpPr>
+          <p:cNvPr id="3" name="Content Placeholder 2"/>
+          <p:cNvSpPr>
+            <a:spLocks noGrp="1"/>
+          </p:cNvSpPr>
+          <p:nvPr>
+            <p:ph idx="1"/>
+          </p:nvPr>
+        </p:nvSpPr>
+        <p:spPr/>
+        <p:txBody>
+          <a:bodyPr/>
+          <a:lstStyle/>
+          <a:p>
+            <a:pPr lvl="0" indent="0" marL="0">
+              <a:spcBef>
+                <a:spcPts val="3000"/>
+              </a:spcBef>
+              <a:buNone/>
+            </a:pPr>
+            <a:r>
+              <a:rPr b="1"/>
+              <a:t>Conclusion</a:t>
+            </a:r>
+          </a:p>
+          <a:p>
+            <a:pPr lvl="0" indent="0" marL="0">
+              <a:spcBef>
+                <a:spcPts val="3000"/>
+              </a:spcBef>
+              <a:buNone/>
+            </a:pPr>
+            <a:r>
+              <a:rPr b="1"/>
+              <a:t>What We Know (2026)</a:t>
+            </a:r>
+          </a:p>
+          <a:p>
+            <a:pPr lvl="0" indent="-342900" marL="342900">
+              <a:buAutoNum type="arabicPeriod"/>
+            </a:pPr>
+            <a:r>
+              <a:rPr b="1"/>
+              <a:t>Skills do affect behavior</a:t>
+            </a:r>
+            <a:r>
+              <a:rPr/>
+              <a:t> — empirically proven by BIV (80% deviation means agents are trying to follow instructions), SSL (94% structure extraction), and ClawHavoc (1,200+ malicious skills show skills are a real threat vector). But this is probabilistic, not deterministic.</a:t>
+            </a:r>
+          </a:p>
+          <a:p>
+            <a:pPr lvl="0" indent="-342900" marL="342900">
+              <a:buAutoNum type="arabicPeriod"/>
+            </a:pPr>
+            <a:r>
+              <a:rPr b="1"/>
+              <a:t>Formal static checking exists for multi-agent coordination</a:t>
+            </a:r>
+            <a:r>
+              <a:rPr/>
+              <a:t> — ZipperGen provides deadlock-free-by-construction guarantees via syntax-directed projection from MSC-based global specs. This closes the MPST gap for coordination structure.</a:t>
+            </a:r>
+          </a:p>
+          <a:p>
+            <a:pPr lvl="0" indent="-342900" marL="342900">
+              <a:buAutoNum type="arabicPeriod"/>
+            </a:pPr>
+            <a:r>
+              <a:rPr b="1"/>
+              <a:t>Deterministic runtime enforcement exists for both single-agent and multi-agent</a:t>
+            </a:r>
+            <a:r>
+              <a:rPr/>
+              <a:t> — ACP (sub-microsecond, TLA+ verified), ABC/AgentAssert (&lt;10ms, Drift Bounds Theorem), and ZipperGen (structural induction proof) all provide deterministic enforcement without LLM-as-judge.</a:t>
+            </a:r>
+          </a:p>
+          <a:p>
+            <a:pPr lvl="0" indent="0" marL="0">
+              <a:spcBef>
+                <a:spcPts val="3000"/>
+              </a:spcBef>
+              <a:buNone/>
+            </a:pPr>
+            <a:r>
+              <a:rPr b="1"/>
+              <a:t>What We Don’t Know (The Open Frontier)</a:t>
+            </a:r>
+          </a:p>
+          <a:p>
+            <a:pPr lvl="0" indent="-342900" marL="342900">
+              <a:buAutoNum type="arabicPeriod"/>
+            </a:pPr>
+            <a:r>
+              <a:rPr b="1"/>
+              <a:t>Behavioral typing of LLM action content</a:t>
+            </a:r>
+            <a:r>
+              <a:rPr/>
+              <a:t> — ZipperGen treats actions as opaque. No paper verifies </a:t>
+            </a:r>
+            <a:r>
+              <a:rPr i="1"/>
+              <a:t>what</a:t>
+            </a:r>
+            <a:r>
+              <a:rPr/>
+              <a:t> LLMs compute inside action blocks.</a:t>
+            </a:r>
+          </a:p>
+          <a:p>
+            <a:pPr lvl="0" indent="-342900" marL="342900">
+              <a:buAutoNum type="arabicPeriod"/>
+            </a:pPr>
+            <a:r>
+              <a:rPr b="1"/>
+              <a:t>Skill-skill composition within a single agent</a:t>
+            </a:r>
+            <a:r>
+              <a:rPr/>
+              <a:t> — No static analysis of how multiple skills loaded by one agent interact.</a:t>
+            </a:r>
+          </a:p>
+          <a:p>
+            <a:pPr lvl="0" indent="-342900" marL="342900">
+              <a:buAutoNum type="arabicPeriod"/>
+            </a:pPr>
+            <a:r>
+              <a:rPr b="1"/>
+              <a:t>Blame assignment in multi-agent violations</a:t>
+            </a:r>
+            <a:r>
+              <a:rPr/>
+              <a:t> — When something goes wrong, who is responsible? ZipperGen provides no mechanism.</a:t>
+            </a:r>
+          </a:p>
+          <a:p>
+            <a:pPr lvl="0" indent="-342900" marL="342900">
+              <a:buAutoNum type="arabicPeriod"/>
+            </a:pPr>
+            <a:r>
+              <a:rPr b="1"/>
+              <a:t>Automatic rollback</a:t>
+            </a:r>
+            <a:r>
+              <a:rPr/>
+              <a:t> — ABC has Recovery (R) contracts for single-agent, but multi-agent rollback is unaddressed.</a:t>
+            </a:r>
+          </a:p>
+          <a:p>
+            <a:pPr lvl="0" indent="-342900" marL="342900">
+              <a:buAutoNum type="arabicPeriod"/>
+            </a:pPr>
+            <a:r>
+              <a:rPr b="1"/>
+              <a:t>Formal guarantee that skill markdown alone determines behavior</a:t>
+            </a:r>
+            <a:r>
+              <a:rPr/>
+              <a:t> — Impossible without L3 runtime enforcement. LLM internals, context truncation, system prompts, and user messages all contribute.</a:t>
+            </a:r>
+          </a:p>
+          <a:p>
+            <a:pPr lvl="0" indent="0" marL="0">
+              <a:spcBef>
+                <a:spcPts val="3000"/>
+              </a:spcBef>
+              <a:buNone/>
+            </a:pPr>
+            <a:r>
+              <a:rPr b="1"/>
+              <a:t>The Path Forward</a:t>
+            </a:r>
+          </a:p>
+          <a:p>
+            <a:pPr lvl="0" indent="0" marL="0">
+              <a:buNone/>
+            </a:pPr>
+            <a:r>
+              <a:rPr/>
+              <a:t>The user’s intuition about MPST-style governance was prescient. ZipperGen (arXiv:2604.17612) proves that formal multi-agent coordination with guaranteed deadlock-freedom is not just theoretical — it is implementable, open-source, and compatible with LLM runtime planning. The next step is not to invent MPST for agents, but to </a:t>
+            </a:r>
+            <a:r>
+              <a:rPr b="1"/>
+              <a:t>extend ZipperGen with behavioral typing, blame assignment, and rollback mechanisms</a:t>
+            </a:r>
+            <a:r>
+              <a:rPr/>
+              <a:t>.</a:t>
+            </a:r>
+          </a:p>
+          <a:p>
+            <a:pPr lvl="0" indent="0" marL="0">
+              <a:buNone/>
+            </a:pPr>
+            <a:r>
+              <a:rPr/>
+              <a:t>The research agenda should focus on: - </a:t>
+            </a:r>
+            <a:r>
+              <a:rPr b="1"/>
+              <a:t>Action-level contracts</a:t>
+            </a:r>
+            <a:r>
+              <a:rPr/>
+              <a:t> inside ZipperGen’s action blocks (integrating ABC/AgentAssert) - </a:t>
+            </a:r>
+            <a:r>
+              <a:rPr b="1"/>
+              <a:t>Skill composition analysis</a:t>
+            </a:r>
+            <a:r>
+              <a:rPr/>
+              <a:t> for single-agent multi-skill scenarios (applying ZipperGen’s projection logic to intra-agent interactions) - </a:t>
+            </a:r>
+            <a:r>
+              <a:rPr b="1"/>
+              <a:t>Blame and rollback</a:t>
+            </a:r>
+            <a:r>
+              <a:rPr/>
+              <a:t> as first-class primitives in the coordination DSL (extending ZipperGen’s owned control flow with violation handling)</a:t>
+            </a:r>
+          </a:p>
+          <a:p>
+            <a:pPr lvl="0" indent="0" marL="0">
+              <a:buNone/>
+            </a:pPr>
+            <a:r>
+              <a:rPr/>
+              <a:t>The Three-Layer Governance Stack is not a wishlist — it is a near-term engineering roadmap. The papers are already being written. The tools are already being built. The gap is closing.</a:t>
+            </a:r>
+          </a:p>
+        </p:txBody>
+      </p:sp>
+    </p:spTree>
+  </p:cSld>
+</p:sld>
+</file>
+
+<file path=ppt/slides/slide21.xml><?xml version="1.0" encoding="utf-8"?>
 <p:sld xmlns:a="http://schemas.openxmlformats.org/drawingml/2006/main" xmlns:r="http://schemas.openxmlformats.org/officeDocument/2006/relationships" xmlns:p="http://schemas.openxmlformats.org/presentationml/2006/main">
   <p:cSld>
     <p:spTree>

</xml_diff>